<commit_message>
Pitch slide: one column per judging criterion, product-first headline
Co-Authored-By: Claude Opus 5.5 <noreply@anthropic.com>
</commit_message>
<xml_diff>
--- a/docs/pitch-slide.pptx
+++ b/docs/pitch-slide.pptx
@@ -961,8 +961,8 @@
         </p:nvSpPr>
         <p:spPr>
           <a:xfrm>
-            <a:off x="548640" y="777240"/>
-            <a:ext cx="8686800" cy="960120"/>
+            <a:off x="548640" y="749808"/>
+            <a:ext cx="11091672" cy="868680"/>
           </a:xfrm>
           <a:prstGeom prst="rect">
             <a:avLst/>
@@ -981,7 +981,7 @@
               <a:buNone/>
             </a:pPr>
             <a:r>
-              <a:rPr lang="en-US" sz="2800" dirty="0">
+              <a:rPr lang="en-US" sz="2600" dirty="0">
                 <a:solidFill>
                   <a:srgbClr val="EEE9DE"/>
                 </a:solidFill>
@@ -989,9 +989,9 @@
                 <a:ea typeface="Georgia" pitchFamily="34" charset="-122"/>
                 <a:cs typeface="Georgia" pitchFamily="34" charset="-120"/>
               </a:rPr>
-              <a:t>Sponsors pay millions for screen time.</a:t>
-            </a:r>
-            <a:endParaRPr lang="en-US" sz="2800" dirty="0"/>
+              <a:t>AI agents that measure every second a sponsor is on screen.</a:t>
+            </a:r>
+            <a:endParaRPr lang="en-US" sz="2600" dirty="0"/>
           </a:p>
           <a:p>
             <a:pPr indent="0" marL="0">
@@ -1001,7 +1001,7 @@
               <a:buNone/>
             </a:pPr>
             <a:r>
-              <a:rPr lang="en-US" sz="2800" dirty="0">
+              <a:rPr lang="en-US" sz="2600" dirty="0">
                 <a:solidFill>
                   <a:srgbClr val="EEE9DE"/>
                 </a:solidFill>
@@ -1009,9 +1009,9 @@
                 <a:ea typeface="Georgia" pitchFamily="34" charset="-122"/>
                 <a:cs typeface="Georgia" pitchFamily="34" charset="-120"/>
               </a:rPr>
-              <a:t>No club can prove how much they got.</a:t>
-            </a:r>
-            <a:endParaRPr lang="en-US" sz="2800" dirty="0"/>
+              <a:t>Live, per surface, with the frame as proof.</a:t>
+            </a:r>
+            <a:endParaRPr lang="en-US" sz="2600" dirty="0"/>
           </a:p>
         </p:txBody>
       </p:sp>
@@ -1023,8 +1023,8 @@
         </p:nvSpPr>
         <p:spPr>
           <a:xfrm>
-            <a:off x="548640" y="1828800"/>
-            <a:ext cx="8961120" cy="457200"/>
+            <a:off x="548640" y="1691640"/>
+            <a:ext cx="11091672" cy="274320"/>
           </a:xfrm>
           <a:prstGeom prst="rect">
             <a:avLst/>
@@ -1062,7 +1062,7 @@
                 <a:ea typeface="Arial" pitchFamily="34" charset="-122"/>
                 <a:cs typeface="Arial" pitchFamily="34" charset="-120"/>
               </a:rPr>
-              <a:t> is a team of AI agents that watches the broadcast and logs every second each sponsor is on screen, per surface, with the frame as proof.</a:t>
+              <a:t> turns a football broadcast into an auditable sponsor ledger that clubs bring to every renewal.</a:t>
             </a:r>
             <a:endParaRPr lang="en-US" sz="1400" dirty="0"/>
           </a:p>
@@ -1076,7 +1076,7 @@
         </p:nvSpPr>
         <p:spPr>
           <a:xfrm>
-            <a:off x="548640" y="2450592"/>
+            <a:off x="548640" y="2176272"/>
             <a:ext cx="11091672" cy="0"/>
           </a:xfrm>
           <a:prstGeom prst="line">
@@ -1099,8 +1099,8 @@
         </p:nvSpPr>
         <p:spPr>
           <a:xfrm>
-            <a:off x="4251960" y="2633472"/>
-            <a:ext cx="0" cy="3236976"/>
+            <a:off x="3520440" y="2340864"/>
+            <a:ext cx="0" cy="3529584"/>
           </a:xfrm>
           <a:prstGeom prst="line">
             <a:avLst/>
@@ -1122,8 +1122,8 @@
         </p:nvSpPr>
         <p:spPr>
           <a:xfrm>
-            <a:off x="8229600" y="2633472"/>
-            <a:ext cx="0" cy="3236976"/>
+            <a:off x="6675120" y="2340864"/>
+            <a:ext cx="0" cy="3529584"/>
           </a:xfrm>
           <a:prstGeom prst="line">
             <a:avLst/>
@@ -1139,30 +1139,53 @@
       </p:sp>
       <p:sp>
         <p:nvSpPr>
-          <p:cNvPr id="9" name="Text 7"/>
-          <p:cNvSpPr txBox="1"/>
-          <p:nvPr/>
-        </p:nvSpPr>
-        <p:spPr>
-          <a:xfrm>
-            <a:off x="548640" y="2633472"/>
-            <a:ext cx="3520440" cy="228600"/>
-          </a:xfrm>
-          <a:prstGeom prst="rect">
-            <a:avLst/>
-          </a:prstGeom>
-          <a:noFill/>
-          <a:ln/>
-        </p:spPr>
-        <p:txBody>
-          <a:bodyPr wrap="square" lIns="0" tIns="0" rIns="0" bIns="0" rtlCol="0" anchor="t"/>
-          <a:lstStyle/>
-          <a:p>
-            <a:pPr indent="0" marL="0">
-              <a:buNone/>
-            </a:pPr>
-            <a:r>
-              <a:rPr lang="en-US" sz="1000" b="1" spc="150" kern="0" dirty="0">
+          <p:cNvPr id="9" name="Shape 7"/>
+          <p:cNvSpPr/>
+          <p:nvPr/>
+        </p:nvSpPr>
+        <p:spPr>
+          <a:xfrm>
+            <a:off x="9189720" y="2340864"/>
+            <a:ext cx="0" cy="3529584"/>
+          </a:xfrm>
+          <a:prstGeom prst="line">
+            <a:avLst/>
+          </a:prstGeom>
+          <a:noFill/>
+          <a:ln w="9525">
+            <a:solidFill>
+              <a:srgbClr val="2E302A"/>
+            </a:solidFill>
+            <a:prstDash val="solid"/>
+          </a:ln>
+        </p:spPr>
+      </p:sp>
+      <p:sp>
+        <p:nvSpPr>
+          <p:cNvPr id="10" name="Text 8"/>
+          <p:cNvSpPr txBox="1"/>
+          <p:nvPr/>
+        </p:nvSpPr>
+        <p:spPr>
+          <a:xfrm>
+            <a:off x="548640" y="2340864"/>
+            <a:ext cx="2788920" cy="201168"/>
+          </a:xfrm>
+          <a:prstGeom prst="rect">
+            <a:avLst/>
+          </a:prstGeom>
+          <a:noFill/>
+          <a:ln/>
+        </p:spPr>
+        <p:txBody>
+          <a:bodyPr wrap="square" lIns="0" tIns="0" rIns="0" bIns="0" rtlCol="0" anchor="t"/>
+          <a:lstStyle/>
+          <a:p>
+            <a:pPr indent="0" marL="0">
+              <a:buNone/>
+            </a:pPr>
+            <a:r>
+              <a:rPr lang="en-US" sz="900" b="1" spc="120" kern="0" dirty="0">
                 <a:solidFill>
                   <a:srgbClr val="C9A766"/>
                 </a:solidFill>
@@ -1170,61 +1193,415 @@
                 <a:ea typeface="Arial" pitchFamily="34" charset="-122"/>
                 <a:cs typeface="Arial" pitchFamily="34" charset="-120"/>
               </a:rPr>
-              <a:t>01   THE CUSTOMER</a:t>
-            </a:r>
-            <a:endParaRPr lang="en-US" sz="1000" dirty="0"/>
-          </a:p>
-        </p:txBody>
-      </p:sp>
-      <p:sp>
-        <p:nvSpPr>
-          <p:cNvPr id="10" name="Text 8"/>
-          <p:cNvSpPr txBox="1"/>
-          <p:nvPr/>
-        </p:nvSpPr>
-        <p:spPr>
-          <a:xfrm>
-            <a:off x="548640" y="2999232"/>
-            <a:ext cx="3520440" cy="182880"/>
-          </a:xfrm>
-          <a:prstGeom prst="rect">
-            <a:avLst/>
-          </a:prstGeom>
-          <a:noFill/>
-          <a:ln/>
-        </p:spPr>
-        <p:txBody>
-          <a:bodyPr wrap="square" lIns="0" tIns="0" rIns="0" bIns="0" rtlCol="0" anchor="t"/>
-          <a:lstStyle/>
-          <a:p>
-            <a:pPr indent="0" marL="0">
-              <a:buNone/>
-            </a:pPr>
-            <a:r>
-              <a:rPr lang="en-US" sz="950" b="1" spc="100" kern="0" dirty="0">
+              <a:t>01  CUSTOMER PROBLEM &amp; VALUE</a:t>
+            </a:r>
+            <a:endParaRPr lang="en-US" sz="900" dirty="0"/>
+          </a:p>
+        </p:txBody>
+      </p:sp>
+      <p:sp>
+        <p:nvSpPr>
+          <p:cNvPr id="11" name="Text 9"/>
+          <p:cNvSpPr txBox="1"/>
+          <p:nvPr/>
+        </p:nvSpPr>
+        <p:spPr>
+          <a:xfrm>
+            <a:off x="548640" y="2615184"/>
+            <a:ext cx="2788920" cy="530352"/>
+          </a:xfrm>
+          <a:prstGeom prst="rect">
+            <a:avLst/>
+          </a:prstGeom>
+          <a:noFill/>
+          <a:ln/>
+        </p:spPr>
+        <p:txBody>
+          <a:bodyPr wrap="square" lIns="0" tIns="0" rIns="0" bIns="0" rtlCol="0" anchor="t"/>
+          <a:lstStyle/>
+          <a:p>
+            <a:pPr indent="0" marL="0">
+              <a:lnSpc>
+                <a:spcPct val="95000"/>
+              </a:lnSpc>
+              <a:buNone/>
+            </a:pPr>
+            <a:r>
+              <a:rPr lang="en-US" sz="1400" dirty="0">
                 <a:solidFill>
                   <a:srgbClr val="EEE9DE"/>
                 </a:solidFill>
+                <a:latin typeface="Georgia" pitchFamily="34" charset="0"/>
+                <a:ea typeface="Georgia" pitchFamily="34" charset="-122"/>
+                <a:cs typeface="Georgia" pitchFamily="34" charset="-120"/>
+              </a:rPr>
+              <a:t>A buyer with a deadline: the sponsor renewal.</a:t>
+            </a:r>
+            <a:endParaRPr lang="en-US" sz="1400" dirty="0"/>
+          </a:p>
+        </p:txBody>
+      </p:sp>
+      <p:sp>
+        <p:nvSpPr>
+          <p:cNvPr id="12" name="Text 10"/>
+          <p:cNvSpPr txBox="1"/>
+          <p:nvPr/>
+        </p:nvSpPr>
+        <p:spPr>
+          <a:xfrm>
+            <a:off x="548640" y="3236976"/>
+            <a:ext cx="2788920" cy="164592"/>
+          </a:xfrm>
+          <a:prstGeom prst="rect">
+            <a:avLst/>
+          </a:prstGeom>
+          <a:noFill/>
+          <a:ln/>
+        </p:spPr>
+        <p:txBody>
+          <a:bodyPr wrap="square" lIns="0" tIns="0" rIns="0" bIns="0" rtlCol="0" anchor="t"/>
+          <a:lstStyle/>
+          <a:p>
+            <a:pPr indent="0" marL="0">
+              <a:buNone/>
+            </a:pPr>
+            <a:r>
+              <a:rPr lang="en-US" sz="850" b="1" spc="100" kern="0" dirty="0">
+                <a:solidFill>
+                  <a:srgbClr val="EEE9DE"/>
+                </a:solidFill>
                 <a:latin typeface="Arial" pitchFamily="34" charset="0"/>
                 <a:ea typeface="Arial" pitchFamily="34" charset="-122"/>
                 <a:cs typeface="Arial" pitchFamily="34" charset="-120"/>
               </a:rPr>
               <a:t>WHO</a:t>
             </a:r>
-            <a:endParaRPr lang="en-US" sz="950" dirty="0"/>
-          </a:p>
-        </p:txBody>
-      </p:sp>
-      <p:sp>
-        <p:nvSpPr>
-          <p:cNvPr id="11" name="Text 9"/>
-          <p:cNvSpPr txBox="1"/>
-          <p:nvPr/>
-        </p:nvSpPr>
-        <p:spPr>
-          <a:xfrm>
-            <a:off x="548640" y="3200400"/>
-            <a:ext cx="3520440" cy="502920"/>
+            <a:endParaRPr lang="en-US" sz="850" dirty="0"/>
+          </a:p>
+        </p:txBody>
+      </p:sp>
+      <p:sp>
+        <p:nvSpPr>
+          <p:cNvPr id="13" name="Text 11"/>
+          <p:cNvSpPr txBox="1"/>
+          <p:nvPr/>
+        </p:nvSpPr>
+        <p:spPr>
+          <a:xfrm>
+            <a:off x="548640" y="3419856"/>
+            <a:ext cx="2788920" cy="438912"/>
+          </a:xfrm>
+          <a:prstGeom prst="rect">
+            <a:avLst/>
+          </a:prstGeom>
+          <a:noFill/>
+          <a:ln/>
+        </p:spPr>
+        <p:txBody>
+          <a:bodyPr wrap="square" lIns="0" tIns="0" rIns="0" bIns="0" rtlCol="0" anchor="t"/>
+          <a:lstStyle/>
+          <a:p>
+            <a:pPr indent="0" marL="0">
+              <a:buNone/>
+            </a:pPr>
+            <a:r>
+              <a:rPr lang="en-US" sz="1050" dirty="0">
+                <a:solidFill>
+                  <a:srgbClr val="A39F94"/>
+                </a:solidFill>
+                <a:latin typeface="Arial" pitchFamily="34" charset="0"/>
+                <a:ea typeface="Arial" pitchFamily="34" charset="-122"/>
+                <a:cs typeface="Arial" pitchFamily="34" charset="-120"/>
+              </a:rPr>
+              <a:t>Club commercial teams selling LED boards, shirts and backdrops; 2nd-tier clubs first.</a:t>
+            </a:r>
+            <a:endParaRPr lang="en-US" sz="1050" dirty="0"/>
+          </a:p>
+        </p:txBody>
+      </p:sp>
+      <p:sp>
+        <p:nvSpPr>
+          <p:cNvPr id="14" name="Text 12"/>
+          <p:cNvSpPr txBox="1"/>
+          <p:nvPr/>
+        </p:nvSpPr>
+        <p:spPr>
+          <a:xfrm>
+            <a:off x="548640" y="3895344"/>
+            <a:ext cx="2788920" cy="164592"/>
+          </a:xfrm>
+          <a:prstGeom prst="rect">
+            <a:avLst/>
+          </a:prstGeom>
+          <a:noFill/>
+          <a:ln/>
+        </p:spPr>
+        <p:txBody>
+          <a:bodyPr wrap="square" lIns="0" tIns="0" rIns="0" bIns="0" rtlCol="0" anchor="t"/>
+          <a:lstStyle/>
+          <a:p>
+            <a:pPr indent="0" marL="0">
+              <a:buNone/>
+            </a:pPr>
+            <a:r>
+              <a:rPr lang="en-US" sz="850" b="1" spc="100" kern="0" dirty="0">
+                <a:solidFill>
+                  <a:srgbClr val="EEE9DE"/>
+                </a:solidFill>
+                <a:latin typeface="Arial" pitchFamily="34" charset="0"/>
+                <a:ea typeface="Arial" pitchFamily="34" charset="-122"/>
+                <a:cs typeface="Arial" pitchFamily="34" charset="-120"/>
+              </a:rPr>
+              <a:t>VALUE</a:t>
+            </a:r>
+            <a:endParaRPr lang="en-US" sz="850" dirty="0"/>
+          </a:p>
+        </p:txBody>
+      </p:sp>
+      <p:sp>
+        <p:nvSpPr>
+          <p:cNvPr id="15" name="Text 13"/>
+          <p:cNvSpPr txBox="1"/>
+          <p:nvPr/>
+        </p:nvSpPr>
+        <p:spPr>
+          <a:xfrm>
+            <a:off x="548640" y="4078224"/>
+            <a:ext cx="2788920" cy="438912"/>
+          </a:xfrm>
+          <a:prstGeom prst="rect">
+            <a:avLst/>
+          </a:prstGeom>
+          <a:noFill/>
+          <a:ln/>
+        </p:spPr>
+        <p:txBody>
+          <a:bodyPr wrap="square" lIns="0" tIns="0" rIns="0" bIns="0" rtlCol="0" anchor="t"/>
+          <a:lstStyle/>
+          <a:p>
+            <a:pPr indent="0" marL="0">
+              <a:buNone/>
+            </a:pPr>
+            <a:r>
+              <a:rPr lang="en-US" sz="1050" dirty="0">
+                <a:solidFill>
+                  <a:srgbClr val="A39F94"/>
+                </a:solidFill>
+                <a:latin typeface="Arial" pitchFamily="34" charset="0"/>
+                <a:ea typeface="Arial" pitchFamily="34" charset="-122"/>
+                <a:cs typeface="Arial" pitchFamily="34" charset="-120"/>
+              </a:rPr>
+              <a:t>Proof of seconds on screen per sponsor and surface, instead of a manual count.</a:t>
+            </a:r>
+            <a:endParaRPr lang="en-US" sz="1050" dirty="0"/>
+          </a:p>
+        </p:txBody>
+      </p:sp>
+      <p:sp>
+        <p:nvSpPr>
+          <p:cNvPr id="16" name="Text 14"/>
+          <p:cNvSpPr txBox="1"/>
+          <p:nvPr/>
+        </p:nvSpPr>
+        <p:spPr>
+          <a:xfrm>
+            <a:off x="548640" y="4553712"/>
+            <a:ext cx="2788920" cy="164592"/>
+          </a:xfrm>
+          <a:prstGeom prst="rect">
+            <a:avLst/>
+          </a:prstGeom>
+          <a:noFill/>
+          <a:ln/>
+        </p:spPr>
+        <p:txBody>
+          <a:bodyPr wrap="square" lIns="0" tIns="0" rIns="0" bIns="0" rtlCol="0" anchor="t"/>
+          <a:lstStyle/>
+          <a:p>
+            <a:pPr indent="0" marL="0">
+              <a:buNone/>
+            </a:pPr>
+            <a:r>
+              <a:rPr lang="en-US" sz="850" b="1" spc="100" kern="0" dirty="0">
+                <a:solidFill>
+                  <a:srgbClr val="EEE9DE"/>
+                </a:solidFill>
+                <a:latin typeface="Arial" pitchFamily="34" charset="0"/>
+                <a:ea typeface="Arial" pitchFamily="34" charset="-122"/>
+                <a:cs typeface="Arial" pitchFamily="34" charset="-120"/>
+              </a:rPr>
+              <a:t>WHY NOW</a:t>
+            </a:r>
+            <a:endParaRPr lang="en-US" sz="850" dirty="0"/>
+          </a:p>
+        </p:txBody>
+      </p:sp>
+      <p:sp>
+        <p:nvSpPr>
+          <p:cNvPr id="17" name="Text 15"/>
+          <p:cNvSpPr txBox="1"/>
+          <p:nvPr/>
+        </p:nvSpPr>
+        <p:spPr>
+          <a:xfrm>
+            <a:off x="548640" y="4736592"/>
+            <a:ext cx="2788920" cy="438912"/>
+          </a:xfrm>
+          <a:prstGeom prst="rect">
+            <a:avLst/>
+          </a:prstGeom>
+          <a:noFill/>
+          <a:ln/>
+        </p:spPr>
+        <p:txBody>
+          <a:bodyPr wrap="square" lIns="0" tIns="0" rIns="0" bIns="0" rtlCol="0" anchor="t"/>
+          <a:lstStyle/>
+          <a:p>
+            <a:pPr indent="0" marL="0">
+              <a:buNone/>
+            </a:pPr>
+            <a:r>
+              <a:rPr lang="en-US" sz="1050" dirty="0">
+                <a:solidFill>
+                  <a:srgbClr val="A39F94"/>
+                </a:solidFill>
+                <a:latin typeface="Arial" pitchFamily="34" charset="0"/>
+                <a:ea typeface="Arial" pitchFamily="34" charset="-122"/>
+                <a:cs typeface="Arial" pitchFamily="34" charset="-120"/>
+              </a:rPr>
+              <a:t>Vision models read stylised logos OCR misses, at ≈ $0.12 per match-minute.</a:t>
+            </a:r>
+            <a:endParaRPr lang="en-US" sz="1050" dirty="0"/>
+          </a:p>
+        </p:txBody>
+      </p:sp>
+      <p:sp>
+        <p:nvSpPr>
+          <p:cNvPr id="18" name="Text 16"/>
+          <p:cNvSpPr txBox="1"/>
+          <p:nvPr/>
+        </p:nvSpPr>
+        <p:spPr>
+          <a:xfrm>
+            <a:off x="548640" y="5212080"/>
+            <a:ext cx="2788920" cy="164592"/>
+          </a:xfrm>
+          <a:prstGeom prst="rect">
+            <a:avLst/>
+          </a:prstGeom>
+          <a:noFill/>
+          <a:ln/>
+        </p:spPr>
+        <p:txBody>
+          <a:bodyPr wrap="square" lIns="0" tIns="0" rIns="0" bIns="0" rtlCol="0" anchor="t"/>
+          <a:lstStyle/>
+          <a:p>
+            <a:pPr indent="0" marL="0">
+              <a:buNone/>
+            </a:pPr>
+            <a:r>
+              <a:rPr lang="en-US" sz="850" b="1" spc="100" kern="0" dirty="0">
+                <a:solidFill>
+                  <a:srgbClr val="EEE9DE"/>
+                </a:solidFill>
+                <a:latin typeface="Arial" pitchFamily="34" charset="0"/>
+                <a:ea typeface="Arial" pitchFamily="34" charset="-122"/>
+                <a:cs typeface="Arial" pitchFamily="34" charset="-120"/>
+              </a:rPr>
+              <a:t>FIRST USERS</a:t>
+            </a:r>
+            <a:endParaRPr lang="en-US" sz="850" dirty="0"/>
+          </a:p>
+        </p:txBody>
+      </p:sp>
+      <p:sp>
+        <p:nvSpPr>
+          <p:cNvPr id="19" name="Text 17"/>
+          <p:cNvSpPr txBox="1"/>
+          <p:nvPr/>
+        </p:nvSpPr>
+        <p:spPr>
+          <a:xfrm>
+            <a:off x="548640" y="5394960"/>
+            <a:ext cx="2788920" cy="438912"/>
+          </a:xfrm>
+          <a:prstGeom prst="rect">
+            <a:avLst/>
+          </a:prstGeom>
+          <a:noFill/>
+          <a:ln/>
+        </p:spPr>
+        <p:txBody>
+          <a:bodyPr wrap="square" lIns="0" tIns="0" rIns="0" bIns="0" rtlCol="0" anchor="t"/>
+          <a:lstStyle/>
+          <a:p>
+            <a:pPr indent="0" marL="0">
+              <a:buNone/>
+            </a:pPr>
+            <a:r>
+              <a:rPr lang="en-US" sz="1050" dirty="0">
+                <a:solidFill>
+                  <a:srgbClr val="A39F94"/>
+                </a:solidFill>
+                <a:latin typeface="Arial" pitchFamily="34" charset="0"/>
+                <a:ea typeface="Arial" pitchFamily="34" charset="-122"/>
+                <a:cs typeface="Arial" pitchFamily="34" charset="-120"/>
+              </a:rPr>
+              <a:t>Pilot done with a 2nd-tier club, a second agreed; then leagues, for all their clubs.</a:t>
+            </a:r>
+            <a:endParaRPr lang="en-US" sz="1050" dirty="0"/>
+          </a:p>
+        </p:txBody>
+      </p:sp>
+      <p:sp>
+        <p:nvSpPr>
+          <p:cNvPr id="20" name="Text 18"/>
+          <p:cNvSpPr txBox="1"/>
+          <p:nvPr/>
+        </p:nvSpPr>
+        <p:spPr>
+          <a:xfrm>
+            <a:off x="3703320" y="2340864"/>
+            <a:ext cx="2788920" cy="201168"/>
+          </a:xfrm>
+          <a:prstGeom prst="rect">
+            <a:avLst/>
+          </a:prstGeom>
+          <a:noFill/>
+          <a:ln/>
+        </p:spPr>
+        <p:txBody>
+          <a:bodyPr wrap="square" lIns="0" tIns="0" rIns="0" bIns="0" rtlCol="0" anchor="t"/>
+          <a:lstStyle/>
+          <a:p>
+            <a:pPr indent="0" marL="0">
+              <a:buNone/>
+            </a:pPr>
+            <a:r>
+              <a:rPr lang="en-US" sz="900" b="1" spc="120" kern="0" dirty="0">
+                <a:solidFill>
+                  <a:srgbClr val="C9A766"/>
+                </a:solidFill>
+                <a:latin typeface="Arial" pitchFamily="34" charset="0"/>
+                <a:ea typeface="Arial" pitchFamily="34" charset="-122"/>
+                <a:cs typeface="Arial" pitchFamily="34" charset="-120"/>
+              </a:rPr>
+              <a:t>02  AGENT CAPABILITY</a:t>
+            </a:r>
+            <a:endParaRPr lang="en-US" sz="900" dirty="0"/>
+          </a:p>
+        </p:txBody>
+      </p:sp>
+      <p:sp>
+        <p:nvSpPr>
+          <p:cNvPr id="21" name="Text 19"/>
+          <p:cNvSpPr txBox="1"/>
+          <p:nvPr/>
+        </p:nvSpPr>
+        <p:spPr>
+          <a:xfrm>
+            <a:off x="3703320" y="2615184"/>
+            <a:ext cx="2788920" cy="530352"/>
           </a:xfrm>
           <a:prstGeom prst="rect">
             <a:avLst/>
@@ -1238,317 +1615,35 @@
           <a:p>
             <a:pPr indent="0" marL="0">
               <a:lnSpc>
-                <a:spcPct val="100000"/>
+                <a:spcPct val="95000"/>
               </a:lnSpc>
               <a:buNone/>
             </a:pPr>
             <a:r>
-              <a:rPr lang="en-US" sz="1150" dirty="0">
-                <a:solidFill>
-                  <a:srgbClr val="A39F94"/>
-                </a:solidFill>
-                <a:latin typeface="Arial" pitchFamily="34" charset="0"/>
-                <a:ea typeface="Arial" pitchFamily="34" charset="-122"/>
-                <a:cs typeface="Arial" pitchFamily="34" charset="-120"/>
-              </a:rPr>
-              <a:t>Club commercial managers, starting with 2nd-tier clubs selling LED boards, shirts and backdrops.</a:t>
-            </a:r>
-            <a:endParaRPr lang="en-US" sz="1150" dirty="0"/>
-          </a:p>
-        </p:txBody>
-      </p:sp>
-      <p:sp>
-        <p:nvSpPr>
-          <p:cNvPr id="12" name="Text 10"/>
-          <p:cNvSpPr txBox="1"/>
-          <p:nvPr/>
-        </p:nvSpPr>
-        <p:spPr>
-          <a:xfrm>
-            <a:off x="548640" y="3721608"/>
-            <a:ext cx="3520440" cy="182880"/>
-          </a:xfrm>
-          <a:prstGeom prst="rect">
-            <a:avLst/>
-          </a:prstGeom>
-          <a:noFill/>
-          <a:ln/>
-        </p:spPr>
-        <p:txBody>
-          <a:bodyPr wrap="square" lIns="0" tIns="0" rIns="0" bIns="0" rtlCol="0" anchor="t"/>
-          <a:lstStyle/>
-          <a:p>
-            <a:pPr indent="0" marL="0">
-              <a:buNone/>
-            </a:pPr>
-            <a:r>
-              <a:rPr lang="en-US" sz="950" b="1" spc="100" kern="0" dirty="0">
+              <a:rPr lang="en-US" sz="1400" dirty="0">
                 <a:solidFill>
                   <a:srgbClr val="EEE9DE"/>
                 </a:solidFill>
-                <a:latin typeface="Arial" pitchFamily="34" charset="0"/>
-                <a:ea typeface="Arial" pitchFamily="34" charset="-122"/>
-                <a:cs typeface="Arial" pitchFamily="34" charset="-120"/>
-              </a:rPr>
-              <a:t>PROBLEM</a:t>
-            </a:r>
-            <a:endParaRPr lang="en-US" sz="950" dirty="0"/>
-          </a:p>
-        </p:txBody>
-      </p:sp>
-      <p:sp>
-        <p:nvSpPr>
-          <p:cNvPr id="13" name="Text 11"/>
-          <p:cNvSpPr txBox="1"/>
-          <p:nvPr/>
-        </p:nvSpPr>
-        <p:spPr>
-          <a:xfrm>
-            <a:off x="548640" y="3922776"/>
-            <a:ext cx="3520440" cy="502920"/>
-          </a:xfrm>
-          <a:prstGeom prst="rect">
-            <a:avLst/>
-          </a:prstGeom>
-          <a:noFill/>
-          <a:ln/>
-        </p:spPr>
-        <p:txBody>
-          <a:bodyPr wrap="square" lIns="0" tIns="0" rIns="0" bIns="0" rtlCol="0" anchor="t"/>
-          <a:lstStyle/>
-          <a:p>
-            <a:pPr indent="0" marL="0">
-              <a:lnSpc>
-                <a:spcPct val="100000"/>
-              </a:lnSpc>
-              <a:buNone/>
-            </a:pPr>
-            <a:r>
-              <a:rPr lang="en-US" sz="1150" dirty="0">
-                <a:solidFill>
-                  <a:srgbClr val="A39F94"/>
-                </a:solidFill>
-                <a:latin typeface="Arial" pitchFamily="34" charset="0"/>
-                <a:ea typeface="Arial" pitchFamily="34" charset="-122"/>
-                <a:cs typeface="Arial" pitchFamily="34" charset="-120"/>
-              </a:rPr>
-              <a:t>At renewal sponsors ask: how many seconds was I on TV, and where? Today: a manual count or a guess.</a:t>
-            </a:r>
-            <a:endParaRPr lang="en-US" sz="1150" dirty="0"/>
-          </a:p>
-        </p:txBody>
-      </p:sp>
-      <p:sp>
-        <p:nvSpPr>
-          <p:cNvPr id="14" name="Text 12"/>
-          <p:cNvSpPr txBox="1"/>
-          <p:nvPr/>
-        </p:nvSpPr>
-        <p:spPr>
-          <a:xfrm>
-            <a:off x="548640" y="4443984"/>
-            <a:ext cx="3520440" cy="182880"/>
-          </a:xfrm>
-          <a:prstGeom prst="rect">
-            <a:avLst/>
-          </a:prstGeom>
-          <a:noFill/>
-          <a:ln/>
-        </p:spPr>
-        <p:txBody>
-          <a:bodyPr wrap="square" lIns="0" tIns="0" rIns="0" bIns="0" rtlCol="0" anchor="t"/>
-          <a:lstStyle/>
-          <a:p>
-            <a:pPr indent="0" marL="0">
-              <a:buNone/>
-            </a:pPr>
-            <a:r>
-              <a:rPr lang="en-US" sz="950" b="1" spc="100" kern="0" dirty="0">
-                <a:solidFill>
-                  <a:srgbClr val="EEE9DE"/>
-                </a:solidFill>
-                <a:latin typeface="Arial" pitchFamily="34" charset="0"/>
-                <a:ea typeface="Arial" pitchFamily="34" charset="-122"/>
-                <a:cs typeface="Arial" pitchFamily="34" charset="-120"/>
-              </a:rPr>
-              <a:t>WHY NOW</a:t>
-            </a:r>
-            <a:endParaRPr lang="en-US" sz="950" dirty="0"/>
-          </a:p>
-        </p:txBody>
-      </p:sp>
-      <p:sp>
-        <p:nvSpPr>
-          <p:cNvPr id="15" name="Text 13"/>
-          <p:cNvSpPr txBox="1"/>
-          <p:nvPr/>
-        </p:nvSpPr>
-        <p:spPr>
-          <a:xfrm>
-            <a:off x="548640" y="4645152"/>
-            <a:ext cx="3520440" cy="502920"/>
-          </a:xfrm>
-          <a:prstGeom prst="rect">
-            <a:avLst/>
-          </a:prstGeom>
-          <a:noFill/>
-          <a:ln/>
-        </p:spPr>
-        <p:txBody>
-          <a:bodyPr wrap="square" lIns="0" tIns="0" rIns="0" bIns="0" rtlCol="0" anchor="t"/>
-          <a:lstStyle/>
-          <a:p>
-            <a:pPr indent="0" marL="0">
-              <a:lnSpc>
-                <a:spcPct val="100000"/>
-              </a:lnSpc>
-              <a:buNone/>
-            </a:pPr>
-            <a:r>
-              <a:rPr lang="en-US" sz="1150" dirty="0">
-                <a:solidFill>
-                  <a:srgbClr val="A39F94"/>
-                </a:solidFill>
-                <a:latin typeface="Arial" pitchFamily="34" charset="0"/>
-                <a:ea typeface="Arial" pitchFamily="34" charset="-122"/>
-                <a:cs typeface="Arial" pitchFamily="34" charset="-120"/>
-              </a:rPr>
-              <a:t>Vision models now read stylised logos OCR misses, cheaply enough for every club, every match.</a:t>
-            </a:r>
-            <a:endParaRPr lang="en-US" sz="1150" dirty="0"/>
-          </a:p>
-        </p:txBody>
-      </p:sp>
-      <p:sp>
-        <p:nvSpPr>
-          <p:cNvPr id="16" name="Text 14"/>
-          <p:cNvSpPr txBox="1"/>
-          <p:nvPr/>
-        </p:nvSpPr>
-        <p:spPr>
-          <a:xfrm>
-            <a:off x="548640" y="5166360"/>
-            <a:ext cx="3520440" cy="182880"/>
-          </a:xfrm>
-          <a:prstGeom prst="rect">
-            <a:avLst/>
-          </a:prstGeom>
-          <a:noFill/>
-          <a:ln/>
-        </p:spPr>
-        <p:txBody>
-          <a:bodyPr wrap="square" lIns="0" tIns="0" rIns="0" bIns="0" rtlCol="0" anchor="t"/>
-          <a:lstStyle/>
-          <a:p>
-            <a:pPr indent="0" marL="0">
-              <a:buNone/>
-            </a:pPr>
-            <a:r>
-              <a:rPr lang="en-US" sz="950" b="1" spc="100" kern="0" dirty="0">
-                <a:solidFill>
-                  <a:srgbClr val="EEE9DE"/>
-                </a:solidFill>
-                <a:latin typeface="Arial" pitchFamily="34" charset="0"/>
-                <a:ea typeface="Arial" pitchFamily="34" charset="-122"/>
-                <a:cs typeface="Arial" pitchFamily="34" charset="-120"/>
-              </a:rPr>
-              <a:t>FIRST USERS</a:t>
-            </a:r>
-            <a:endParaRPr lang="en-US" sz="950" dirty="0"/>
-          </a:p>
-        </p:txBody>
-      </p:sp>
-      <p:sp>
-        <p:nvSpPr>
-          <p:cNvPr id="17" name="Text 15"/>
-          <p:cNvSpPr txBox="1"/>
-          <p:nvPr/>
-        </p:nvSpPr>
-        <p:spPr>
-          <a:xfrm>
-            <a:off x="548640" y="5367528"/>
-            <a:ext cx="3520440" cy="502920"/>
-          </a:xfrm>
-          <a:prstGeom prst="rect">
-            <a:avLst/>
-          </a:prstGeom>
-          <a:noFill/>
-          <a:ln/>
-        </p:spPr>
-        <p:txBody>
-          <a:bodyPr wrap="square" lIns="0" tIns="0" rIns="0" bIns="0" rtlCol="0" anchor="t"/>
-          <a:lstStyle/>
-          <a:p>
-            <a:pPr indent="0" marL="0">
-              <a:lnSpc>
-                <a:spcPct val="100000"/>
-              </a:lnSpc>
-              <a:buNone/>
-            </a:pPr>
-            <a:r>
-              <a:rPr lang="en-US" sz="1150" dirty="0">
-                <a:solidFill>
-                  <a:srgbClr val="A39F94"/>
-                </a:solidFill>
-                <a:latin typeface="Arial" pitchFamily="34" charset="0"/>
-                <a:ea typeface="Arial" pitchFamily="34" charset="-122"/>
-                <a:cs typeface="Arial" pitchFamily="34" charset="-120"/>
-              </a:rPr>
-              <a:t>Pilot done with a 2nd-tier club, a second agreed. Next: renewal season, then leagues for all their clubs.</a:t>
-            </a:r>
-            <a:endParaRPr lang="en-US" sz="1150" dirty="0"/>
-          </a:p>
-        </p:txBody>
-      </p:sp>
-      <p:sp>
-        <p:nvSpPr>
-          <p:cNvPr id="18" name="Text 16"/>
-          <p:cNvSpPr txBox="1"/>
-          <p:nvPr/>
-        </p:nvSpPr>
-        <p:spPr>
-          <a:xfrm>
-            <a:off x="4434840" y="2633472"/>
-            <a:ext cx="3611880" cy="228600"/>
-          </a:xfrm>
-          <a:prstGeom prst="rect">
-            <a:avLst/>
-          </a:prstGeom>
-          <a:noFill/>
-          <a:ln/>
-        </p:spPr>
-        <p:txBody>
-          <a:bodyPr wrap="square" lIns="0" tIns="0" rIns="0" bIns="0" rtlCol="0" anchor="t"/>
-          <a:lstStyle/>
-          <a:p>
-            <a:pPr indent="0" marL="0">
-              <a:buNone/>
-            </a:pPr>
-            <a:r>
-              <a:rPr lang="en-US" sz="1000" b="1" spc="150" kern="0" dirty="0">
-                <a:solidFill>
-                  <a:srgbClr val="C9A766"/>
-                </a:solidFill>
-                <a:latin typeface="Arial" pitchFamily="34" charset="0"/>
-                <a:ea typeface="Arial" pitchFamily="34" charset="-122"/>
-                <a:cs typeface="Arial" pitchFamily="34" charset="-120"/>
-              </a:rPr>
-              <a:t>02   THREE AGENTS, ONE LEDGER</a:t>
-            </a:r>
-            <a:endParaRPr lang="en-US" sz="1000" dirty="0"/>
-          </a:p>
-        </p:txBody>
-      </p:sp>
-      <p:sp>
-        <p:nvSpPr>
-          <p:cNvPr id="19" name="Shape 17"/>
+                <a:latin typeface="Georgia" pitchFamily="34" charset="0"/>
+                <a:ea typeface="Georgia" pitchFamily="34" charset="-122"/>
+                <a:cs typeface="Georgia" pitchFamily="34" charset="-120"/>
+              </a:rPr>
+              <a:t>Three agents that decide, budget and explain.</a:t>
+            </a:r>
+            <a:endParaRPr lang="en-US" sz="1400" dirty="0"/>
+          </a:p>
+        </p:txBody>
+      </p:sp>
+      <p:sp>
+        <p:nvSpPr>
+          <p:cNvPr id="22" name="Shape 20"/>
           <p:cNvSpPr/>
           <p:nvPr/>
         </p:nvSpPr>
         <p:spPr>
           <a:xfrm>
-            <a:off x="4434840" y="3017520"/>
-            <a:ext cx="329184" cy="329184"/>
+            <a:off x="3703320" y="3255264"/>
+            <a:ext cx="310896" cy="310896"/>
           </a:xfrm>
           <a:prstGeom prst="ellipse">
             <a:avLst/>
@@ -1566,14 +1661,14 @@
       </p:sp>
       <p:sp>
         <p:nvSpPr>
-          <p:cNvPr id="20" name="Text 18"/>
-          <p:cNvSpPr txBox="1"/>
-          <p:nvPr/>
-        </p:nvSpPr>
-        <p:spPr>
-          <a:xfrm>
-            <a:off x="4434840" y="3044952"/>
-            <a:ext cx="329184" cy="274320"/>
+          <p:cNvPr id="23" name="Text 21"/>
+          <p:cNvSpPr txBox="1"/>
+          <p:nvPr/>
+        </p:nvSpPr>
+        <p:spPr>
+          <a:xfrm>
+            <a:off x="3703320" y="3273552"/>
+            <a:ext cx="310896" cy="274320"/>
           </a:xfrm>
           <a:prstGeom prst="rect">
             <a:avLst/>
@@ -1589,7 +1684,7 @@
               <a:buNone/>
             </a:pPr>
             <a:r>
-              <a:rPr lang="en-US" sz="1300" dirty="0">
+              <a:rPr lang="en-US" sz="1200" dirty="0">
                 <a:solidFill>
                   <a:srgbClr val="C9A766"/>
                 </a:solidFill>
@@ -1599,36 +1694,36 @@
               </a:rPr>
               <a:t>1</a:t>
             </a:r>
-            <a:endParaRPr lang="en-US" sz="1300" dirty="0"/>
-          </a:p>
-        </p:txBody>
-      </p:sp>
-      <p:sp>
-        <p:nvSpPr>
-          <p:cNvPr id="21" name="Text 19"/>
-          <p:cNvSpPr txBox="1"/>
-          <p:nvPr/>
-        </p:nvSpPr>
-        <p:spPr>
-          <a:xfrm>
-            <a:off x="4937760" y="2999232"/>
-            <a:ext cx="3108960" cy="219456"/>
-          </a:xfrm>
-          <a:prstGeom prst="rect">
-            <a:avLst/>
-          </a:prstGeom>
-          <a:noFill/>
-          <a:ln/>
-        </p:spPr>
-        <p:txBody>
-          <a:bodyPr wrap="square" lIns="0" tIns="0" rIns="0" bIns="0" rtlCol="0" anchor="t"/>
-          <a:lstStyle/>
-          <a:p>
-            <a:pPr indent="0" marL="0">
-              <a:buNone/>
-            </a:pPr>
-            <a:r>
-              <a:rPr lang="en-US" sz="1250" b="1" dirty="0">
+            <a:endParaRPr lang="en-US" sz="1200" dirty="0"/>
+          </a:p>
+        </p:txBody>
+      </p:sp>
+      <p:sp>
+        <p:nvSpPr>
+          <p:cNvPr id="24" name="Text 22"/>
+          <p:cNvSpPr txBox="1"/>
+          <p:nvPr/>
+        </p:nvSpPr>
+        <p:spPr>
+          <a:xfrm>
+            <a:off x="4160520" y="3246120"/>
+            <a:ext cx="2331720" cy="219456"/>
+          </a:xfrm>
+          <a:prstGeom prst="rect">
+            <a:avLst/>
+          </a:prstGeom>
+          <a:noFill/>
+          <a:ln/>
+        </p:spPr>
+        <p:txBody>
+          <a:bodyPr wrap="square" lIns="0" tIns="0" rIns="0" bIns="0" rtlCol="0" anchor="t"/>
+          <a:lstStyle/>
+          <a:p>
+            <a:pPr indent="0" marL="0">
+              <a:buNone/>
+            </a:pPr>
+            <a:r>
+              <a:rPr lang="en-US" sz="1200" b="1" dirty="0">
                 <a:solidFill>
                   <a:srgbClr val="EEE9DE"/>
                 </a:solidFill>
@@ -1638,20 +1733,20 @@
               </a:rPr>
               <a:t>Vision Reader</a:t>
             </a:r>
-            <a:endParaRPr lang="en-US" sz="1250" dirty="0"/>
-          </a:p>
-        </p:txBody>
-      </p:sp>
-      <p:sp>
-        <p:nvSpPr>
-          <p:cNvPr id="22" name="Text 20"/>
-          <p:cNvSpPr txBox="1"/>
-          <p:nvPr/>
-        </p:nvSpPr>
-        <p:spPr>
-          <a:xfrm>
-            <a:off x="4937760" y="3227832"/>
-            <a:ext cx="3108960" cy="411480"/>
+            <a:endParaRPr lang="en-US" sz="1200" dirty="0"/>
+          </a:p>
+        </p:txBody>
+      </p:sp>
+      <p:sp>
+        <p:nvSpPr>
+          <p:cNvPr id="25" name="Text 23"/>
+          <p:cNvSpPr txBox="1"/>
+          <p:nvPr/>
+        </p:nvSpPr>
+        <p:spPr>
+          <a:xfrm>
+            <a:off x="4160520" y="3474720"/>
+            <a:ext cx="2331720" cy="548640"/>
           </a:xfrm>
           <a:prstGeom prst="rect">
             <a:avLst/>
@@ -1675,7 +1770,7 @@
                 <a:ea typeface="Arial" pitchFamily="34" charset="-122"/>
                 <a:cs typeface="Arial" pitchFamily="34" charset="-120"/>
               </a:rPr>
-              <a:t>Reads every frame, picks only from the club's sponsor list. Not sure? It says unknown.</a:t>
+              <a:t>Reads each frame, picks only from the sponsor list. Unsure? Says unknown.</a:t>
             </a:r>
             <a:endParaRPr lang="en-US" sz="1050" dirty="0"/>
           </a:p>
@@ -1683,14 +1778,14 @@
       </p:sp>
       <p:sp>
         <p:nvSpPr>
-          <p:cNvPr id="23" name="Shape 21"/>
+          <p:cNvPr id="26" name="Shape 24"/>
           <p:cNvSpPr/>
           <p:nvPr/>
         </p:nvSpPr>
         <p:spPr>
           <a:xfrm>
-            <a:off x="4434840" y="3694176"/>
-            <a:ext cx="329184" cy="329184"/>
+            <a:off x="3703320" y="4123944"/>
+            <a:ext cx="310896" cy="310896"/>
           </a:xfrm>
           <a:prstGeom prst="ellipse">
             <a:avLst/>
@@ -1708,14 +1803,14 @@
       </p:sp>
       <p:sp>
         <p:nvSpPr>
-          <p:cNvPr id="24" name="Text 22"/>
-          <p:cNvSpPr txBox="1"/>
-          <p:nvPr/>
-        </p:nvSpPr>
-        <p:spPr>
-          <a:xfrm>
-            <a:off x="4434840" y="3721608"/>
-            <a:ext cx="329184" cy="274320"/>
+          <p:cNvPr id="27" name="Text 25"/>
+          <p:cNvSpPr txBox="1"/>
+          <p:nvPr/>
+        </p:nvSpPr>
+        <p:spPr>
+          <a:xfrm>
+            <a:off x="3703320" y="4142232"/>
+            <a:ext cx="310896" cy="274320"/>
           </a:xfrm>
           <a:prstGeom prst="rect">
             <a:avLst/>
@@ -1731,7 +1826,7 @@
               <a:buNone/>
             </a:pPr>
             <a:r>
-              <a:rPr lang="en-US" sz="1300" dirty="0">
+              <a:rPr lang="en-US" sz="1200" dirty="0">
                 <a:solidFill>
                   <a:srgbClr val="C9A766"/>
                 </a:solidFill>
@@ -1741,36 +1836,36 @@
               </a:rPr>
               <a:t>2</a:t>
             </a:r>
-            <a:endParaRPr lang="en-US" sz="1300" dirty="0"/>
-          </a:p>
-        </p:txBody>
-      </p:sp>
-      <p:sp>
-        <p:nvSpPr>
-          <p:cNvPr id="25" name="Text 23"/>
-          <p:cNvSpPr txBox="1"/>
-          <p:nvPr/>
-        </p:nvSpPr>
-        <p:spPr>
-          <a:xfrm>
-            <a:off x="4937760" y="3675888"/>
-            <a:ext cx="3108960" cy="219456"/>
-          </a:xfrm>
-          <a:prstGeom prst="rect">
-            <a:avLst/>
-          </a:prstGeom>
-          <a:noFill/>
-          <a:ln/>
-        </p:spPr>
-        <p:txBody>
-          <a:bodyPr wrap="square" lIns="0" tIns="0" rIns="0" bIns="0" rtlCol="0" anchor="t"/>
-          <a:lstStyle/>
-          <a:p>
-            <a:pPr indent="0" marL="0">
-              <a:buNone/>
-            </a:pPr>
-            <a:r>
-              <a:rPr lang="en-US" sz="1250" b="1" dirty="0">
+            <a:endParaRPr lang="en-US" sz="1200" dirty="0"/>
+          </a:p>
+        </p:txBody>
+      </p:sp>
+      <p:sp>
+        <p:nvSpPr>
+          <p:cNvPr id="28" name="Text 26"/>
+          <p:cNvSpPr txBox="1"/>
+          <p:nvPr/>
+        </p:nvSpPr>
+        <p:spPr>
+          <a:xfrm>
+            <a:off x="4160520" y="4114800"/>
+            <a:ext cx="2331720" cy="219456"/>
+          </a:xfrm>
+          <a:prstGeom prst="rect">
+            <a:avLst/>
+          </a:prstGeom>
+          <a:noFill/>
+          <a:ln/>
+        </p:spPr>
+        <p:txBody>
+          <a:bodyPr wrap="square" lIns="0" tIns="0" rIns="0" bIns="0" rtlCol="0" anchor="t"/>
+          <a:lstStyle/>
+          <a:p>
+            <a:pPr indent="0" marL="0">
+              <a:buNone/>
+            </a:pPr>
+            <a:r>
+              <a:rPr lang="en-US" sz="1200" b="1" dirty="0">
                 <a:solidFill>
                   <a:srgbClr val="EEE9DE"/>
                 </a:solidFill>
@@ -1780,20 +1875,20 @@
               </a:rPr>
               <a:t>Budget Guard</a:t>
             </a:r>
-            <a:endParaRPr lang="en-US" sz="1250" dirty="0"/>
-          </a:p>
-        </p:txBody>
-      </p:sp>
-      <p:sp>
-        <p:nvSpPr>
-          <p:cNvPr id="26" name="Text 24"/>
-          <p:cNvSpPr txBox="1"/>
-          <p:nvPr/>
-        </p:nvSpPr>
-        <p:spPr>
-          <a:xfrm>
-            <a:off x="4937760" y="3904488"/>
-            <a:ext cx="3108960" cy="411480"/>
+            <a:endParaRPr lang="en-US" sz="1200" dirty="0"/>
+          </a:p>
+        </p:txBody>
+      </p:sp>
+      <p:sp>
+        <p:nvSpPr>
+          <p:cNvPr id="29" name="Text 27"/>
+          <p:cNvSpPr txBox="1"/>
+          <p:nvPr/>
+        </p:nvSpPr>
+        <p:spPr>
+          <a:xfrm>
+            <a:off x="4160520" y="4343400"/>
+            <a:ext cx="2331720" cy="548640"/>
           </a:xfrm>
           <a:prstGeom prst="rect">
             <a:avLst/>
@@ -1817,7 +1912,7 @@
                 <a:ea typeface="Arial" pitchFamily="34" charset="-122"/>
                 <a:cs typeface="Arial" pitchFamily="34" charset="-120"/>
               </a:rPr>
-              <a:t>Prices each model call before making it, under a hard per-match budget.</a:t>
+              <a:t>Prices every model call first; stops at a hard per-match budget.</a:t>
             </a:r>
             <a:endParaRPr lang="en-US" sz="1050" dirty="0"/>
           </a:p>
@@ -1825,14 +1920,14 @@
       </p:sp>
       <p:sp>
         <p:nvSpPr>
-          <p:cNvPr id="27" name="Shape 25"/>
+          <p:cNvPr id="30" name="Shape 28"/>
           <p:cNvSpPr/>
           <p:nvPr/>
         </p:nvSpPr>
         <p:spPr>
           <a:xfrm>
-            <a:off x="4434840" y="4370832"/>
-            <a:ext cx="329184" cy="329184"/>
+            <a:off x="3703320" y="4992624"/>
+            <a:ext cx="310896" cy="310896"/>
           </a:xfrm>
           <a:prstGeom prst="ellipse">
             <a:avLst/>
@@ -1850,14 +1945,14 @@
       </p:sp>
       <p:sp>
         <p:nvSpPr>
-          <p:cNvPr id="28" name="Text 26"/>
-          <p:cNvSpPr txBox="1"/>
-          <p:nvPr/>
-        </p:nvSpPr>
-        <p:spPr>
-          <a:xfrm>
-            <a:off x="4434840" y="4398264"/>
-            <a:ext cx="329184" cy="274320"/>
+          <p:cNvPr id="31" name="Text 29"/>
+          <p:cNvSpPr txBox="1"/>
+          <p:nvPr/>
+        </p:nvSpPr>
+        <p:spPr>
+          <a:xfrm>
+            <a:off x="3703320" y="5010912"/>
+            <a:ext cx="310896" cy="274320"/>
           </a:xfrm>
           <a:prstGeom prst="rect">
             <a:avLst/>
@@ -1873,7 +1968,7 @@
               <a:buNone/>
             </a:pPr>
             <a:r>
-              <a:rPr lang="en-US" sz="1300" dirty="0">
+              <a:rPr lang="en-US" sz="1200" dirty="0">
                 <a:solidFill>
                   <a:srgbClr val="C9A766"/>
                 </a:solidFill>
@@ -1883,36 +1978,36 @@
               </a:rPr>
               <a:t>3</a:t>
             </a:r>
-            <a:endParaRPr lang="en-US" sz="1300" dirty="0"/>
-          </a:p>
-        </p:txBody>
-      </p:sp>
-      <p:sp>
-        <p:nvSpPr>
-          <p:cNvPr id="29" name="Text 27"/>
-          <p:cNvSpPr txBox="1"/>
-          <p:nvPr/>
-        </p:nvSpPr>
-        <p:spPr>
-          <a:xfrm>
-            <a:off x="4937760" y="4352544"/>
-            <a:ext cx="3108960" cy="219456"/>
-          </a:xfrm>
-          <a:prstGeom prst="rect">
-            <a:avLst/>
-          </a:prstGeom>
-          <a:noFill/>
-          <a:ln/>
-        </p:spPr>
-        <p:txBody>
-          <a:bodyPr wrap="square" lIns="0" tIns="0" rIns="0" bIns="0" rtlCol="0" anchor="t"/>
-          <a:lstStyle/>
-          <a:p>
-            <a:pPr indent="0" marL="0">
-              <a:buNone/>
-            </a:pPr>
-            <a:r>
-              <a:rPr lang="en-US" sz="1250" b="1" dirty="0">
+            <a:endParaRPr lang="en-US" sz="1200" dirty="0"/>
+          </a:p>
+        </p:txBody>
+      </p:sp>
+      <p:sp>
+        <p:nvSpPr>
+          <p:cNvPr id="32" name="Text 30"/>
+          <p:cNvSpPr txBox="1"/>
+          <p:nvPr/>
+        </p:nvSpPr>
+        <p:spPr>
+          <a:xfrm>
+            <a:off x="4160520" y="4983480"/>
+            <a:ext cx="2331720" cy="219456"/>
+          </a:xfrm>
+          <a:prstGeom prst="rect">
+            <a:avLst/>
+          </a:prstGeom>
+          <a:noFill/>
+          <a:ln/>
+        </p:spPr>
+        <p:txBody>
+          <a:bodyPr wrap="square" lIns="0" tIns="0" rIns="0" bIns="0" rtlCol="0" anchor="t"/>
+          <a:lstStyle/>
+          <a:p>
+            <a:pPr indent="0" marL="0">
+              <a:buNone/>
+            </a:pPr>
+            <a:r>
+              <a:rPr lang="en-US" sz="1200" b="1" dirty="0">
                 <a:solidFill>
                   <a:srgbClr val="EEE9DE"/>
                 </a:solidFill>
@@ -1922,20 +2017,20 @@
               </a:rPr>
               <a:t>Sponsor Analyst</a:t>
             </a:r>
-            <a:endParaRPr lang="en-US" sz="1250" dirty="0"/>
-          </a:p>
-        </p:txBody>
-      </p:sp>
-      <p:sp>
-        <p:nvSpPr>
-          <p:cNvPr id="30" name="Text 28"/>
-          <p:cNvSpPr txBox="1"/>
-          <p:nvPr/>
-        </p:nvSpPr>
-        <p:spPr>
-          <a:xfrm>
-            <a:off x="4937760" y="4581144"/>
-            <a:ext cx="3108960" cy="411480"/>
+            <a:endParaRPr lang="en-US" sz="1200" dirty="0"/>
+          </a:p>
+        </p:txBody>
+      </p:sp>
+      <p:sp>
+        <p:nvSpPr>
+          <p:cNvPr id="33" name="Text 31"/>
+          <p:cNvSpPr txBox="1"/>
+          <p:nvPr/>
+        </p:nvSpPr>
+        <p:spPr>
+          <a:xfrm>
+            <a:off x="4160520" y="5212080"/>
+            <a:ext cx="2331720" cy="548640"/>
           </a:xfrm>
           <a:prstGeom prst="rect">
             <a:avLst/>
@@ -1959,7 +2054,7 @@
                 <a:ea typeface="Arial" pitchFamily="34" charset="-122"/>
                 <a:cs typeface="Arial" pitchFamily="34" charset="-120"/>
               </a:rPr>
-              <a:t>Answers open questions by calling the data API as tools, citing seconds and frames.</a:t>
+              <a:t>Plans its own tool calls on the data API; cites seconds and frames.</a:t>
             </a:r>
             <a:endParaRPr lang="en-US" sz="1050" dirty="0"/>
           </a:p>
@@ -1967,38 +2062,38 @@
       </p:sp>
       <p:sp>
         <p:nvSpPr>
-          <p:cNvPr id="31" name="Text 29"/>
-          <p:cNvSpPr txBox="1"/>
-          <p:nvPr/>
-        </p:nvSpPr>
-        <p:spPr>
-          <a:xfrm>
-            <a:off x="4434840" y="5120640"/>
-            <a:ext cx="3611880" cy="182880"/>
-          </a:xfrm>
-          <a:prstGeom prst="rect">
-            <a:avLst/>
-          </a:prstGeom>
-          <a:noFill/>
-          <a:ln/>
-        </p:spPr>
-        <p:txBody>
-          <a:bodyPr wrap="square" lIns="0" tIns="0" rIns="0" bIns="0" rtlCol="0" anchor="t"/>
-          <a:lstStyle/>
-          <a:p>
-            <a:pPr indent="0" marL="0">
-              <a:buNone/>
-            </a:pPr>
-            <a:r>
-              <a:rPr lang="en-US" sz="900" b="1" spc="100" kern="0" dirty="0">
-                <a:solidFill>
-                  <a:srgbClr val="6F6C64"/>
-                </a:solidFill>
-                <a:latin typeface="Arial" pitchFamily="34" charset="0"/>
-                <a:ea typeface="Arial" pitchFamily="34" charset="-122"/>
-                <a:cs typeface="Arial" pitchFamily="34" charset="-120"/>
-              </a:rPr>
-              <a:t>LIVE DATA LAYER ON AIVEN</a:t>
+          <p:cNvPr id="34" name="Text 32"/>
+          <p:cNvSpPr txBox="1"/>
+          <p:nvPr/>
+        </p:nvSpPr>
+        <p:spPr>
+          <a:xfrm>
+            <a:off x="6858000" y="2340864"/>
+            <a:ext cx="2148840" cy="201168"/>
+          </a:xfrm>
+          <a:prstGeom prst="rect">
+            <a:avLst/>
+          </a:prstGeom>
+          <a:noFill/>
+          <a:ln/>
+        </p:spPr>
+        <p:txBody>
+          <a:bodyPr wrap="square" lIns="0" tIns="0" rIns="0" bIns="0" rtlCol="0" anchor="t"/>
+          <a:lstStyle/>
+          <a:p>
+            <a:pPr indent="0" marL="0">
+              <a:buNone/>
+            </a:pPr>
+            <a:r>
+              <a:rPr lang="en-US" sz="900" b="1" spc="120" kern="0" dirty="0">
+                <a:solidFill>
+                  <a:srgbClr val="C9A766"/>
+                </a:solidFill>
+                <a:latin typeface="Arial" pitchFamily="34" charset="0"/>
+                <a:ea typeface="Arial" pitchFamily="34" charset="-122"/>
+                <a:cs typeface="Arial" pitchFamily="34" charset="-120"/>
+              </a:rPr>
+              <a:t>03  DATA AT THE CORE</a:t>
             </a:r>
             <a:endParaRPr lang="en-US" sz="900" dirty="0"/>
           </a:p>
@@ -2006,18 +2101,60 @@
       </p:sp>
       <p:sp>
         <p:nvSpPr>
-          <p:cNvPr id="32" name="Shape 30"/>
+          <p:cNvPr id="35" name="Text 33"/>
+          <p:cNvSpPr txBox="1"/>
+          <p:nvPr/>
+        </p:nvSpPr>
+        <p:spPr>
+          <a:xfrm>
+            <a:off x="6858000" y="2615184"/>
+            <a:ext cx="2148840" cy="530352"/>
+          </a:xfrm>
+          <a:prstGeom prst="rect">
+            <a:avLst/>
+          </a:prstGeom>
+          <a:noFill/>
+          <a:ln/>
+        </p:spPr>
+        <p:txBody>
+          <a:bodyPr wrap="square" lIns="0" tIns="0" rIns="0" bIns="0" rtlCol="0" anchor="t"/>
+          <a:lstStyle/>
+          <a:p>
+            <a:pPr indent="0" marL="0">
+              <a:lnSpc>
+                <a:spcPct val="95000"/>
+              </a:lnSpc>
+              <a:buNone/>
+            </a:pPr>
+            <a:r>
+              <a:rPr lang="en-US" sz="1400" dirty="0">
+                <a:solidFill>
+                  <a:srgbClr val="EEE9DE"/>
+                </a:solidFill>
+                <a:latin typeface="Georgia" pitchFamily="34" charset="0"/>
+                <a:ea typeface="Georgia" pitchFamily="34" charset="-122"/>
+                <a:cs typeface="Georgia" pitchFamily="34" charset="-120"/>
+              </a:rPr>
+              <a:t>No live data, no product.</a:t>
+            </a:r>
+            <a:endParaRPr lang="en-US" sz="1400" dirty="0"/>
+          </a:p>
+        </p:txBody>
+      </p:sp>
+      <p:sp>
+        <p:nvSpPr>
+          <p:cNvPr id="36" name="Shape 34"/>
           <p:cNvSpPr/>
           <p:nvPr/>
         </p:nvSpPr>
         <p:spPr>
           <a:xfrm>
-            <a:off x="4434840" y="5367528"/>
-            <a:ext cx="658368" cy="292608"/>
+            <a:off x="6858000" y="3236976"/>
+            <a:ext cx="2148840" cy="512064"/>
           </a:xfrm>
           <a:prstGeom prst="roundRect">
             <a:avLst>
-              <a:gd name="adj" fmla="val 50000"/>
+              <a:gd name="adj" fmla="val 14286"/>
             </a:avLst>
           </a:prstGeom>
           <a:solidFill>
@@ -2033,30 +2170,30 @@
       </p:sp>
       <p:sp>
         <p:nvSpPr>
-          <p:cNvPr id="33" name="Text 31"/>
-          <p:cNvSpPr txBox="1"/>
-          <p:nvPr/>
-        </p:nvSpPr>
-        <p:spPr>
-          <a:xfrm>
-            <a:off x="4434840" y="5367528"/>
-            <a:ext cx="658368" cy="292608"/>
-          </a:xfrm>
-          <a:prstGeom prst="rect">
-            <a:avLst/>
-          </a:prstGeom>
-          <a:noFill/>
-          <a:ln/>
-        </p:spPr>
-        <p:txBody>
-          <a:bodyPr wrap="square" lIns="0" tIns="0" rIns="0" bIns="0" rtlCol="0" anchor="ctr"/>
-          <a:lstStyle/>
-          <a:p>
-            <a:pPr algn="ctr" indent="0" marL="0">
-              <a:buNone/>
-            </a:pPr>
-            <a:r>
-              <a:rPr lang="en-US" sz="950" dirty="0">
+          <p:cNvPr id="37" name="Text 35"/>
+          <p:cNvSpPr txBox="1"/>
+          <p:nvPr/>
+        </p:nvSpPr>
+        <p:spPr>
+          <a:xfrm>
+            <a:off x="6986016" y="3300984"/>
+            <a:ext cx="1892808" cy="182880"/>
+          </a:xfrm>
+          <a:prstGeom prst="rect">
+            <a:avLst/>
+          </a:prstGeom>
+          <a:noFill/>
+          <a:ln/>
+        </p:spPr>
+        <p:txBody>
+          <a:bodyPr wrap="square" lIns="0" tIns="0" rIns="0" bIns="0" rtlCol="0" anchor="t"/>
+          <a:lstStyle/>
+          <a:p>
+            <a:pPr indent="0" marL="0">
+              <a:buNone/>
+            </a:pPr>
+            <a:r>
+              <a:rPr lang="en-US" sz="1050" b="1" dirty="0">
                 <a:solidFill>
                   <a:srgbClr val="EEE9DE"/>
                 </a:solidFill>
@@ -2066,63 +2203,63 @@
               </a:rPr>
               <a:t>Kafka</a:t>
             </a:r>
-            <a:endParaRPr lang="en-US" sz="950" dirty="0"/>
-          </a:p>
-        </p:txBody>
-      </p:sp>
-      <p:sp>
-        <p:nvSpPr>
-          <p:cNvPr id="34" name="Text 32"/>
-          <p:cNvSpPr txBox="1"/>
-          <p:nvPr/>
-        </p:nvSpPr>
-        <p:spPr>
-          <a:xfrm>
-            <a:off x="5093208" y="5358384"/>
-            <a:ext cx="182880" cy="292608"/>
-          </a:xfrm>
-          <a:prstGeom prst="rect">
-            <a:avLst/>
-          </a:prstGeom>
-          <a:noFill/>
-          <a:ln/>
-        </p:spPr>
-        <p:txBody>
-          <a:bodyPr wrap="square" lIns="0" tIns="0" rIns="0" bIns="0" rtlCol="0" anchor="ctr"/>
-          <a:lstStyle/>
-          <a:p>
-            <a:pPr algn="ctr" indent="0" marL="0">
-              <a:buNone/>
-            </a:pPr>
-            <a:r>
-              <a:rPr lang="en-US" sz="1200" dirty="0">
-                <a:solidFill>
-                  <a:srgbClr val="C9A766"/>
-                </a:solidFill>
-                <a:latin typeface="Arial" pitchFamily="34" charset="0"/>
-                <a:ea typeface="Arial" pitchFamily="34" charset="-122"/>
-                <a:cs typeface="Arial" pitchFamily="34" charset="-120"/>
-              </a:rPr>
-              <a:t>›</a:t>
-            </a:r>
-            <a:endParaRPr lang="en-US" sz="1200" dirty="0"/>
-          </a:p>
-        </p:txBody>
-      </p:sp>
-      <p:sp>
-        <p:nvSpPr>
-          <p:cNvPr id="35" name="Shape 33"/>
+            <a:endParaRPr lang="en-US" sz="1050" dirty="0"/>
+          </a:p>
+        </p:txBody>
+      </p:sp>
+      <p:sp>
+        <p:nvSpPr>
+          <p:cNvPr id="38" name="Text 36"/>
+          <p:cNvSpPr txBox="1"/>
+          <p:nvPr/>
+        </p:nvSpPr>
+        <p:spPr>
+          <a:xfrm>
+            <a:off x="6986016" y="3502152"/>
+            <a:ext cx="1892808" cy="182880"/>
+          </a:xfrm>
+          <a:prstGeom prst="rect">
+            <a:avLst/>
+          </a:prstGeom>
+          <a:noFill/>
+          <a:ln/>
+        </p:spPr>
+        <p:txBody>
+          <a:bodyPr wrap="square" lIns="0" tIns="0" rIns="0" bIns="0" rtlCol="0" anchor="t"/>
+          <a:lstStyle/>
+          <a:p>
+            <a:pPr indent="0" marL="0">
+              <a:buNone/>
+            </a:pPr>
+            <a:r>
+              <a:rPr lang="en-US" sz="900" dirty="0">
+                <a:solidFill>
+                  <a:srgbClr val="A39F94"/>
+                </a:solidFill>
+                <a:latin typeface="Arial" pitchFamily="34" charset="0"/>
+                <a:ea typeface="Arial" pitchFamily="34" charset="-122"/>
+                <a:cs typeface="Arial" pitchFamily="34" charset="-120"/>
+              </a:rPr>
+              <a:t>frames + decisions, streamed</a:t>
+            </a:r>
+            <a:endParaRPr lang="en-US" sz="900" dirty="0"/>
+          </a:p>
+        </p:txBody>
+      </p:sp>
+      <p:sp>
+        <p:nvSpPr>
+          <p:cNvPr id="39" name="Shape 37"/>
           <p:cNvSpPr/>
           <p:nvPr/>
         </p:nvSpPr>
         <p:spPr>
           <a:xfrm>
-            <a:off x="5276088" y="5367528"/>
-            <a:ext cx="896112" cy="292608"/>
+            <a:off x="6858000" y="3877056"/>
+            <a:ext cx="2148840" cy="512064"/>
           </a:xfrm>
           <a:prstGeom prst="roundRect">
             <a:avLst>
-              <a:gd name="adj" fmla="val 50000"/>
+              <a:gd name="adj" fmla="val 14286"/>
             </a:avLst>
           </a:prstGeom>
           <a:solidFill>
@@ -2138,30 +2275,30 @@
       </p:sp>
       <p:sp>
         <p:nvSpPr>
-          <p:cNvPr id="36" name="Text 34"/>
-          <p:cNvSpPr txBox="1"/>
-          <p:nvPr/>
-        </p:nvSpPr>
-        <p:spPr>
-          <a:xfrm>
-            <a:off x="5276088" y="5367528"/>
-            <a:ext cx="896112" cy="292608"/>
-          </a:xfrm>
-          <a:prstGeom prst="rect">
-            <a:avLst/>
-          </a:prstGeom>
-          <a:noFill/>
-          <a:ln/>
-        </p:spPr>
-        <p:txBody>
-          <a:bodyPr wrap="square" lIns="0" tIns="0" rIns="0" bIns="0" rtlCol="0" anchor="ctr"/>
-          <a:lstStyle/>
-          <a:p>
-            <a:pPr algn="ctr" indent="0" marL="0">
-              <a:buNone/>
-            </a:pPr>
-            <a:r>
-              <a:rPr lang="en-US" sz="950" dirty="0">
+          <p:cNvPr id="40" name="Text 38"/>
+          <p:cNvSpPr txBox="1"/>
+          <p:nvPr/>
+        </p:nvSpPr>
+        <p:spPr>
+          <a:xfrm>
+            <a:off x="6986016" y="3941064"/>
+            <a:ext cx="1892808" cy="182880"/>
+          </a:xfrm>
+          <a:prstGeom prst="rect">
+            <a:avLst/>
+          </a:prstGeom>
+          <a:noFill/>
+          <a:ln/>
+        </p:spPr>
+        <p:txBody>
+          <a:bodyPr wrap="square" lIns="0" tIns="0" rIns="0" bIns="0" rtlCol="0" anchor="t"/>
+          <a:lstStyle/>
+          <a:p>
+            <a:pPr indent="0" marL="0">
+              <a:buNone/>
+            </a:pPr>
+            <a:r>
+              <a:rPr lang="en-US" sz="1050" b="1" dirty="0">
                 <a:solidFill>
                   <a:srgbClr val="EEE9DE"/>
                 </a:solidFill>
@@ -2171,63 +2308,63 @@
               </a:rPr>
               <a:t>ClickHouse</a:t>
             </a:r>
-            <a:endParaRPr lang="en-US" sz="950" dirty="0"/>
-          </a:p>
-        </p:txBody>
-      </p:sp>
-      <p:sp>
-        <p:nvSpPr>
-          <p:cNvPr id="37" name="Text 35"/>
-          <p:cNvSpPr txBox="1"/>
-          <p:nvPr/>
-        </p:nvSpPr>
-        <p:spPr>
-          <a:xfrm>
-            <a:off x="6172200" y="5358384"/>
-            <a:ext cx="182880" cy="292608"/>
-          </a:xfrm>
-          <a:prstGeom prst="rect">
-            <a:avLst/>
-          </a:prstGeom>
-          <a:noFill/>
-          <a:ln/>
-        </p:spPr>
-        <p:txBody>
-          <a:bodyPr wrap="square" lIns="0" tIns="0" rIns="0" bIns="0" rtlCol="0" anchor="ctr"/>
-          <a:lstStyle/>
-          <a:p>
-            <a:pPr algn="ctr" indent="0" marL="0">
-              <a:buNone/>
-            </a:pPr>
-            <a:r>
-              <a:rPr lang="en-US" sz="1200" dirty="0">
-                <a:solidFill>
-                  <a:srgbClr val="C9A766"/>
-                </a:solidFill>
-                <a:latin typeface="Arial" pitchFamily="34" charset="0"/>
-                <a:ea typeface="Arial" pitchFamily="34" charset="-122"/>
-                <a:cs typeface="Arial" pitchFamily="34" charset="-120"/>
-              </a:rPr>
-              <a:t>›</a:t>
-            </a:r>
-            <a:endParaRPr lang="en-US" sz="1200" dirty="0"/>
-          </a:p>
-        </p:txBody>
-      </p:sp>
-      <p:sp>
-        <p:nvSpPr>
-          <p:cNvPr id="38" name="Shape 36"/>
+            <a:endParaRPr lang="en-US" sz="1050" dirty="0"/>
+          </a:p>
+        </p:txBody>
+      </p:sp>
+      <p:sp>
+        <p:nvSpPr>
+          <p:cNvPr id="41" name="Text 39"/>
+          <p:cNvSpPr txBox="1"/>
+          <p:nvPr/>
+        </p:nvSpPr>
+        <p:spPr>
+          <a:xfrm>
+            <a:off x="6986016" y="4142232"/>
+            <a:ext cx="1892808" cy="182880"/>
+          </a:xfrm>
+          <a:prstGeom prst="rect">
+            <a:avLst/>
+          </a:prstGeom>
+          <a:noFill/>
+          <a:ln/>
+        </p:spPr>
+        <p:txBody>
+          <a:bodyPr wrap="square" lIns="0" tIns="0" rIns="0" bIns="0" rtlCol="0" anchor="t"/>
+          <a:lstStyle/>
+          <a:p>
+            <a:pPr indent="0" marL="0">
+              <a:buNone/>
+            </a:pPr>
+            <a:r>
+              <a:rPr lang="en-US" sz="900" dirty="0">
+                <a:solidFill>
+                  <a:srgbClr val="A39F94"/>
+                </a:solidFill>
+                <a:latin typeface="Arial" pitchFamily="34" charset="0"/>
+                <a:ea typeface="Arial" pitchFamily="34" charset="-122"/>
+                <a:cs typeface="Arial" pitchFamily="34" charset="-120"/>
+              </a:rPr>
+              <a:t>per-second intervals, coverage</a:t>
+            </a:r>
+            <a:endParaRPr lang="en-US" sz="900" dirty="0"/>
+          </a:p>
+        </p:txBody>
+      </p:sp>
+      <p:sp>
+        <p:nvSpPr>
+          <p:cNvPr id="42" name="Shape 40"/>
           <p:cNvSpPr/>
           <p:nvPr/>
         </p:nvSpPr>
         <p:spPr>
           <a:xfrm>
-            <a:off x="6355080" y="5367528"/>
-            <a:ext cx="658368" cy="292608"/>
+            <a:off x="6858000" y="4517136"/>
+            <a:ext cx="2148840" cy="512064"/>
           </a:xfrm>
           <a:prstGeom prst="roundRect">
             <a:avLst>
-              <a:gd name="adj" fmla="val 50000"/>
+              <a:gd name="adj" fmla="val 14286"/>
             </a:avLst>
           </a:prstGeom>
           <a:solidFill>
@@ -2243,30 +2380,30 @@
       </p:sp>
       <p:sp>
         <p:nvSpPr>
-          <p:cNvPr id="39" name="Text 37"/>
-          <p:cNvSpPr txBox="1"/>
-          <p:nvPr/>
-        </p:nvSpPr>
-        <p:spPr>
-          <a:xfrm>
-            <a:off x="6355080" y="5367528"/>
-            <a:ext cx="658368" cy="292608"/>
-          </a:xfrm>
-          <a:prstGeom prst="rect">
-            <a:avLst/>
-          </a:prstGeom>
-          <a:noFill/>
-          <a:ln/>
-        </p:spPr>
-        <p:txBody>
-          <a:bodyPr wrap="square" lIns="0" tIns="0" rIns="0" bIns="0" rtlCol="0" anchor="ctr"/>
-          <a:lstStyle/>
-          <a:p>
-            <a:pPr algn="ctr" indent="0" marL="0">
-              <a:buNone/>
-            </a:pPr>
-            <a:r>
-              <a:rPr lang="en-US" sz="950" dirty="0">
+          <p:cNvPr id="43" name="Text 41"/>
+          <p:cNvSpPr txBox="1"/>
+          <p:nvPr/>
+        </p:nvSpPr>
+        <p:spPr>
+          <a:xfrm>
+            <a:off x="6986016" y="4581144"/>
+            <a:ext cx="1892808" cy="182880"/>
+          </a:xfrm>
+          <a:prstGeom prst="rect">
+            <a:avLst/>
+          </a:prstGeom>
+          <a:noFill/>
+          <a:ln/>
+        </p:spPr>
+        <p:txBody>
+          <a:bodyPr wrap="square" lIns="0" tIns="0" rIns="0" bIns="0" rtlCol="0" anchor="t"/>
+          <a:lstStyle/>
+          <a:p>
+            <a:pPr indent="0" marL="0">
+              <a:buNone/>
+            </a:pPr>
+            <a:r>
+              <a:rPr lang="en-US" sz="1050" b="1" dirty="0">
                 <a:solidFill>
                   <a:srgbClr val="EEE9DE"/>
                 </a:solidFill>
@@ -2276,63 +2413,63 @@
               </a:rPr>
               <a:t>Valkey</a:t>
             </a:r>
-            <a:endParaRPr lang="en-US" sz="950" dirty="0"/>
-          </a:p>
-        </p:txBody>
-      </p:sp>
-      <p:sp>
-        <p:nvSpPr>
-          <p:cNvPr id="40" name="Text 38"/>
-          <p:cNvSpPr txBox="1"/>
-          <p:nvPr/>
-        </p:nvSpPr>
-        <p:spPr>
-          <a:xfrm>
-            <a:off x="7013448" y="5358384"/>
-            <a:ext cx="182880" cy="292608"/>
-          </a:xfrm>
-          <a:prstGeom prst="rect">
-            <a:avLst/>
-          </a:prstGeom>
-          <a:noFill/>
-          <a:ln/>
-        </p:spPr>
-        <p:txBody>
-          <a:bodyPr wrap="square" lIns="0" tIns="0" rIns="0" bIns="0" rtlCol="0" anchor="ctr"/>
-          <a:lstStyle/>
-          <a:p>
-            <a:pPr algn="ctr" indent="0" marL="0">
-              <a:buNone/>
-            </a:pPr>
-            <a:r>
-              <a:rPr lang="en-US" sz="1200" dirty="0">
-                <a:solidFill>
-                  <a:srgbClr val="C9A766"/>
-                </a:solidFill>
-                <a:latin typeface="Arial" pitchFamily="34" charset="0"/>
-                <a:ea typeface="Arial" pitchFamily="34" charset="-122"/>
-                <a:cs typeface="Arial" pitchFamily="34" charset="-120"/>
-              </a:rPr>
-              <a:t>›</a:t>
-            </a:r>
-            <a:endParaRPr lang="en-US" sz="1200" dirty="0"/>
-          </a:p>
-        </p:txBody>
-      </p:sp>
-      <p:sp>
-        <p:nvSpPr>
-          <p:cNvPr id="41" name="Shape 39"/>
+            <a:endParaRPr lang="en-US" sz="1050" dirty="0"/>
+          </a:p>
+        </p:txBody>
+      </p:sp>
+      <p:sp>
+        <p:nvSpPr>
+          <p:cNvPr id="44" name="Text 42"/>
+          <p:cNvSpPr txBox="1"/>
+          <p:nvPr/>
+        </p:nvSpPr>
+        <p:spPr>
+          <a:xfrm>
+            <a:off x="6986016" y="4782312"/>
+            <a:ext cx="1892808" cy="182880"/>
+          </a:xfrm>
+          <a:prstGeom prst="rect">
+            <a:avLst/>
+          </a:prstGeom>
+          <a:noFill/>
+          <a:ln/>
+        </p:spPr>
+        <p:txBody>
+          <a:bodyPr wrap="square" lIns="0" tIns="0" rIns="0" bIns="0" rtlCol="0" anchor="t"/>
+          <a:lstStyle/>
+          <a:p>
+            <a:pPr indent="0" marL="0">
+              <a:buNone/>
+            </a:pPr>
+            <a:r>
+              <a:rPr lang="en-US" sz="900" dirty="0">
+                <a:solidFill>
+                  <a:srgbClr val="A39F94"/>
+                </a:solidFill>
+                <a:latin typeface="Arial" pitchFamily="34" charset="0"/>
+                <a:ea typeface="Arial" pitchFamily="34" charset="-122"/>
+                <a:cs typeface="Arial" pitchFamily="34" charset="-120"/>
+              </a:rPr>
+              <a:t>live counters, atomic budget</a:t>
+            </a:r>
+            <a:endParaRPr lang="en-US" sz="900" dirty="0"/>
+          </a:p>
+        </p:txBody>
+      </p:sp>
+      <p:sp>
+        <p:nvSpPr>
+          <p:cNvPr id="45" name="Shape 43"/>
           <p:cNvSpPr/>
           <p:nvPr/>
         </p:nvSpPr>
         <p:spPr>
           <a:xfrm>
-            <a:off x="7196328" y="5367528"/>
-            <a:ext cx="795528" cy="292608"/>
+            <a:off x="6858000" y="5157216"/>
+            <a:ext cx="2148840" cy="512064"/>
           </a:xfrm>
           <a:prstGeom prst="roundRect">
             <a:avLst>
-              <a:gd name="adj" fmla="val 50000"/>
+              <a:gd name="adj" fmla="val 14286"/>
             </a:avLst>
           </a:prstGeom>
           <a:solidFill>
@@ -2348,30 +2485,30 @@
       </p:sp>
       <p:sp>
         <p:nvSpPr>
-          <p:cNvPr id="42" name="Text 40"/>
-          <p:cNvSpPr txBox="1"/>
-          <p:nvPr/>
-        </p:nvSpPr>
-        <p:spPr>
-          <a:xfrm>
-            <a:off x="7196328" y="5367528"/>
-            <a:ext cx="795528" cy="292608"/>
-          </a:xfrm>
-          <a:prstGeom prst="rect">
-            <a:avLst/>
-          </a:prstGeom>
-          <a:noFill/>
-          <a:ln/>
-        </p:spPr>
-        <p:txBody>
-          <a:bodyPr wrap="square" lIns="0" tIns="0" rIns="0" bIns="0" rtlCol="0" anchor="ctr"/>
-          <a:lstStyle/>
-          <a:p>
-            <a:pPr algn="ctr" indent="0" marL="0">
-              <a:buNone/>
-            </a:pPr>
-            <a:r>
-              <a:rPr lang="en-US" sz="950" dirty="0">
+          <p:cNvPr id="46" name="Text 44"/>
+          <p:cNvSpPr txBox="1"/>
+          <p:nvPr/>
+        </p:nvSpPr>
+        <p:spPr>
+          <a:xfrm>
+            <a:off x="6986016" y="5221224"/>
+            <a:ext cx="1892808" cy="182880"/>
+          </a:xfrm>
+          <a:prstGeom prst="rect">
+            <a:avLst/>
+          </a:prstGeom>
+          <a:noFill/>
+          <a:ln/>
+        </p:spPr>
+        <p:txBody>
+          <a:bodyPr wrap="square" lIns="0" tIns="0" rIns="0" bIns="0" rtlCol="0" anchor="t"/>
+          <a:lstStyle/>
+          <a:p>
+            <a:pPr indent="0" marL="0">
+              <a:buNone/>
+            </a:pPr>
+            <a:r>
+              <a:rPr lang="en-US" sz="1050" b="1" dirty="0">
                 <a:solidFill>
                   <a:srgbClr val="EEE9DE"/>
                 </a:solidFill>
@@ -2379,38 +2516,38 @@
                 <a:ea typeface="Arial" pitchFamily="34" charset="-122"/>
                 <a:cs typeface="Arial" pitchFamily="34" charset="-120"/>
               </a:rPr>
-              <a:t>Postgres</a:t>
-            </a:r>
-            <a:endParaRPr lang="en-US" sz="950" dirty="0"/>
-          </a:p>
-        </p:txBody>
-      </p:sp>
-      <p:sp>
-        <p:nvSpPr>
-          <p:cNvPr id="43" name="Text 41"/>
-          <p:cNvSpPr txBox="1"/>
-          <p:nvPr/>
-        </p:nvSpPr>
-        <p:spPr>
-          <a:xfrm>
-            <a:off x="4434840" y="5760720"/>
-            <a:ext cx="3611880" cy="228600"/>
-          </a:xfrm>
-          <a:prstGeom prst="rect">
-            <a:avLst/>
-          </a:prstGeom>
-          <a:noFill/>
-          <a:ln/>
-        </p:spPr>
-        <p:txBody>
-          <a:bodyPr wrap="square" lIns="0" tIns="0" rIns="0" bIns="0" rtlCol="0" anchor="t"/>
-          <a:lstStyle/>
-          <a:p>
-            <a:pPr indent="0" marL="0">
-              <a:buNone/>
-            </a:pPr>
-            <a:r>
-              <a:rPr lang="en-US" sz="950" i="1" dirty="0">
+              <a:t>Postgres + pgvector</a:t>
+            </a:r>
+            <a:endParaRPr lang="en-US" sz="1050" dirty="0"/>
+          </a:p>
+        </p:txBody>
+      </p:sp>
+      <p:sp>
+        <p:nvSpPr>
+          <p:cNvPr id="47" name="Text 45"/>
+          <p:cNvSpPr txBox="1"/>
+          <p:nvPr/>
+        </p:nvSpPr>
+        <p:spPr>
+          <a:xfrm>
+            <a:off x="6986016" y="5422392"/>
+            <a:ext cx="1892808" cy="182880"/>
+          </a:xfrm>
+          <a:prstGeom prst="rect">
+            <a:avLst/>
+          </a:prstGeom>
+          <a:noFill/>
+          <a:ln/>
+        </p:spPr>
+        <p:txBody>
+          <a:bodyPr wrap="square" lIns="0" tIns="0" rIns="0" bIns="0" rtlCol="0" anchor="t"/>
+          <a:lstStyle/>
+          <a:p>
+            <a:pPr indent="0" marL="0">
+              <a:buNone/>
+            </a:pPr>
+            <a:r>
+              <a:rPr lang="en-US" sz="900" dirty="0">
                 <a:solidFill>
                   <a:srgbClr val="A39F94"/>
                 </a:solidFill>
@@ -2418,38 +2555,38 @@
                 <a:ea typeface="Arial" pitchFamily="34" charset="-122"/>
                 <a:cs typeface="Arial" pitchFamily="34" charset="-120"/>
               </a:rPr>
-              <a:t>Unmeasured seconds are logged, never counted.</a:t>
-            </a:r>
-            <a:endParaRPr lang="en-US" sz="950" dirty="0"/>
-          </a:p>
-        </p:txBody>
-      </p:sp>
-      <p:sp>
-        <p:nvSpPr>
-          <p:cNvPr id="44" name="Text 42"/>
-          <p:cNvSpPr txBox="1"/>
-          <p:nvPr/>
-        </p:nvSpPr>
-        <p:spPr>
-          <a:xfrm>
-            <a:off x="8412480" y="2633472"/>
-            <a:ext cx="3227832" cy="228600"/>
-          </a:xfrm>
-          <a:prstGeom prst="rect">
-            <a:avLst/>
-          </a:prstGeom>
-          <a:noFill/>
-          <a:ln/>
-        </p:spPr>
-        <p:txBody>
-          <a:bodyPr wrap="square" lIns="0" tIns="0" rIns="0" bIns="0" rtlCol="0" anchor="t"/>
-          <a:lstStyle/>
-          <a:p>
-            <a:pPr indent="0" marL="0">
-              <a:buNone/>
-            </a:pPr>
-            <a:r>
-              <a:rPr lang="en-US" sz="1000" b="1" spc="150" kern="0" dirty="0">
+              <a:t>evidence frames, logo memory</a:t>
+            </a:r>
+            <a:endParaRPr lang="en-US" sz="900" dirty="0"/>
+          </a:p>
+        </p:txBody>
+      </p:sp>
+      <p:sp>
+        <p:nvSpPr>
+          <p:cNvPr id="48" name="Text 46"/>
+          <p:cNvSpPr txBox="1"/>
+          <p:nvPr/>
+        </p:nvSpPr>
+        <p:spPr>
+          <a:xfrm>
+            <a:off x="9372600" y="2340864"/>
+            <a:ext cx="2267712" cy="201168"/>
+          </a:xfrm>
+          <a:prstGeom prst="rect">
+            <a:avLst/>
+          </a:prstGeom>
+          <a:noFill/>
+          <a:ln/>
+        </p:spPr>
+        <p:txBody>
+          <a:bodyPr wrap="square" lIns="0" tIns="0" rIns="0" bIns="0" rtlCol="0" anchor="t"/>
+          <a:lstStyle/>
+          <a:p>
+            <a:pPr indent="0" marL="0">
+              <a:buNone/>
+            </a:pPr>
+            <a:r>
+              <a:rPr lang="en-US" sz="900" b="1" spc="120" kern="0" dirty="0">
                 <a:solidFill>
                   <a:srgbClr val="C9A766"/>
                 </a:solidFill>
@@ -2457,116 +2594,80 @@
                 <a:ea typeface="Arial" pitchFamily="34" charset="-122"/>
                 <a:cs typeface="Arial" pitchFamily="34" charset="-120"/>
               </a:rPr>
-              <a:t>03   EVIDENCE IT WORKS</a:t>
-            </a:r>
-            <a:endParaRPr lang="en-US" sz="1000" dirty="0"/>
-          </a:p>
-        </p:txBody>
-      </p:sp>
-      <p:sp>
-        <p:nvSpPr>
-          <p:cNvPr id="45" name="Text 43"/>
-          <p:cNvSpPr txBox="1"/>
-          <p:nvPr/>
-        </p:nvSpPr>
-        <p:spPr>
-          <a:xfrm>
-            <a:off x="8412480" y="2980944"/>
-            <a:ext cx="1554480" cy="438912"/>
-          </a:xfrm>
-          <a:prstGeom prst="rect">
-            <a:avLst/>
-          </a:prstGeom>
-          <a:noFill/>
-          <a:ln/>
-        </p:spPr>
-        <p:txBody>
-          <a:bodyPr wrap="square" lIns="0" tIns="0" rIns="0" bIns="0" rtlCol="0" anchor="t"/>
-          <a:lstStyle/>
-          <a:p>
-            <a:pPr indent="0" marL="0">
-              <a:buNone/>
-            </a:pPr>
-            <a:r>
-              <a:rPr lang="en-US" sz="2800" dirty="0">
-                <a:solidFill>
-                  <a:srgbClr val="C9A766"/>
+              <a:t>04  EVIDENCE IT WORKS</a:t>
+            </a:r>
+            <a:endParaRPr lang="en-US" sz="900" dirty="0"/>
+          </a:p>
+        </p:txBody>
+      </p:sp>
+      <p:sp>
+        <p:nvSpPr>
+          <p:cNvPr id="49" name="Text 47"/>
+          <p:cNvSpPr txBox="1"/>
+          <p:nvPr/>
+        </p:nvSpPr>
+        <p:spPr>
+          <a:xfrm>
+            <a:off x="9372600" y="2615184"/>
+            <a:ext cx="2267712" cy="530352"/>
+          </a:xfrm>
+          <a:prstGeom prst="rect">
+            <a:avLst/>
+          </a:prstGeom>
+          <a:noFill/>
+          <a:ln/>
+        </p:spPr>
+        <p:txBody>
+          <a:bodyPr wrap="square" lIns="0" tIns="0" rIns="0" bIns="0" rtlCol="0" anchor="t"/>
+          <a:lstStyle/>
+          <a:p>
+            <a:pPr indent="0" marL="0">
+              <a:lnSpc>
+                <a:spcPct val="95000"/>
+              </a:lnSpc>
+              <a:buNone/>
+            </a:pPr>
+            <a:r>
+              <a:rPr lang="en-US" sz="1400" dirty="0">
+                <a:solidFill>
+                  <a:srgbClr val="EEE9DE"/>
                 </a:solidFill>
                 <a:latin typeface="Georgia" pitchFamily="34" charset="0"/>
                 <a:ea typeface="Georgia" pitchFamily="34" charset="-122"/>
                 <a:cs typeface="Georgia" pitchFamily="34" charset="-120"/>
               </a:rPr>
-              <a:t>116</a:t>
-            </a:r>
-            <a:endParaRPr lang="en-US" sz="2800" dirty="0"/>
-          </a:p>
-        </p:txBody>
-      </p:sp>
-      <p:sp>
-        <p:nvSpPr>
-          <p:cNvPr id="46" name="Text 44"/>
-          <p:cNvSpPr txBox="1"/>
-          <p:nvPr/>
-        </p:nvSpPr>
-        <p:spPr>
-          <a:xfrm>
-            <a:off x="8412480" y="3419856"/>
-            <a:ext cx="1536192" cy="310896"/>
-          </a:xfrm>
-          <a:prstGeom prst="rect">
-            <a:avLst/>
-          </a:prstGeom>
-          <a:noFill/>
-          <a:ln/>
-        </p:spPr>
-        <p:txBody>
-          <a:bodyPr wrap="square" lIns="0" tIns="0" rIns="0" bIns="0" rtlCol="0" anchor="t"/>
-          <a:lstStyle/>
-          <a:p>
-            <a:pPr indent="0" marL="0">
-              <a:buNone/>
-            </a:pPr>
-            <a:r>
-              <a:rPr lang="en-US" sz="900" dirty="0">
-                <a:solidFill>
-                  <a:srgbClr val="A39F94"/>
-                </a:solidFill>
-                <a:latin typeface="Arial" pitchFamily="34" charset="0"/>
-                <a:ea typeface="Arial" pitchFamily="34" charset="-122"/>
-                <a:cs typeface="Arial" pitchFamily="34" charset="-120"/>
-              </a:rPr>
-              <a:t>frames read, 81 logo sightings</a:t>
-            </a:r>
-            <a:endParaRPr lang="en-US" sz="900" dirty="0"/>
-          </a:p>
-        </p:txBody>
-      </p:sp>
-      <p:sp>
-        <p:nvSpPr>
-          <p:cNvPr id="47" name="Text 45"/>
-          <p:cNvSpPr txBox="1"/>
-          <p:nvPr/>
-        </p:nvSpPr>
-        <p:spPr>
-          <a:xfrm>
-            <a:off x="10076688" y="2980944"/>
-            <a:ext cx="1554480" cy="438912"/>
-          </a:xfrm>
-          <a:prstGeom prst="rect">
-            <a:avLst/>
-          </a:prstGeom>
-          <a:noFill/>
-          <a:ln/>
-        </p:spPr>
-        <p:txBody>
-          <a:bodyPr wrap="square" lIns="0" tIns="0" rIns="0" bIns="0" rtlCol="0" anchor="t"/>
-          <a:lstStyle/>
-          <a:p>
-            <a:pPr indent="0" marL="0">
-              <a:buNone/>
-            </a:pPr>
-            <a:r>
-              <a:rPr lang="en-US" sz="2800" dirty="0">
+              <a:t>Measured on a real broadcast.</a:t>
+            </a:r>
+            <a:endParaRPr lang="en-US" sz="1400" dirty="0"/>
+          </a:p>
+        </p:txBody>
+      </p:sp>
+      <p:sp>
+        <p:nvSpPr>
+          <p:cNvPr id="50" name="Text 48"/>
+          <p:cNvSpPr txBox="1"/>
+          <p:nvPr/>
+        </p:nvSpPr>
+        <p:spPr>
+          <a:xfrm>
+            <a:off x="9372600" y="3163824"/>
+            <a:ext cx="1143000" cy="402336"/>
+          </a:xfrm>
+          <a:prstGeom prst="rect">
+            <a:avLst/>
+          </a:prstGeom>
+          <a:noFill/>
+          <a:ln/>
+        </p:spPr>
+        <p:txBody>
+          <a:bodyPr wrap="square" lIns="0" tIns="0" rIns="0" bIns="0" rtlCol="0" anchor="t"/>
+          <a:lstStyle/>
+          <a:p>
+            <a:pPr indent="0" marL="0">
+              <a:buNone/>
+            </a:pPr>
+            <a:r>
+              <a:rPr lang="en-US" sz="2400" dirty="0">
                 <a:solidFill>
                   <a:srgbClr val="C9A766"/>
                 </a:solidFill>
@@ -2574,38 +2675,38 @@
                 <a:ea typeface="Georgia" pitchFamily="34" charset="-122"/>
                 <a:cs typeface="Georgia" pitchFamily="34" charset="-120"/>
               </a:rPr>
-              <a:t>0</a:t>
-            </a:r>
-            <a:endParaRPr lang="en-US" sz="2800" dirty="0"/>
-          </a:p>
-        </p:txBody>
-      </p:sp>
-      <p:sp>
-        <p:nvSpPr>
-          <p:cNvPr id="48" name="Text 46"/>
-          <p:cNvSpPr txBox="1"/>
-          <p:nvPr/>
-        </p:nvSpPr>
-        <p:spPr>
-          <a:xfrm>
-            <a:off x="10076688" y="3419856"/>
-            <a:ext cx="1536192" cy="310896"/>
-          </a:xfrm>
-          <a:prstGeom prst="rect">
-            <a:avLst/>
-          </a:prstGeom>
-          <a:noFill/>
-          <a:ln/>
-        </p:spPr>
-        <p:txBody>
-          <a:bodyPr wrap="square" lIns="0" tIns="0" rIns="0" bIns="0" rtlCol="0" anchor="t"/>
-          <a:lstStyle/>
-          <a:p>
-            <a:pPr indent="0" marL="0">
-              <a:buNone/>
-            </a:pPr>
-            <a:r>
-              <a:rPr lang="en-US" sz="900" dirty="0">
+              <a:t>116</a:t>
+            </a:r>
+            <a:endParaRPr lang="en-US" sz="2400" dirty="0"/>
+          </a:p>
+        </p:txBody>
+      </p:sp>
+      <p:sp>
+        <p:nvSpPr>
+          <p:cNvPr id="51" name="Text 49"/>
+          <p:cNvSpPr txBox="1"/>
+          <p:nvPr/>
+        </p:nvSpPr>
+        <p:spPr>
+          <a:xfrm>
+            <a:off x="9372600" y="3566160"/>
+            <a:ext cx="1097280" cy="274320"/>
+          </a:xfrm>
+          <a:prstGeom prst="rect">
+            <a:avLst/>
+          </a:prstGeom>
+          <a:noFill/>
+          <a:ln/>
+        </p:spPr>
+        <p:txBody>
+          <a:bodyPr wrap="square" lIns="0" tIns="0" rIns="0" bIns="0" rtlCol="0" anchor="t"/>
+          <a:lstStyle/>
+          <a:p>
+            <a:pPr indent="0" marL="0">
+              <a:buNone/>
+            </a:pPr>
+            <a:r>
+              <a:rPr lang="en-US" sz="850" dirty="0">
                 <a:solidFill>
                   <a:srgbClr val="A39F94"/>
                 </a:solidFill>
@@ -2613,38 +2714,38 @@
                 <a:ea typeface="Arial" pitchFamily="34" charset="-122"/>
                 <a:cs typeface="Arial" pitchFamily="34" charset="-120"/>
               </a:rPr>
-              <a:t>failed calls, 0 off-list brands</a:t>
-            </a:r>
-            <a:endParaRPr lang="en-US" sz="900" dirty="0"/>
-          </a:p>
-        </p:txBody>
-      </p:sp>
-      <p:sp>
-        <p:nvSpPr>
-          <p:cNvPr id="49" name="Text 47"/>
-          <p:cNvSpPr txBox="1"/>
-          <p:nvPr/>
-        </p:nvSpPr>
-        <p:spPr>
-          <a:xfrm>
-            <a:off x="8412480" y="3767328"/>
-            <a:ext cx="1554480" cy="438912"/>
-          </a:xfrm>
-          <a:prstGeom prst="rect">
-            <a:avLst/>
-          </a:prstGeom>
-          <a:noFill/>
-          <a:ln/>
-        </p:spPr>
-        <p:txBody>
-          <a:bodyPr wrap="square" lIns="0" tIns="0" rIns="0" bIns="0" rtlCol="0" anchor="t"/>
-          <a:lstStyle/>
-          <a:p>
-            <a:pPr indent="0" marL="0">
-              <a:buNone/>
-            </a:pPr>
-            <a:r>
-              <a:rPr lang="en-US" sz="2800" dirty="0">
+              <a:t>frames read</a:t>
+            </a:r>
+            <a:endParaRPr lang="en-US" sz="850" dirty="0"/>
+          </a:p>
+        </p:txBody>
+      </p:sp>
+      <p:sp>
+        <p:nvSpPr>
+          <p:cNvPr id="52" name="Text 50"/>
+          <p:cNvSpPr txBox="1"/>
+          <p:nvPr/>
+        </p:nvSpPr>
+        <p:spPr>
+          <a:xfrm>
+            <a:off x="10561320" y="3163824"/>
+            <a:ext cx="1143000" cy="402336"/>
+          </a:xfrm>
+          <a:prstGeom prst="rect">
+            <a:avLst/>
+          </a:prstGeom>
+          <a:noFill/>
+          <a:ln/>
+        </p:spPr>
+        <p:txBody>
+          <a:bodyPr wrap="square" lIns="0" tIns="0" rIns="0" bIns="0" rtlCol="0" anchor="t"/>
+          <a:lstStyle/>
+          <a:p>
+            <a:pPr indent="0" marL="0">
+              <a:buNone/>
+            </a:pPr>
+            <a:r>
+              <a:rPr lang="en-US" sz="2400" dirty="0">
                 <a:solidFill>
                   <a:srgbClr val="C9A766"/>
                 </a:solidFill>
@@ -2652,38 +2753,38 @@
                 <a:ea typeface="Georgia" pitchFamily="34" charset="-122"/>
                 <a:cs typeface="Georgia" pitchFamily="34" charset="-120"/>
               </a:rPr>
-              <a:t>$0.12</a:t>
-            </a:r>
-            <a:endParaRPr lang="en-US" sz="2800" dirty="0"/>
-          </a:p>
-        </p:txBody>
-      </p:sp>
-      <p:sp>
-        <p:nvSpPr>
-          <p:cNvPr id="50" name="Text 48"/>
-          <p:cNvSpPr txBox="1"/>
-          <p:nvPr/>
-        </p:nvSpPr>
-        <p:spPr>
-          <a:xfrm>
-            <a:off x="8412480" y="4206240"/>
-            <a:ext cx="1536192" cy="310896"/>
-          </a:xfrm>
-          <a:prstGeom prst="rect">
-            <a:avLst/>
-          </a:prstGeom>
-          <a:noFill/>
-          <a:ln/>
-        </p:spPr>
-        <p:txBody>
-          <a:bodyPr wrap="square" lIns="0" tIns="0" rIns="0" bIns="0" rtlCol="0" anchor="t"/>
-          <a:lstStyle/>
-          <a:p>
-            <a:pPr indent="0" marL="0">
-              <a:buNone/>
-            </a:pPr>
-            <a:r>
-              <a:rPr lang="en-US" sz="900" dirty="0">
+              <a:t>0</a:t>
+            </a:r>
+            <a:endParaRPr lang="en-US" sz="2400" dirty="0"/>
+          </a:p>
+        </p:txBody>
+      </p:sp>
+      <p:sp>
+        <p:nvSpPr>
+          <p:cNvPr id="53" name="Text 51"/>
+          <p:cNvSpPr txBox="1"/>
+          <p:nvPr/>
+        </p:nvSpPr>
+        <p:spPr>
+          <a:xfrm>
+            <a:off x="10561320" y="3566160"/>
+            <a:ext cx="1097280" cy="274320"/>
+          </a:xfrm>
+          <a:prstGeom prst="rect">
+            <a:avLst/>
+          </a:prstGeom>
+          <a:noFill/>
+          <a:ln/>
+        </p:spPr>
+        <p:txBody>
+          <a:bodyPr wrap="square" lIns="0" tIns="0" rIns="0" bIns="0" rtlCol="0" anchor="t"/>
+          <a:lstStyle/>
+          <a:p>
+            <a:pPr indent="0" marL="0">
+              <a:buNone/>
+            </a:pPr>
+            <a:r>
+              <a:rPr lang="en-US" sz="850" dirty="0">
                 <a:solidFill>
                   <a:srgbClr val="A39F94"/>
                 </a:solidFill>
@@ -2691,38 +2792,38 @@
                 <a:ea typeface="Arial" pitchFamily="34" charset="-122"/>
                 <a:cs typeface="Arial" pitchFamily="34" charset="-120"/>
               </a:rPr>
-              <a:t>per match-minute</a:t>
-            </a:r>
-            <a:endParaRPr lang="en-US" sz="900" dirty="0"/>
-          </a:p>
-        </p:txBody>
-      </p:sp>
-      <p:sp>
-        <p:nvSpPr>
-          <p:cNvPr id="51" name="Text 49"/>
-          <p:cNvSpPr txBox="1"/>
-          <p:nvPr/>
-        </p:nvSpPr>
-        <p:spPr>
-          <a:xfrm>
-            <a:off x="10076688" y="3767328"/>
-            <a:ext cx="1554480" cy="438912"/>
-          </a:xfrm>
-          <a:prstGeom prst="rect">
-            <a:avLst/>
-          </a:prstGeom>
-          <a:noFill/>
-          <a:ln/>
-        </p:spPr>
-        <p:txBody>
-          <a:bodyPr wrap="square" lIns="0" tIns="0" rIns="0" bIns="0" rtlCol="0" anchor="t"/>
-          <a:lstStyle/>
-          <a:p>
-            <a:pPr indent="0" marL="0">
-              <a:buNone/>
-            </a:pPr>
-            <a:r>
-              <a:rPr lang="en-US" sz="2800" dirty="0">
+              <a:t>errors, off-list brands</a:t>
+            </a:r>
+            <a:endParaRPr lang="en-US" sz="850" dirty="0"/>
+          </a:p>
+        </p:txBody>
+      </p:sp>
+      <p:sp>
+        <p:nvSpPr>
+          <p:cNvPr id="54" name="Text 52"/>
+          <p:cNvSpPr txBox="1"/>
+          <p:nvPr/>
+        </p:nvSpPr>
+        <p:spPr>
+          <a:xfrm>
+            <a:off x="9372600" y="3895344"/>
+            <a:ext cx="1143000" cy="402336"/>
+          </a:xfrm>
+          <a:prstGeom prst="rect">
+            <a:avLst/>
+          </a:prstGeom>
+          <a:noFill/>
+          <a:ln/>
+        </p:spPr>
+        <p:txBody>
+          <a:bodyPr wrap="square" lIns="0" tIns="0" rIns="0" bIns="0" rtlCol="0" anchor="t"/>
+          <a:lstStyle/>
+          <a:p>
+            <a:pPr indent="0" marL="0">
+              <a:buNone/>
+            </a:pPr>
+            <a:r>
+              <a:rPr lang="en-US" sz="2400" dirty="0">
                 <a:solidFill>
                   <a:srgbClr val="C9A766"/>
                 </a:solidFill>
@@ -2730,38 +2831,116 @@
                 <a:ea typeface="Georgia" pitchFamily="34" charset="-122"/>
                 <a:cs typeface="Georgia" pitchFamily="34" charset="-120"/>
               </a:rPr>
+              <a:t>$0.12</a:t>
+            </a:r>
+            <a:endParaRPr lang="en-US" sz="2400" dirty="0"/>
+          </a:p>
+        </p:txBody>
+      </p:sp>
+      <p:sp>
+        <p:nvSpPr>
+          <p:cNvPr id="55" name="Text 53"/>
+          <p:cNvSpPr txBox="1"/>
+          <p:nvPr/>
+        </p:nvSpPr>
+        <p:spPr>
+          <a:xfrm>
+            <a:off x="9372600" y="4297680"/>
+            <a:ext cx="1097280" cy="274320"/>
+          </a:xfrm>
+          <a:prstGeom prst="rect">
+            <a:avLst/>
+          </a:prstGeom>
+          <a:noFill/>
+          <a:ln/>
+        </p:spPr>
+        <p:txBody>
+          <a:bodyPr wrap="square" lIns="0" tIns="0" rIns="0" bIns="0" rtlCol="0" anchor="t"/>
+          <a:lstStyle/>
+          <a:p>
+            <a:pPr indent="0" marL="0">
+              <a:buNone/>
+            </a:pPr>
+            <a:r>
+              <a:rPr lang="en-US" sz="850" dirty="0">
+                <a:solidFill>
+                  <a:srgbClr val="A39F94"/>
+                </a:solidFill>
+                <a:latin typeface="Arial" pitchFamily="34" charset="0"/>
+                <a:ea typeface="Arial" pitchFamily="34" charset="-122"/>
+                <a:cs typeface="Arial" pitchFamily="34" charset="-120"/>
+              </a:rPr>
+              <a:t>per match-minute</a:t>
+            </a:r>
+            <a:endParaRPr lang="en-US" sz="850" dirty="0"/>
+          </a:p>
+        </p:txBody>
+      </p:sp>
+      <p:sp>
+        <p:nvSpPr>
+          <p:cNvPr id="56" name="Text 54"/>
+          <p:cNvSpPr txBox="1"/>
+          <p:nvPr/>
+        </p:nvSpPr>
+        <p:spPr>
+          <a:xfrm>
+            <a:off x="10561320" y="3895344"/>
+            <a:ext cx="1143000" cy="402336"/>
+          </a:xfrm>
+          <a:prstGeom prst="rect">
+            <a:avLst/>
+          </a:prstGeom>
+          <a:noFill/>
+          <a:ln/>
+        </p:spPr>
+        <p:txBody>
+          <a:bodyPr wrap="square" lIns="0" tIns="0" rIns="0" bIns="0" rtlCol="0" anchor="t"/>
+          <a:lstStyle/>
+          <a:p>
+            <a:pPr indent="0" marL="0">
+              <a:buNone/>
+            </a:pPr>
+            <a:r>
+              <a:rPr lang="en-US" sz="2400" dirty="0">
+                <a:solidFill>
+                  <a:srgbClr val="C9A766"/>
+                </a:solidFill>
+                <a:latin typeface="Georgia" pitchFamily="34" charset="0"/>
+                <a:ea typeface="Georgia" pitchFamily="34" charset="-122"/>
+                <a:cs typeface="Georgia" pitchFamily="34" charset="-120"/>
+              </a:rPr>
               <a:t>96%</a:t>
             </a:r>
-            <a:endParaRPr lang="en-US" sz="2800" dirty="0"/>
-          </a:p>
-        </p:txBody>
-      </p:sp>
-      <p:sp>
-        <p:nvSpPr>
-          <p:cNvPr id="52" name="Text 50"/>
-          <p:cNvSpPr txBox="1"/>
-          <p:nvPr/>
-        </p:nvSpPr>
-        <p:spPr>
-          <a:xfrm>
-            <a:off x="10076688" y="4206240"/>
-            <a:ext cx="1536192" cy="310896"/>
-          </a:xfrm>
-          <a:prstGeom prst="rect">
-            <a:avLst/>
-          </a:prstGeom>
-          <a:noFill/>
-          <a:ln/>
-        </p:spPr>
-        <p:txBody>
-          <a:bodyPr wrap="square" lIns="0" tIns="0" rIns="0" bIns="0" rtlCol="0" anchor="t"/>
-          <a:lstStyle/>
-          <a:p>
-            <a:pPr indent="0" marL="0">
-              <a:buNone/>
-            </a:pPr>
-            <a:r>
-              <a:rPr lang="en-US" sz="900" dirty="0">
+            <a:endParaRPr lang="en-US" sz="2400" dirty="0"/>
+          </a:p>
+        </p:txBody>
+      </p:sp>
+      <p:sp>
+        <p:nvSpPr>
+          <p:cNvPr id="57" name="Text 55"/>
+          <p:cNvSpPr txBox="1"/>
+          <p:nvPr/>
+        </p:nvSpPr>
+        <p:spPr>
+          <a:xfrm>
+            <a:off x="10561320" y="4297680"/>
+            <a:ext cx="1097280" cy="274320"/>
+          </a:xfrm>
+          <a:prstGeom prst="rect">
+            <a:avLst/>
+          </a:prstGeom>
+          <a:noFill/>
+          <a:ln/>
+        </p:spPr>
+        <p:txBody>
+          <a:bodyPr wrap="square" lIns="0" tIns="0" rIns="0" bIns="0" rtlCol="0" anchor="t"/>
+          <a:lstStyle/>
+          <a:p>
+            <a:pPr indent="0" marL="0">
+              <a:buNone/>
+            </a:pPr>
+            <a:r>
+              <a:rPr lang="en-US" sz="850" dirty="0">
                 <a:solidFill>
                   <a:srgbClr val="A39F94"/>
                 </a:solidFill>
@@ -2771,36 +2950,36 @@
               </a:rPr>
               <a:t>pilot vs 18–56% OCR*</a:t>
             </a:r>
-            <a:endParaRPr lang="en-US" sz="900" dirty="0"/>
-          </a:p>
-        </p:txBody>
-      </p:sp>
-      <p:sp>
-        <p:nvSpPr>
-          <p:cNvPr id="53" name="Text 51"/>
-          <p:cNvSpPr txBox="1"/>
-          <p:nvPr/>
-        </p:nvSpPr>
-        <p:spPr>
-          <a:xfrm>
-            <a:off x="8412480" y="4645152"/>
-            <a:ext cx="3227832" cy="182880"/>
-          </a:xfrm>
-          <a:prstGeom prst="rect">
-            <a:avLst/>
-          </a:prstGeom>
-          <a:noFill/>
-          <a:ln/>
-        </p:spPr>
-        <p:txBody>
-          <a:bodyPr wrap="square" lIns="0" tIns="0" rIns="0" bIns="0" rtlCol="0" anchor="t"/>
-          <a:lstStyle/>
-          <a:p>
-            <a:pPr indent="0" marL="0">
-              <a:buNone/>
-            </a:pPr>
-            <a:r>
-              <a:rPr lang="en-US" sz="900" b="1" spc="100" kern="0" dirty="0">
+            <a:endParaRPr lang="en-US" sz="850" dirty="0"/>
+          </a:p>
+        </p:txBody>
+      </p:sp>
+      <p:sp>
+        <p:nvSpPr>
+          <p:cNvPr id="58" name="Text 56"/>
+          <p:cNvSpPr txBox="1"/>
+          <p:nvPr/>
+        </p:nvSpPr>
+        <p:spPr>
+          <a:xfrm>
+            <a:off x="9372600" y="4700016"/>
+            <a:ext cx="2267712" cy="182880"/>
+          </a:xfrm>
+          <a:prstGeom prst="rect">
+            <a:avLst/>
+          </a:prstGeom>
+          <a:noFill/>
+          <a:ln/>
+        </p:spPr>
+        <p:txBody>
+          <a:bodyPr wrap="square" lIns="0" tIns="0" rIns="0" bIns="0" rtlCol="0" anchor="t"/>
+          <a:lstStyle/>
+          <a:p>
+            <a:pPr indent="0" marL="0">
+              <a:buNone/>
+            </a:pPr>
+            <a:r>
+              <a:rPr lang="en-US" sz="850" b="1" spc="100" kern="0" dirty="0">
                 <a:solidFill>
                   <a:srgbClr val="6F6C64"/>
                 </a:solidFill>
@@ -2810,20 +2989,20 @@
               </a:rPr>
               <a:t>SCREEN TIME, 58 s UCL SEGMENT</a:t>
             </a:r>
-            <a:endParaRPr lang="en-US" sz="900" dirty="0"/>
-          </a:p>
-        </p:txBody>
-      </p:sp>
-      <p:sp>
-        <p:nvSpPr>
-          <p:cNvPr id="54" name="Text 52"/>
-          <p:cNvSpPr txBox="1"/>
-          <p:nvPr/>
-        </p:nvSpPr>
-        <p:spPr>
-          <a:xfrm>
-            <a:off x="8412480" y="4919472"/>
-            <a:ext cx="868680" cy="164592"/>
+            <a:endParaRPr lang="en-US" sz="850" dirty="0"/>
+          </a:p>
+        </p:txBody>
+      </p:sp>
+      <p:sp>
+        <p:nvSpPr>
+          <p:cNvPr id="59" name="Text 57"/>
+          <p:cNvSpPr txBox="1"/>
+          <p:nvPr/>
+        </p:nvSpPr>
+        <p:spPr>
+          <a:xfrm>
+            <a:off x="9372600" y="4956048"/>
+            <a:ext cx="749808" cy="164592"/>
           </a:xfrm>
           <a:prstGeom prst="rect">
             <a:avLst/>
@@ -2839,7 +3018,7 @@
               <a:buNone/>
             </a:pPr>
             <a:r>
-              <a:rPr lang="en-US" sz="900" dirty="0">
+              <a:rPr lang="en-US" sz="850" dirty="0">
                 <a:solidFill>
                   <a:srgbClr val="EEE9DE"/>
                 </a:solidFill>
@@ -2849,20 +3028,20 @@
               </a:rPr>
               <a:t>FedEx</a:t>
             </a:r>
-            <a:endParaRPr lang="en-US" sz="900" dirty="0"/>
-          </a:p>
-        </p:txBody>
-      </p:sp>
-      <p:sp>
-        <p:nvSpPr>
-          <p:cNvPr id="55" name="Shape 53"/>
+            <a:endParaRPr lang="en-US" sz="850" dirty="0"/>
+          </a:p>
+        </p:txBody>
+      </p:sp>
+      <p:sp>
+        <p:nvSpPr>
+          <p:cNvPr id="60" name="Shape 58"/>
           <p:cNvSpPr/>
           <p:nvPr/>
         </p:nvSpPr>
         <p:spPr>
           <a:xfrm>
-            <a:off x="9326880" y="4965192"/>
-            <a:ext cx="1828800" cy="73152"/>
+            <a:off x="10149840" y="5001768"/>
+            <a:ext cx="1051560" cy="73152"/>
           </a:xfrm>
           <a:prstGeom prst="rect">
             <a:avLst/>
@@ -2875,14 +3054,14 @@
       </p:sp>
       <p:sp>
         <p:nvSpPr>
-          <p:cNvPr id="56" name="Shape 54"/>
+          <p:cNvPr id="61" name="Shape 59"/>
           <p:cNvSpPr/>
           <p:nvPr/>
         </p:nvSpPr>
         <p:spPr>
           <a:xfrm>
-            <a:off x="9326880" y="4965192"/>
-            <a:ext cx="1828800" cy="73152"/>
+            <a:off x="10149840" y="5001768"/>
+            <a:ext cx="1051560" cy="73152"/>
           </a:xfrm>
           <a:prstGeom prst="rect">
             <a:avLst/>
@@ -2895,14 +3074,14 @@
       </p:sp>
       <p:sp>
         <p:nvSpPr>
-          <p:cNvPr id="57" name="Text 55"/>
-          <p:cNvSpPr txBox="1"/>
-          <p:nvPr/>
-        </p:nvSpPr>
-        <p:spPr>
-          <a:xfrm>
-            <a:off x="11228832" y="4919472"/>
-            <a:ext cx="411480" cy="164592"/>
+          <p:cNvPr id="62" name="Text 60"/>
+          <p:cNvSpPr txBox="1"/>
+          <p:nvPr/>
+        </p:nvSpPr>
+        <p:spPr>
+          <a:xfrm>
+            <a:off x="11247120" y="4956048"/>
+            <a:ext cx="393192" cy="164592"/>
           </a:xfrm>
           <a:prstGeom prst="rect">
             <a:avLst/>
@@ -2918,7 +3097,7 @@
               <a:buNone/>
             </a:pPr>
             <a:r>
-              <a:rPr lang="en-US" sz="900" dirty="0">
+              <a:rPr lang="en-US" sz="850" dirty="0">
                 <a:solidFill>
                   <a:srgbClr val="A39F94"/>
                 </a:solidFill>
@@ -2928,20 +3107,20 @@
               </a:rPr>
               <a:t>20.0 s</a:t>
             </a:r>
-            <a:endParaRPr lang="en-US" sz="900" dirty="0"/>
-          </a:p>
-        </p:txBody>
-      </p:sp>
-      <p:sp>
-        <p:nvSpPr>
-          <p:cNvPr id="58" name="Text 56"/>
-          <p:cNvSpPr txBox="1"/>
-          <p:nvPr/>
-        </p:nvSpPr>
-        <p:spPr>
-          <a:xfrm>
-            <a:off x="8412480" y="5148072"/>
-            <a:ext cx="868680" cy="164592"/>
+            <a:endParaRPr lang="en-US" sz="850" dirty="0"/>
+          </a:p>
+        </p:txBody>
+      </p:sp>
+      <p:sp>
+        <p:nvSpPr>
+          <p:cNvPr id="63" name="Text 61"/>
+          <p:cNvSpPr txBox="1"/>
+          <p:nvPr/>
+        </p:nvSpPr>
+        <p:spPr>
+          <a:xfrm>
+            <a:off x="9372600" y="5175504"/>
+            <a:ext cx="749808" cy="164592"/>
           </a:xfrm>
           <a:prstGeom prst="rect">
             <a:avLst/>
@@ -2957,7 +3136,7 @@
               <a:buNone/>
             </a:pPr>
             <a:r>
-              <a:rPr lang="en-US" sz="900" dirty="0">
+              <a:rPr lang="en-US" sz="850" dirty="0">
                 <a:solidFill>
                   <a:srgbClr val="EEE9DE"/>
                 </a:solidFill>
@@ -2967,20 +3146,20 @@
               </a:rPr>
               <a:t>PlayStation</a:t>
             </a:r>
-            <a:endParaRPr lang="en-US" sz="900" dirty="0"/>
-          </a:p>
-        </p:txBody>
-      </p:sp>
-      <p:sp>
-        <p:nvSpPr>
-          <p:cNvPr id="59" name="Shape 57"/>
+            <a:endParaRPr lang="en-US" sz="850" dirty="0"/>
+          </a:p>
+        </p:txBody>
+      </p:sp>
+      <p:sp>
+        <p:nvSpPr>
+          <p:cNvPr id="64" name="Shape 62"/>
           <p:cNvSpPr/>
           <p:nvPr/>
         </p:nvSpPr>
         <p:spPr>
           <a:xfrm>
-            <a:off x="9326880" y="5193792"/>
-            <a:ext cx="1828800" cy="73152"/>
+            <a:off x="10149840" y="5221224"/>
+            <a:ext cx="1051560" cy="73152"/>
           </a:xfrm>
           <a:prstGeom prst="rect">
             <a:avLst/>
@@ -2993,14 +3172,14 @@
       </p:sp>
       <p:sp>
         <p:nvSpPr>
-          <p:cNvPr id="60" name="Shape 58"/>
+          <p:cNvPr id="65" name="Shape 63"/>
           <p:cNvSpPr/>
           <p:nvPr/>
         </p:nvSpPr>
         <p:spPr>
           <a:xfrm>
-            <a:off x="9326880" y="5193792"/>
-            <a:ext cx="1097280" cy="73152"/>
+            <a:off x="10149840" y="5221224"/>
+            <a:ext cx="630936" cy="73152"/>
           </a:xfrm>
           <a:prstGeom prst="rect">
             <a:avLst/>
@@ -3013,14 +3192,14 @@
       </p:sp>
       <p:sp>
         <p:nvSpPr>
-          <p:cNvPr id="61" name="Text 59"/>
-          <p:cNvSpPr txBox="1"/>
-          <p:nvPr/>
-        </p:nvSpPr>
-        <p:spPr>
-          <a:xfrm>
-            <a:off x="11228832" y="5148072"/>
-            <a:ext cx="411480" cy="164592"/>
+          <p:cNvPr id="66" name="Text 64"/>
+          <p:cNvSpPr txBox="1"/>
+          <p:nvPr/>
+        </p:nvSpPr>
+        <p:spPr>
+          <a:xfrm>
+            <a:off x="11247120" y="5175504"/>
+            <a:ext cx="393192" cy="164592"/>
           </a:xfrm>
           <a:prstGeom prst="rect">
             <a:avLst/>
@@ -3036,7 +3215,7 @@
               <a:buNone/>
             </a:pPr>
             <a:r>
-              <a:rPr lang="en-US" sz="900" dirty="0">
+              <a:rPr lang="en-US" sz="850" dirty="0">
                 <a:solidFill>
                   <a:srgbClr val="A39F94"/>
                 </a:solidFill>
@@ -3046,20 +3225,20 @@
               </a:rPr>
               <a:t>12.0 s</a:t>
             </a:r>
-            <a:endParaRPr lang="en-US" sz="900" dirty="0"/>
-          </a:p>
-        </p:txBody>
-      </p:sp>
-      <p:sp>
-        <p:nvSpPr>
-          <p:cNvPr id="62" name="Text 60"/>
-          <p:cNvSpPr txBox="1"/>
-          <p:nvPr/>
-        </p:nvSpPr>
-        <p:spPr>
-          <a:xfrm>
-            <a:off x="8412480" y="5376672"/>
-            <a:ext cx="868680" cy="164592"/>
+            <a:endParaRPr lang="en-US" sz="850" dirty="0"/>
+          </a:p>
+        </p:txBody>
+      </p:sp>
+      <p:sp>
+        <p:nvSpPr>
+          <p:cNvPr id="67" name="Text 65"/>
+          <p:cNvSpPr txBox="1"/>
+          <p:nvPr/>
+        </p:nvSpPr>
+        <p:spPr>
+          <a:xfrm>
+            <a:off x="9372600" y="5394960"/>
+            <a:ext cx="749808" cy="164592"/>
           </a:xfrm>
           <a:prstGeom prst="rect">
             <a:avLst/>
@@ -3075,7 +3254,7 @@
               <a:buNone/>
             </a:pPr>
             <a:r>
-              <a:rPr lang="en-US" sz="900" dirty="0">
+              <a:rPr lang="en-US" sz="850" dirty="0">
                 <a:solidFill>
                   <a:srgbClr val="EEE9DE"/>
                 </a:solidFill>
@@ -3085,20 +3264,20 @@
               </a:rPr>
               <a:t>Heineken</a:t>
             </a:r>
-            <a:endParaRPr lang="en-US" sz="900" dirty="0"/>
-          </a:p>
-        </p:txBody>
-      </p:sp>
-      <p:sp>
-        <p:nvSpPr>
-          <p:cNvPr id="63" name="Shape 61"/>
+            <a:endParaRPr lang="en-US" sz="850" dirty="0"/>
+          </a:p>
+        </p:txBody>
+      </p:sp>
+      <p:sp>
+        <p:nvSpPr>
+          <p:cNvPr id="68" name="Shape 66"/>
           <p:cNvSpPr/>
           <p:nvPr/>
         </p:nvSpPr>
         <p:spPr>
           <a:xfrm>
-            <a:off x="9326880" y="5422392"/>
-            <a:ext cx="1828800" cy="73152"/>
+            <a:off x="10149840" y="5440680"/>
+            <a:ext cx="1051560" cy="73152"/>
           </a:xfrm>
           <a:prstGeom prst="rect">
             <a:avLst/>
@@ -3111,14 +3290,14 @@
       </p:sp>
       <p:sp>
         <p:nvSpPr>
-          <p:cNvPr id="64" name="Shape 62"/>
+          <p:cNvPr id="69" name="Shape 67"/>
           <p:cNvSpPr/>
           <p:nvPr/>
         </p:nvSpPr>
         <p:spPr>
           <a:xfrm>
-            <a:off x="9326880" y="5422392"/>
-            <a:ext cx="594360" cy="73152"/>
+            <a:off x="10149840" y="5440680"/>
+            <a:ext cx="341757" cy="73152"/>
           </a:xfrm>
           <a:prstGeom prst="rect">
             <a:avLst/>
@@ -3131,14 +3310,14 @@
       </p:sp>
       <p:sp>
         <p:nvSpPr>
-          <p:cNvPr id="65" name="Text 63"/>
-          <p:cNvSpPr txBox="1"/>
-          <p:nvPr/>
-        </p:nvSpPr>
-        <p:spPr>
-          <a:xfrm>
-            <a:off x="11228832" y="5376672"/>
-            <a:ext cx="411480" cy="164592"/>
+          <p:cNvPr id="70" name="Text 68"/>
+          <p:cNvSpPr txBox="1"/>
+          <p:nvPr/>
+        </p:nvSpPr>
+        <p:spPr>
+          <a:xfrm>
+            <a:off x="11247120" y="5394960"/>
+            <a:ext cx="393192" cy="164592"/>
           </a:xfrm>
           <a:prstGeom prst="rect">
             <a:avLst/>
@@ -3154,7 +3333,7 @@
               <a:buNone/>
             </a:pPr>
             <a:r>
-              <a:rPr lang="en-US" sz="900" dirty="0">
+              <a:rPr lang="en-US" sz="850" dirty="0">
                 <a:solidFill>
                   <a:srgbClr val="A39F94"/>
                 </a:solidFill>
@@ -3164,20 +3343,20 @@
               </a:rPr>
               <a:t>6.5 s</a:t>
             </a:r>
-            <a:endParaRPr lang="en-US" sz="900" dirty="0"/>
-          </a:p>
-        </p:txBody>
-      </p:sp>
-      <p:sp>
-        <p:nvSpPr>
-          <p:cNvPr id="66" name="Text 64"/>
-          <p:cNvSpPr txBox="1"/>
-          <p:nvPr/>
-        </p:nvSpPr>
-        <p:spPr>
-          <a:xfrm>
-            <a:off x="8412480" y="5605272"/>
-            <a:ext cx="868680" cy="164592"/>
+            <a:endParaRPr lang="en-US" sz="850" dirty="0"/>
+          </a:p>
+        </p:txBody>
+      </p:sp>
+      <p:sp>
+        <p:nvSpPr>
+          <p:cNvPr id="71" name="Text 69"/>
+          <p:cNvSpPr txBox="1"/>
+          <p:nvPr/>
+        </p:nvSpPr>
+        <p:spPr>
+          <a:xfrm>
+            <a:off x="9372600" y="5614416"/>
+            <a:ext cx="749808" cy="164592"/>
           </a:xfrm>
           <a:prstGeom prst="rect">
             <a:avLst/>
@@ -3193,7 +3372,7 @@
               <a:buNone/>
             </a:pPr>
             <a:r>
-              <a:rPr lang="en-US" sz="900" dirty="0">
+              <a:rPr lang="en-US" sz="850" dirty="0">
                 <a:solidFill>
                   <a:srgbClr val="EEE9DE"/>
                 </a:solidFill>
@@ -3203,20 +3382,20 @@
               </a:rPr>
               <a:t>Mastercard</a:t>
             </a:r>
-            <a:endParaRPr lang="en-US" sz="900" dirty="0"/>
-          </a:p>
-        </p:txBody>
-      </p:sp>
-      <p:sp>
-        <p:nvSpPr>
-          <p:cNvPr id="67" name="Shape 65"/>
+            <a:endParaRPr lang="en-US" sz="850" dirty="0"/>
+          </a:p>
+        </p:txBody>
+      </p:sp>
+      <p:sp>
+        <p:nvSpPr>
+          <p:cNvPr id="72" name="Shape 70"/>
           <p:cNvSpPr/>
           <p:nvPr/>
         </p:nvSpPr>
         <p:spPr>
           <a:xfrm>
-            <a:off x="9326880" y="5650992"/>
-            <a:ext cx="1828800" cy="73152"/>
+            <a:off x="10149840" y="5660136"/>
+            <a:ext cx="1051560" cy="73152"/>
           </a:xfrm>
           <a:prstGeom prst="rect">
             <a:avLst/>
@@ -3229,14 +3408,14 @@
       </p:sp>
       <p:sp>
         <p:nvSpPr>
-          <p:cNvPr id="68" name="Shape 66"/>
+          <p:cNvPr id="73" name="Shape 71"/>
           <p:cNvSpPr/>
           <p:nvPr/>
         </p:nvSpPr>
         <p:spPr>
           <a:xfrm>
-            <a:off x="9326880" y="5650992"/>
-            <a:ext cx="91440" cy="73152"/>
+            <a:off x="10149840" y="5660136"/>
+            <a:ext cx="52578" cy="73152"/>
           </a:xfrm>
           <a:prstGeom prst="rect">
             <a:avLst/>
@@ -3249,14 +3428,14 @@
       </p:sp>
       <p:sp>
         <p:nvSpPr>
-          <p:cNvPr id="69" name="Text 67"/>
-          <p:cNvSpPr txBox="1"/>
-          <p:nvPr/>
-        </p:nvSpPr>
-        <p:spPr>
-          <a:xfrm>
-            <a:off x="11228832" y="5605272"/>
-            <a:ext cx="411480" cy="164592"/>
+          <p:cNvPr id="74" name="Text 72"/>
+          <p:cNvSpPr txBox="1"/>
+          <p:nvPr/>
+        </p:nvSpPr>
+        <p:spPr>
+          <a:xfrm>
+            <a:off x="11247120" y="5614416"/>
+            <a:ext cx="393192" cy="164592"/>
           </a:xfrm>
           <a:prstGeom prst="rect">
             <a:avLst/>
@@ -3272,7 +3451,7 @@
               <a:buNone/>
             </a:pPr>
             <a:r>
-              <a:rPr lang="en-US" sz="900" dirty="0">
+              <a:rPr lang="en-US" sz="850" dirty="0">
                 <a:solidFill>
                   <a:srgbClr val="A39F94"/>
                 </a:solidFill>
@@ -3282,13 +3461,13 @@
               </a:rPr>
               <a:t>1.0 s</a:t>
             </a:r>
-            <a:endParaRPr lang="en-US" sz="900" dirty="0"/>
-          </a:p>
-        </p:txBody>
-      </p:sp>
-      <p:sp>
-        <p:nvSpPr>
-          <p:cNvPr id="70" name="Shape 68"/>
+            <a:endParaRPr lang="en-US" sz="850" dirty="0"/>
+          </a:p>
+        </p:txBody>
+      </p:sp>
+      <p:sp>
+        <p:nvSpPr>
+          <p:cNvPr id="75" name="Shape 73"/>
           <p:cNvSpPr/>
           <p:nvPr/>
         </p:nvSpPr>
@@ -3311,14 +3490,14 @@
       </p:sp>
       <p:sp>
         <p:nvSpPr>
-          <p:cNvPr id="71" name="Text 69"/>
+          <p:cNvPr id="76" name="Text 74"/>
           <p:cNvSpPr txBox="1"/>
           <p:nvPr/>
         </p:nvSpPr>
         <p:spPr>
           <a:xfrm>
             <a:off x="548640" y="6144768"/>
-            <a:ext cx="8595360" cy="274320"/>
+            <a:ext cx="9326880" cy="274320"/>
           </a:xfrm>
           <a:prstGeom prst="rect">
             <a:avLst/>
@@ -3334,7 +3513,7 @@
               <a:buNone/>
             </a:pPr>
             <a:r>
-              <a:rPr lang="en-US" sz="1000" b="1" spc="100" kern="0" dirty="0">
+              <a:rPr lang="en-US" sz="900" b="1" spc="120" kern="0" dirty="0">
                 <a:solidFill>
                   <a:srgbClr val="C9A766"/>
                 </a:solidFill>
@@ -3342,13 +3521,13 @@
                 <a:ea typeface="Arial" pitchFamily="34" charset="-122"/>
                 <a:cs typeface="Arial" pitchFamily="34" charset="-120"/>
               </a:rPr>
-              <a:t>WHY US  </a:t>
-            </a:r>
-            <a:pPr indent="0" marL="0">
-              <a:buNone/>
-            </a:pPr>
-            <a:r>
-              <a:rPr lang="en-US" sz="1300" i="1" dirty="0">
+              <a:t>05  EXECUTION &amp; PITCH   </a:t>
+            </a:r>
+            <a:pPr indent="0" marL="0">
+              <a:buNone/>
+            </a:pPr>
+            <a:r>
+              <a:rPr lang="en-US" sz="1250" i="1" dirty="0">
                 <a:solidFill>
                   <a:srgbClr val="EEE9DE"/>
                 </a:solidFill>
@@ -3356,15 +3535,15 @@
                 <a:ea typeface="Georgia" pitchFamily="34" charset="-122"/>
                 <a:cs typeface="Georgia" pitchFamily="34" charset="-120"/>
               </a:rPr>
-              <a:t>Not a count after the match: a live ledger where every second has a frame, a confidence and a cost.</a:t>
-            </a:r>
-            <a:endParaRPr lang="en-US" sz="1000" dirty="0"/>
-          </a:p>
-        </p:txBody>
-      </p:sp>
-      <p:sp>
-        <p:nvSpPr>
-          <p:cNvPr id="72" name="Text 70"/>
+              <a:t>Live on Aiven Runtime. Not a count after the match: proof for every second.</a:t>
+            </a:r>
+            <a:endParaRPr lang="en-US" sz="900" dirty="0"/>
+          </a:p>
+        </p:txBody>
+      </p:sp>
+      <p:sp>
+        <p:nvSpPr>
+          <p:cNvPr id="77" name="Text 75"/>
           <p:cNvSpPr txBox="1"/>
           <p:nvPr/>
         </p:nvSpPr>
@@ -3395,7 +3574,7 @@
                 <a:ea typeface="Arial" pitchFamily="34" charset="-122"/>
                 <a:cs typeface="Arial" pitchFamily="34" charset="-120"/>
               </a:rPr>
-              <a:t>*Pilot on our earlier prototype, partly circular; independent labelling next. Evidence: recorded broadcast replayed through the live pipeline on Aiven Runtime. Repo: github.com/kaktamsdengami/accel_hack-</a:t>
+              <a:t>*Pilot on our earlier prototype, partly circular; independent labelling next. Evidence: recorded broadcast replayed through the live pipeline. Repo: github.com/kaktamsdengami/accel_hack-</a:t>
             </a:r>
             <a:endParaRPr lang="en-US" sz="800" dirty="0"/>
           </a:p>
@@ -3403,7 +3582,7 @@
       </p:sp>
       <p:sp>
         <p:nvSpPr>
-          <p:cNvPr id="73" name="Text 71">
+          <p:cNvPr id="78" name="Text 76">
             <a:hlinkClick r:id="rId1" tooltip=""/>
           </p:cNvPr>
           <p:cNvSpPr txBox="1"/>
@@ -3411,8 +3590,8 @@
         </p:nvSpPr>
         <p:spPr>
           <a:xfrm>
-            <a:off x="9509760" y="6144768"/>
-            <a:ext cx="2130552" cy="274320"/>
+            <a:off x="9966960" y="6144768"/>
+            <a:ext cx="1673352" cy="274320"/>
           </a:xfrm>
           <a:prstGeom prst="rect">
             <a:avLst/>

</xml_diff>

<commit_message>
Pitch slide: one column per judging criterion, product-first headline (#60)
Co-authored-by: Claude Opus 5.5 <noreply@anthropic.com>
</commit_message>
<xml_diff>
--- a/docs/pitch-slide.pptx
+++ b/docs/pitch-slide.pptx
@@ -961,8 +961,8 @@
         </p:nvSpPr>
         <p:spPr>
           <a:xfrm>
-            <a:off x="548640" y="777240"/>
-            <a:ext cx="8686800" cy="960120"/>
+            <a:off x="548640" y="749808"/>
+            <a:ext cx="11091672" cy="868680"/>
           </a:xfrm>
           <a:prstGeom prst="rect">
             <a:avLst/>
@@ -981,7 +981,7 @@
               <a:buNone/>
             </a:pPr>
             <a:r>
-              <a:rPr lang="en-US" sz="2800" dirty="0">
+              <a:rPr lang="en-US" sz="2600" dirty="0">
                 <a:solidFill>
                   <a:srgbClr val="EEE9DE"/>
                 </a:solidFill>
@@ -989,9 +989,9 @@
                 <a:ea typeface="Georgia" pitchFamily="34" charset="-122"/>
                 <a:cs typeface="Georgia" pitchFamily="34" charset="-120"/>
               </a:rPr>
-              <a:t>Sponsors pay millions for screen time.</a:t>
-            </a:r>
-            <a:endParaRPr lang="en-US" sz="2800" dirty="0"/>
+              <a:t>AI agents that measure every second a sponsor is on screen.</a:t>
+            </a:r>
+            <a:endParaRPr lang="en-US" sz="2600" dirty="0"/>
           </a:p>
           <a:p>
             <a:pPr indent="0" marL="0">
@@ -1001,7 +1001,7 @@
               <a:buNone/>
             </a:pPr>
             <a:r>
-              <a:rPr lang="en-US" sz="2800" dirty="0">
+              <a:rPr lang="en-US" sz="2600" dirty="0">
                 <a:solidFill>
                   <a:srgbClr val="EEE9DE"/>
                 </a:solidFill>
@@ -1009,9 +1009,9 @@
                 <a:ea typeface="Georgia" pitchFamily="34" charset="-122"/>
                 <a:cs typeface="Georgia" pitchFamily="34" charset="-120"/>
               </a:rPr>
-              <a:t>No club can prove how much they got.</a:t>
-            </a:r>
-            <a:endParaRPr lang="en-US" sz="2800" dirty="0"/>
+              <a:t>Live, per surface, with the frame as proof.</a:t>
+            </a:r>
+            <a:endParaRPr lang="en-US" sz="2600" dirty="0"/>
           </a:p>
         </p:txBody>
       </p:sp>
@@ -1023,8 +1023,8 @@
         </p:nvSpPr>
         <p:spPr>
           <a:xfrm>
-            <a:off x="548640" y="1828800"/>
-            <a:ext cx="8961120" cy="457200"/>
+            <a:off x="548640" y="1691640"/>
+            <a:ext cx="11091672" cy="274320"/>
           </a:xfrm>
           <a:prstGeom prst="rect">
             <a:avLst/>
@@ -1062,7 +1062,7 @@
                 <a:ea typeface="Arial" pitchFamily="34" charset="-122"/>
                 <a:cs typeface="Arial" pitchFamily="34" charset="-120"/>
               </a:rPr>
-              <a:t> is a team of AI agents that watches the broadcast and logs every second each sponsor is on screen, per surface, with the frame as proof.</a:t>
+              <a:t> turns a football broadcast into an auditable sponsor ledger that clubs bring to every renewal.</a:t>
             </a:r>
             <a:endParaRPr lang="en-US" sz="1400" dirty="0"/>
           </a:p>
@@ -1076,7 +1076,7 @@
         </p:nvSpPr>
         <p:spPr>
           <a:xfrm>
-            <a:off x="548640" y="2450592"/>
+            <a:off x="548640" y="2176272"/>
             <a:ext cx="11091672" cy="0"/>
           </a:xfrm>
           <a:prstGeom prst="line">
@@ -1099,8 +1099,8 @@
         </p:nvSpPr>
         <p:spPr>
           <a:xfrm>
-            <a:off x="4251960" y="2633472"/>
-            <a:ext cx="0" cy="3236976"/>
+            <a:off x="3520440" y="2340864"/>
+            <a:ext cx="0" cy="3529584"/>
           </a:xfrm>
           <a:prstGeom prst="line">
             <a:avLst/>
@@ -1122,8 +1122,8 @@
         </p:nvSpPr>
         <p:spPr>
           <a:xfrm>
-            <a:off x="8229600" y="2633472"/>
-            <a:ext cx="0" cy="3236976"/>
+            <a:off x="6675120" y="2340864"/>
+            <a:ext cx="0" cy="3529584"/>
           </a:xfrm>
           <a:prstGeom prst="line">
             <a:avLst/>
@@ -1139,30 +1139,53 @@
       </p:sp>
       <p:sp>
         <p:nvSpPr>
-          <p:cNvPr id="9" name="Text 7"/>
-          <p:cNvSpPr txBox="1"/>
-          <p:nvPr/>
-        </p:nvSpPr>
-        <p:spPr>
-          <a:xfrm>
-            <a:off x="548640" y="2633472"/>
-            <a:ext cx="3520440" cy="228600"/>
-          </a:xfrm>
-          <a:prstGeom prst="rect">
-            <a:avLst/>
-          </a:prstGeom>
-          <a:noFill/>
-          <a:ln/>
-        </p:spPr>
-        <p:txBody>
-          <a:bodyPr wrap="square" lIns="0" tIns="0" rIns="0" bIns="0" rtlCol="0" anchor="t"/>
-          <a:lstStyle/>
-          <a:p>
-            <a:pPr indent="0" marL="0">
-              <a:buNone/>
-            </a:pPr>
-            <a:r>
-              <a:rPr lang="en-US" sz="1000" b="1" spc="150" kern="0" dirty="0">
+          <p:cNvPr id="9" name="Shape 7"/>
+          <p:cNvSpPr/>
+          <p:nvPr/>
+        </p:nvSpPr>
+        <p:spPr>
+          <a:xfrm>
+            <a:off x="9189720" y="2340864"/>
+            <a:ext cx="0" cy="3529584"/>
+          </a:xfrm>
+          <a:prstGeom prst="line">
+            <a:avLst/>
+          </a:prstGeom>
+          <a:noFill/>
+          <a:ln w="9525">
+            <a:solidFill>
+              <a:srgbClr val="2E302A"/>
+            </a:solidFill>
+            <a:prstDash val="solid"/>
+          </a:ln>
+        </p:spPr>
+      </p:sp>
+      <p:sp>
+        <p:nvSpPr>
+          <p:cNvPr id="10" name="Text 8"/>
+          <p:cNvSpPr txBox="1"/>
+          <p:nvPr/>
+        </p:nvSpPr>
+        <p:spPr>
+          <a:xfrm>
+            <a:off x="548640" y="2340864"/>
+            <a:ext cx="2788920" cy="201168"/>
+          </a:xfrm>
+          <a:prstGeom prst="rect">
+            <a:avLst/>
+          </a:prstGeom>
+          <a:noFill/>
+          <a:ln/>
+        </p:spPr>
+        <p:txBody>
+          <a:bodyPr wrap="square" lIns="0" tIns="0" rIns="0" bIns="0" rtlCol="0" anchor="t"/>
+          <a:lstStyle/>
+          <a:p>
+            <a:pPr indent="0" marL="0">
+              <a:buNone/>
+            </a:pPr>
+            <a:r>
+              <a:rPr lang="en-US" sz="900" b="1" spc="120" kern="0" dirty="0">
                 <a:solidFill>
                   <a:srgbClr val="C9A766"/>
                 </a:solidFill>
@@ -1170,61 +1193,415 @@
                 <a:ea typeface="Arial" pitchFamily="34" charset="-122"/>
                 <a:cs typeface="Arial" pitchFamily="34" charset="-120"/>
               </a:rPr>
-              <a:t>01   THE CUSTOMER</a:t>
-            </a:r>
-            <a:endParaRPr lang="en-US" sz="1000" dirty="0"/>
-          </a:p>
-        </p:txBody>
-      </p:sp>
-      <p:sp>
-        <p:nvSpPr>
-          <p:cNvPr id="10" name="Text 8"/>
-          <p:cNvSpPr txBox="1"/>
-          <p:nvPr/>
-        </p:nvSpPr>
-        <p:spPr>
-          <a:xfrm>
-            <a:off x="548640" y="2999232"/>
-            <a:ext cx="3520440" cy="182880"/>
-          </a:xfrm>
-          <a:prstGeom prst="rect">
-            <a:avLst/>
-          </a:prstGeom>
-          <a:noFill/>
-          <a:ln/>
-        </p:spPr>
-        <p:txBody>
-          <a:bodyPr wrap="square" lIns="0" tIns="0" rIns="0" bIns="0" rtlCol="0" anchor="t"/>
-          <a:lstStyle/>
-          <a:p>
-            <a:pPr indent="0" marL="0">
-              <a:buNone/>
-            </a:pPr>
-            <a:r>
-              <a:rPr lang="en-US" sz="950" b="1" spc="100" kern="0" dirty="0">
+              <a:t>01  CUSTOMER PROBLEM &amp; VALUE</a:t>
+            </a:r>
+            <a:endParaRPr lang="en-US" sz="900" dirty="0"/>
+          </a:p>
+        </p:txBody>
+      </p:sp>
+      <p:sp>
+        <p:nvSpPr>
+          <p:cNvPr id="11" name="Text 9"/>
+          <p:cNvSpPr txBox="1"/>
+          <p:nvPr/>
+        </p:nvSpPr>
+        <p:spPr>
+          <a:xfrm>
+            <a:off x="548640" y="2615184"/>
+            <a:ext cx="2788920" cy="530352"/>
+          </a:xfrm>
+          <a:prstGeom prst="rect">
+            <a:avLst/>
+          </a:prstGeom>
+          <a:noFill/>
+          <a:ln/>
+        </p:spPr>
+        <p:txBody>
+          <a:bodyPr wrap="square" lIns="0" tIns="0" rIns="0" bIns="0" rtlCol="0" anchor="t"/>
+          <a:lstStyle/>
+          <a:p>
+            <a:pPr indent="0" marL="0">
+              <a:lnSpc>
+                <a:spcPct val="95000"/>
+              </a:lnSpc>
+              <a:buNone/>
+            </a:pPr>
+            <a:r>
+              <a:rPr lang="en-US" sz="1400" dirty="0">
                 <a:solidFill>
                   <a:srgbClr val="EEE9DE"/>
                 </a:solidFill>
+                <a:latin typeface="Georgia" pitchFamily="34" charset="0"/>
+                <a:ea typeface="Georgia" pitchFamily="34" charset="-122"/>
+                <a:cs typeface="Georgia" pitchFamily="34" charset="-120"/>
+              </a:rPr>
+              <a:t>A buyer with a deadline: the sponsor renewal.</a:t>
+            </a:r>
+            <a:endParaRPr lang="en-US" sz="1400" dirty="0"/>
+          </a:p>
+        </p:txBody>
+      </p:sp>
+      <p:sp>
+        <p:nvSpPr>
+          <p:cNvPr id="12" name="Text 10"/>
+          <p:cNvSpPr txBox="1"/>
+          <p:nvPr/>
+        </p:nvSpPr>
+        <p:spPr>
+          <a:xfrm>
+            <a:off x="548640" y="3236976"/>
+            <a:ext cx="2788920" cy="164592"/>
+          </a:xfrm>
+          <a:prstGeom prst="rect">
+            <a:avLst/>
+          </a:prstGeom>
+          <a:noFill/>
+          <a:ln/>
+        </p:spPr>
+        <p:txBody>
+          <a:bodyPr wrap="square" lIns="0" tIns="0" rIns="0" bIns="0" rtlCol="0" anchor="t"/>
+          <a:lstStyle/>
+          <a:p>
+            <a:pPr indent="0" marL="0">
+              <a:buNone/>
+            </a:pPr>
+            <a:r>
+              <a:rPr lang="en-US" sz="850" b="1" spc="100" kern="0" dirty="0">
+                <a:solidFill>
+                  <a:srgbClr val="EEE9DE"/>
+                </a:solidFill>
                 <a:latin typeface="Arial" pitchFamily="34" charset="0"/>
                 <a:ea typeface="Arial" pitchFamily="34" charset="-122"/>
                 <a:cs typeface="Arial" pitchFamily="34" charset="-120"/>
               </a:rPr>
               <a:t>WHO</a:t>
             </a:r>
-            <a:endParaRPr lang="en-US" sz="950" dirty="0"/>
-          </a:p>
-        </p:txBody>
-      </p:sp>
-      <p:sp>
-        <p:nvSpPr>
-          <p:cNvPr id="11" name="Text 9"/>
-          <p:cNvSpPr txBox="1"/>
-          <p:nvPr/>
-        </p:nvSpPr>
-        <p:spPr>
-          <a:xfrm>
-            <a:off x="548640" y="3200400"/>
-            <a:ext cx="3520440" cy="502920"/>
+            <a:endParaRPr lang="en-US" sz="850" dirty="0"/>
+          </a:p>
+        </p:txBody>
+      </p:sp>
+      <p:sp>
+        <p:nvSpPr>
+          <p:cNvPr id="13" name="Text 11"/>
+          <p:cNvSpPr txBox="1"/>
+          <p:nvPr/>
+        </p:nvSpPr>
+        <p:spPr>
+          <a:xfrm>
+            <a:off x="548640" y="3419856"/>
+            <a:ext cx="2788920" cy="438912"/>
+          </a:xfrm>
+          <a:prstGeom prst="rect">
+            <a:avLst/>
+          </a:prstGeom>
+          <a:noFill/>
+          <a:ln/>
+        </p:spPr>
+        <p:txBody>
+          <a:bodyPr wrap="square" lIns="0" tIns="0" rIns="0" bIns="0" rtlCol="0" anchor="t"/>
+          <a:lstStyle/>
+          <a:p>
+            <a:pPr indent="0" marL="0">
+              <a:buNone/>
+            </a:pPr>
+            <a:r>
+              <a:rPr lang="en-US" sz="1050" dirty="0">
+                <a:solidFill>
+                  <a:srgbClr val="A39F94"/>
+                </a:solidFill>
+                <a:latin typeface="Arial" pitchFamily="34" charset="0"/>
+                <a:ea typeface="Arial" pitchFamily="34" charset="-122"/>
+                <a:cs typeface="Arial" pitchFamily="34" charset="-120"/>
+              </a:rPr>
+              <a:t>Club commercial teams selling LED boards, shirts and backdrops; 2nd-tier clubs first.</a:t>
+            </a:r>
+            <a:endParaRPr lang="en-US" sz="1050" dirty="0"/>
+          </a:p>
+        </p:txBody>
+      </p:sp>
+      <p:sp>
+        <p:nvSpPr>
+          <p:cNvPr id="14" name="Text 12"/>
+          <p:cNvSpPr txBox="1"/>
+          <p:nvPr/>
+        </p:nvSpPr>
+        <p:spPr>
+          <a:xfrm>
+            <a:off x="548640" y="3895344"/>
+            <a:ext cx="2788920" cy="164592"/>
+          </a:xfrm>
+          <a:prstGeom prst="rect">
+            <a:avLst/>
+          </a:prstGeom>
+          <a:noFill/>
+          <a:ln/>
+        </p:spPr>
+        <p:txBody>
+          <a:bodyPr wrap="square" lIns="0" tIns="0" rIns="0" bIns="0" rtlCol="0" anchor="t"/>
+          <a:lstStyle/>
+          <a:p>
+            <a:pPr indent="0" marL="0">
+              <a:buNone/>
+            </a:pPr>
+            <a:r>
+              <a:rPr lang="en-US" sz="850" b="1" spc="100" kern="0" dirty="0">
+                <a:solidFill>
+                  <a:srgbClr val="EEE9DE"/>
+                </a:solidFill>
+                <a:latin typeface="Arial" pitchFamily="34" charset="0"/>
+                <a:ea typeface="Arial" pitchFamily="34" charset="-122"/>
+                <a:cs typeface="Arial" pitchFamily="34" charset="-120"/>
+              </a:rPr>
+              <a:t>VALUE</a:t>
+            </a:r>
+            <a:endParaRPr lang="en-US" sz="850" dirty="0"/>
+          </a:p>
+        </p:txBody>
+      </p:sp>
+      <p:sp>
+        <p:nvSpPr>
+          <p:cNvPr id="15" name="Text 13"/>
+          <p:cNvSpPr txBox="1"/>
+          <p:nvPr/>
+        </p:nvSpPr>
+        <p:spPr>
+          <a:xfrm>
+            <a:off x="548640" y="4078224"/>
+            <a:ext cx="2788920" cy="438912"/>
+          </a:xfrm>
+          <a:prstGeom prst="rect">
+            <a:avLst/>
+          </a:prstGeom>
+          <a:noFill/>
+          <a:ln/>
+        </p:spPr>
+        <p:txBody>
+          <a:bodyPr wrap="square" lIns="0" tIns="0" rIns="0" bIns="0" rtlCol="0" anchor="t"/>
+          <a:lstStyle/>
+          <a:p>
+            <a:pPr indent="0" marL="0">
+              <a:buNone/>
+            </a:pPr>
+            <a:r>
+              <a:rPr lang="en-US" sz="1050" dirty="0">
+                <a:solidFill>
+                  <a:srgbClr val="A39F94"/>
+                </a:solidFill>
+                <a:latin typeface="Arial" pitchFamily="34" charset="0"/>
+                <a:ea typeface="Arial" pitchFamily="34" charset="-122"/>
+                <a:cs typeface="Arial" pitchFamily="34" charset="-120"/>
+              </a:rPr>
+              <a:t>Proof of seconds on screen per sponsor and surface, instead of a manual count.</a:t>
+            </a:r>
+            <a:endParaRPr lang="en-US" sz="1050" dirty="0"/>
+          </a:p>
+        </p:txBody>
+      </p:sp>
+      <p:sp>
+        <p:nvSpPr>
+          <p:cNvPr id="16" name="Text 14"/>
+          <p:cNvSpPr txBox="1"/>
+          <p:nvPr/>
+        </p:nvSpPr>
+        <p:spPr>
+          <a:xfrm>
+            <a:off x="548640" y="4553712"/>
+            <a:ext cx="2788920" cy="164592"/>
+          </a:xfrm>
+          <a:prstGeom prst="rect">
+            <a:avLst/>
+          </a:prstGeom>
+          <a:noFill/>
+          <a:ln/>
+        </p:spPr>
+        <p:txBody>
+          <a:bodyPr wrap="square" lIns="0" tIns="0" rIns="0" bIns="0" rtlCol="0" anchor="t"/>
+          <a:lstStyle/>
+          <a:p>
+            <a:pPr indent="0" marL="0">
+              <a:buNone/>
+            </a:pPr>
+            <a:r>
+              <a:rPr lang="en-US" sz="850" b="1" spc="100" kern="0" dirty="0">
+                <a:solidFill>
+                  <a:srgbClr val="EEE9DE"/>
+                </a:solidFill>
+                <a:latin typeface="Arial" pitchFamily="34" charset="0"/>
+                <a:ea typeface="Arial" pitchFamily="34" charset="-122"/>
+                <a:cs typeface="Arial" pitchFamily="34" charset="-120"/>
+              </a:rPr>
+              <a:t>WHY NOW</a:t>
+            </a:r>
+            <a:endParaRPr lang="en-US" sz="850" dirty="0"/>
+          </a:p>
+        </p:txBody>
+      </p:sp>
+      <p:sp>
+        <p:nvSpPr>
+          <p:cNvPr id="17" name="Text 15"/>
+          <p:cNvSpPr txBox="1"/>
+          <p:nvPr/>
+        </p:nvSpPr>
+        <p:spPr>
+          <a:xfrm>
+            <a:off x="548640" y="4736592"/>
+            <a:ext cx="2788920" cy="438912"/>
+          </a:xfrm>
+          <a:prstGeom prst="rect">
+            <a:avLst/>
+          </a:prstGeom>
+          <a:noFill/>
+          <a:ln/>
+        </p:spPr>
+        <p:txBody>
+          <a:bodyPr wrap="square" lIns="0" tIns="0" rIns="0" bIns="0" rtlCol="0" anchor="t"/>
+          <a:lstStyle/>
+          <a:p>
+            <a:pPr indent="0" marL="0">
+              <a:buNone/>
+            </a:pPr>
+            <a:r>
+              <a:rPr lang="en-US" sz="1050" dirty="0">
+                <a:solidFill>
+                  <a:srgbClr val="A39F94"/>
+                </a:solidFill>
+                <a:latin typeface="Arial" pitchFamily="34" charset="0"/>
+                <a:ea typeface="Arial" pitchFamily="34" charset="-122"/>
+                <a:cs typeface="Arial" pitchFamily="34" charset="-120"/>
+              </a:rPr>
+              <a:t>Vision models read stylised logos OCR misses, at ≈ $0.12 per match-minute.</a:t>
+            </a:r>
+            <a:endParaRPr lang="en-US" sz="1050" dirty="0"/>
+          </a:p>
+        </p:txBody>
+      </p:sp>
+      <p:sp>
+        <p:nvSpPr>
+          <p:cNvPr id="18" name="Text 16"/>
+          <p:cNvSpPr txBox="1"/>
+          <p:nvPr/>
+        </p:nvSpPr>
+        <p:spPr>
+          <a:xfrm>
+            <a:off x="548640" y="5212080"/>
+            <a:ext cx="2788920" cy="164592"/>
+          </a:xfrm>
+          <a:prstGeom prst="rect">
+            <a:avLst/>
+          </a:prstGeom>
+          <a:noFill/>
+          <a:ln/>
+        </p:spPr>
+        <p:txBody>
+          <a:bodyPr wrap="square" lIns="0" tIns="0" rIns="0" bIns="0" rtlCol="0" anchor="t"/>
+          <a:lstStyle/>
+          <a:p>
+            <a:pPr indent="0" marL="0">
+              <a:buNone/>
+            </a:pPr>
+            <a:r>
+              <a:rPr lang="en-US" sz="850" b="1" spc="100" kern="0" dirty="0">
+                <a:solidFill>
+                  <a:srgbClr val="EEE9DE"/>
+                </a:solidFill>
+                <a:latin typeface="Arial" pitchFamily="34" charset="0"/>
+                <a:ea typeface="Arial" pitchFamily="34" charset="-122"/>
+                <a:cs typeface="Arial" pitchFamily="34" charset="-120"/>
+              </a:rPr>
+              <a:t>FIRST USERS</a:t>
+            </a:r>
+            <a:endParaRPr lang="en-US" sz="850" dirty="0"/>
+          </a:p>
+        </p:txBody>
+      </p:sp>
+      <p:sp>
+        <p:nvSpPr>
+          <p:cNvPr id="19" name="Text 17"/>
+          <p:cNvSpPr txBox="1"/>
+          <p:nvPr/>
+        </p:nvSpPr>
+        <p:spPr>
+          <a:xfrm>
+            <a:off x="548640" y="5394960"/>
+            <a:ext cx="2788920" cy="438912"/>
+          </a:xfrm>
+          <a:prstGeom prst="rect">
+            <a:avLst/>
+          </a:prstGeom>
+          <a:noFill/>
+          <a:ln/>
+        </p:spPr>
+        <p:txBody>
+          <a:bodyPr wrap="square" lIns="0" tIns="0" rIns="0" bIns="0" rtlCol="0" anchor="t"/>
+          <a:lstStyle/>
+          <a:p>
+            <a:pPr indent="0" marL="0">
+              <a:buNone/>
+            </a:pPr>
+            <a:r>
+              <a:rPr lang="en-US" sz="1050" dirty="0">
+                <a:solidFill>
+                  <a:srgbClr val="A39F94"/>
+                </a:solidFill>
+                <a:latin typeface="Arial" pitchFamily="34" charset="0"/>
+                <a:ea typeface="Arial" pitchFamily="34" charset="-122"/>
+                <a:cs typeface="Arial" pitchFamily="34" charset="-120"/>
+              </a:rPr>
+              <a:t>Pilot done with a 2nd-tier club, a second agreed; then leagues, for all their clubs.</a:t>
+            </a:r>
+            <a:endParaRPr lang="en-US" sz="1050" dirty="0"/>
+          </a:p>
+        </p:txBody>
+      </p:sp>
+      <p:sp>
+        <p:nvSpPr>
+          <p:cNvPr id="20" name="Text 18"/>
+          <p:cNvSpPr txBox="1"/>
+          <p:nvPr/>
+        </p:nvSpPr>
+        <p:spPr>
+          <a:xfrm>
+            <a:off x="3703320" y="2340864"/>
+            <a:ext cx="2788920" cy="201168"/>
+          </a:xfrm>
+          <a:prstGeom prst="rect">
+            <a:avLst/>
+          </a:prstGeom>
+          <a:noFill/>
+          <a:ln/>
+        </p:spPr>
+        <p:txBody>
+          <a:bodyPr wrap="square" lIns="0" tIns="0" rIns="0" bIns="0" rtlCol="0" anchor="t"/>
+          <a:lstStyle/>
+          <a:p>
+            <a:pPr indent="0" marL="0">
+              <a:buNone/>
+            </a:pPr>
+            <a:r>
+              <a:rPr lang="en-US" sz="900" b="1" spc="120" kern="0" dirty="0">
+                <a:solidFill>
+                  <a:srgbClr val="C9A766"/>
+                </a:solidFill>
+                <a:latin typeface="Arial" pitchFamily="34" charset="0"/>
+                <a:ea typeface="Arial" pitchFamily="34" charset="-122"/>
+                <a:cs typeface="Arial" pitchFamily="34" charset="-120"/>
+              </a:rPr>
+              <a:t>02  AGENT CAPABILITY</a:t>
+            </a:r>
+            <a:endParaRPr lang="en-US" sz="900" dirty="0"/>
+          </a:p>
+        </p:txBody>
+      </p:sp>
+      <p:sp>
+        <p:nvSpPr>
+          <p:cNvPr id="21" name="Text 19"/>
+          <p:cNvSpPr txBox="1"/>
+          <p:nvPr/>
+        </p:nvSpPr>
+        <p:spPr>
+          <a:xfrm>
+            <a:off x="3703320" y="2615184"/>
+            <a:ext cx="2788920" cy="530352"/>
           </a:xfrm>
           <a:prstGeom prst="rect">
             <a:avLst/>
@@ -1238,317 +1615,35 @@
           <a:p>
             <a:pPr indent="0" marL="0">
               <a:lnSpc>
-                <a:spcPct val="100000"/>
+                <a:spcPct val="95000"/>
               </a:lnSpc>
               <a:buNone/>
             </a:pPr>
             <a:r>
-              <a:rPr lang="en-US" sz="1150" dirty="0">
-                <a:solidFill>
-                  <a:srgbClr val="A39F94"/>
-                </a:solidFill>
-                <a:latin typeface="Arial" pitchFamily="34" charset="0"/>
-                <a:ea typeface="Arial" pitchFamily="34" charset="-122"/>
-                <a:cs typeface="Arial" pitchFamily="34" charset="-120"/>
-              </a:rPr>
-              <a:t>Club commercial managers, starting with 2nd-tier clubs selling LED boards, shirts and backdrops.</a:t>
-            </a:r>
-            <a:endParaRPr lang="en-US" sz="1150" dirty="0"/>
-          </a:p>
-        </p:txBody>
-      </p:sp>
-      <p:sp>
-        <p:nvSpPr>
-          <p:cNvPr id="12" name="Text 10"/>
-          <p:cNvSpPr txBox="1"/>
-          <p:nvPr/>
-        </p:nvSpPr>
-        <p:spPr>
-          <a:xfrm>
-            <a:off x="548640" y="3721608"/>
-            <a:ext cx="3520440" cy="182880"/>
-          </a:xfrm>
-          <a:prstGeom prst="rect">
-            <a:avLst/>
-          </a:prstGeom>
-          <a:noFill/>
-          <a:ln/>
-        </p:spPr>
-        <p:txBody>
-          <a:bodyPr wrap="square" lIns="0" tIns="0" rIns="0" bIns="0" rtlCol="0" anchor="t"/>
-          <a:lstStyle/>
-          <a:p>
-            <a:pPr indent="0" marL="0">
-              <a:buNone/>
-            </a:pPr>
-            <a:r>
-              <a:rPr lang="en-US" sz="950" b="1" spc="100" kern="0" dirty="0">
+              <a:rPr lang="en-US" sz="1400" dirty="0">
                 <a:solidFill>
                   <a:srgbClr val="EEE9DE"/>
                 </a:solidFill>
-                <a:latin typeface="Arial" pitchFamily="34" charset="0"/>
-                <a:ea typeface="Arial" pitchFamily="34" charset="-122"/>
-                <a:cs typeface="Arial" pitchFamily="34" charset="-120"/>
-              </a:rPr>
-              <a:t>PROBLEM</a:t>
-            </a:r>
-            <a:endParaRPr lang="en-US" sz="950" dirty="0"/>
-          </a:p>
-        </p:txBody>
-      </p:sp>
-      <p:sp>
-        <p:nvSpPr>
-          <p:cNvPr id="13" name="Text 11"/>
-          <p:cNvSpPr txBox="1"/>
-          <p:nvPr/>
-        </p:nvSpPr>
-        <p:spPr>
-          <a:xfrm>
-            <a:off x="548640" y="3922776"/>
-            <a:ext cx="3520440" cy="502920"/>
-          </a:xfrm>
-          <a:prstGeom prst="rect">
-            <a:avLst/>
-          </a:prstGeom>
-          <a:noFill/>
-          <a:ln/>
-        </p:spPr>
-        <p:txBody>
-          <a:bodyPr wrap="square" lIns="0" tIns="0" rIns="0" bIns="0" rtlCol="0" anchor="t"/>
-          <a:lstStyle/>
-          <a:p>
-            <a:pPr indent="0" marL="0">
-              <a:lnSpc>
-                <a:spcPct val="100000"/>
-              </a:lnSpc>
-              <a:buNone/>
-            </a:pPr>
-            <a:r>
-              <a:rPr lang="en-US" sz="1150" dirty="0">
-                <a:solidFill>
-                  <a:srgbClr val="A39F94"/>
-                </a:solidFill>
-                <a:latin typeface="Arial" pitchFamily="34" charset="0"/>
-                <a:ea typeface="Arial" pitchFamily="34" charset="-122"/>
-                <a:cs typeface="Arial" pitchFamily="34" charset="-120"/>
-              </a:rPr>
-              <a:t>At renewal sponsors ask: how many seconds was I on TV, and where? Today: a manual count or a guess.</a:t>
-            </a:r>
-            <a:endParaRPr lang="en-US" sz="1150" dirty="0"/>
-          </a:p>
-        </p:txBody>
-      </p:sp>
-      <p:sp>
-        <p:nvSpPr>
-          <p:cNvPr id="14" name="Text 12"/>
-          <p:cNvSpPr txBox="1"/>
-          <p:nvPr/>
-        </p:nvSpPr>
-        <p:spPr>
-          <a:xfrm>
-            <a:off x="548640" y="4443984"/>
-            <a:ext cx="3520440" cy="182880"/>
-          </a:xfrm>
-          <a:prstGeom prst="rect">
-            <a:avLst/>
-          </a:prstGeom>
-          <a:noFill/>
-          <a:ln/>
-        </p:spPr>
-        <p:txBody>
-          <a:bodyPr wrap="square" lIns="0" tIns="0" rIns="0" bIns="0" rtlCol="0" anchor="t"/>
-          <a:lstStyle/>
-          <a:p>
-            <a:pPr indent="0" marL="0">
-              <a:buNone/>
-            </a:pPr>
-            <a:r>
-              <a:rPr lang="en-US" sz="950" b="1" spc="100" kern="0" dirty="0">
-                <a:solidFill>
-                  <a:srgbClr val="EEE9DE"/>
-                </a:solidFill>
-                <a:latin typeface="Arial" pitchFamily="34" charset="0"/>
-                <a:ea typeface="Arial" pitchFamily="34" charset="-122"/>
-                <a:cs typeface="Arial" pitchFamily="34" charset="-120"/>
-              </a:rPr>
-              <a:t>WHY NOW</a:t>
-            </a:r>
-            <a:endParaRPr lang="en-US" sz="950" dirty="0"/>
-          </a:p>
-        </p:txBody>
-      </p:sp>
-      <p:sp>
-        <p:nvSpPr>
-          <p:cNvPr id="15" name="Text 13"/>
-          <p:cNvSpPr txBox="1"/>
-          <p:nvPr/>
-        </p:nvSpPr>
-        <p:spPr>
-          <a:xfrm>
-            <a:off x="548640" y="4645152"/>
-            <a:ext cx="3520440" cy="502920"/>
-          </a:xfrm>
-          <a:prstGeom prst="rect">
-            <a:avLst/>
-          </a:prstGeom>
-          <a:noFill/>
-          <a:ln/>
-        </p:spPr>
-        <p:txBody>
-          <a:bodyPr wrap="square" lIns="0" tIns="0" rIns="0" bIns="0" rtlCol="0" anchor="t"/>
-          <a:lstStyle/>
-          <a:p>
-            <a:pPr indent="0" marL="0">
-              <a:lnSpc>
-                <a:spcPct val="100000"/>
-              </a:lnSpc>
-              <a:buNone/>
-            </a:pPr>
-            <a:r>
-              <a:rPr lang="en-US" sz="1150" dirty="0">
-                <a:solidFill>
-                  <a:srgbClr val="A39F94"/>
-                </a:solidFill>
-                <a:latin typeface="Arial" pitchFamily="34" charset="0"/>
-                <a:ea typeface="Arial" pitchFamily="34" charset="-122"/>
-                <a:cs typeface="Arial" pitchFamily="34" charset="-120"/>
-              </a:rPr>
-              <a:t>Vision models now read stylised logos OCR misses, cheaply enough for every club, every match.</a:t>
-            </a:r>
-            <a:endParaRPr lang="en-US" sz="1150" dirty="0"/>
-          </a:p>
-        </p:txBody>
-      </p:sp>
-      <p:sp>
-        <p:nvSpPr>
-          <p:cNvPr id="16" name="Text 14"/>
-          <p:cNvSpPr txBox="1"/>
-          <p:nvPr/>
-        </p:nvSpPr>
-        <p:spPr>
-          <a:xfrm>
-            <a:off x="548640" y="5166360"/>
-            <a:ext cx="3520440" cy="182880"/>
-          </a:xfrm>
-          <a:prstGeom prst="rect">
-            <a:avLst/>
-          </a:prstGeom>
-          <a:noFill/>
-          <a:ln/>
-        </p:spPr>
-        <p:txBody>
-          <a:bodyPr wrap="square" lIns="0" tIns="0" rIns="0" bIns="0" rtlCol="0" anchor="t"/>
-          <a:lstStyle/>
-          <a:p>
-            <a:pPr indent="0" marL="0">
-              <a:buNone/>
-            </a:pPr>
-            <a:r>
-              <a:rPr lang="en-US" sz="950" b="1" spc="100" kern="0" dirty="0">
-                <a:solidFill>
-                  <a:srgbClr val="EEE9DE"/>
-                </a:solidFill>
-                <a:latin typeface="Arial" pitchFamily="34" charset="0"/>
-                <a:ea typeface="Arial" pitchFamily="34" charset="-122"/>
-                <a:cs typeface="Arial" pitchFamily="34" charset="-120"/>
-              </a:rPr>
-              <a:t>FIRST USERS</a:t>
-            </a:r>
-            <a:endParaRPr lang="en-US" sz="950" dirty="0"/>
-          </a:p>
-        </p:txBody>
-      </p:sp>
-      <p:sp>
-        <p:nvSpPr>
-          <p:cNvPr id="17" name="Text 15"/>
-          <p:cNvSpPr txBox="1"/>
-          <p:nvPr/>
-        </p:nvSpPr>
-        <p:spPr>
-          <a:xfrm>
-            <a:off x="548640" y="5367528"/>
-            <a:ext cx="3520440" cy="502920"/>
-          </a:xfrm>
-          <a:prstGeom prst="rect">
-            <a:avLst/>
-          </a:prstGeom>
-          <a:noFill/>
-          <a:ln/>
-        </p:spPr>
-        <p:txBody>
-          <a:bodyPr wrap="square" lIns="0" tIns="0" rIns="0" bIns="0" rtlCol="0" anchor="t"/>
-          <a:lstStyle/>
-          <a:p>
-            <a:pPr indent="0" marL="0">
-              <a:lnSpc>
-                <a:spcPct val="100000"/>
-              </a:lnSpc>
-              <a:buNone/>
-            </a:pPr>
-            <a:r>
-              <a:rPr lang="en-US" sz="1150" dirty="0">
-                <a:solidFill>
-                  <a:srgbClr val="A39F94"/>
-                </a:solidFill>
-                <a:latin typeface="Arial" pitchFamily="34" charset="0"/>
-                <a:ea typeface="Arial" pitchFamily="34" charset="-122"/>
-                <a:cs typeface="Arial" pitchFamily="34" charset="-120"/>
-              </a:rPr>
-              <a:t>Pilot done with a 2nd-tier club, a second agreed. Next: renewal season, then leagues for all their clubs.</a:t>
-            </a:r>
-            <a:endParaRPr lang="en-US" sz="1150" dirty="0"/>
-          </a:p>
-        </p:txBody>
-      </p:sp>
-      <p:sp>
-        <p:nvSpPr>
-          <p:cNvPr id="18" name="Text 16"/>
-          <p:cNvSpPr txBox="1"/>
-          <p:nvPr/>
-        </p:nvSpPr>
-        <p:spPr>
-          <a:xfrm>
-            <a:off x="4434840" y="2633472"/>
-            <a:ext cx="3611880" cy="228600"/>
-          </a:xfrm>
-          <a:prstGeom prst="rect">
-            <a:avLst/>
-          </a:prstGeom>
-          <a:noFill/>
-          <a:ln/>
-        </p:spPr>
-        <p:txBody>
-          <a:bodyPr wrap="square" lIns="0" tIns="0" rIns="0" bIns="0" rtlCol="0" anchor="t"/>
-          <a:lstStyle/>
-          <a:p>
-            <a:pPr indent="0" marL="0">
-              <a:buNone/>
-            </a:pPr>
-            <a:r>
-              <a:rPr lang="en-US" sz="1000" b="1" spc="150" kern="0" dirty="0">
-                <a:solidFill>
-                  <a:srgbClr val="C9A766"/>
-                </a:solidFill>
-                <a:latin typeface="Arial" pitchFamily="34" charset="0"/>
-                <a:ea typeface="Arial" pitchFamily="34" charset="-122"/>
-                <a:cs typeface="Arial" pitchFamily="34" charset="-120"/>
-              </a:rPr>
-              <a:t>02   THREE AGENTS, ONE LEDGER</a:t>
-            </a:r>
-            <a:endParaRPr lang="en-US" sz="1000" dirty="0"/>
-          </a:p>
-        </p:txBody>
-      </p:sp>
-      <p:sp>
-        <p:nvSpPr>
-          <p:cNvPr id="19" name="Shape 17"/>
+                <a:latin typeface="Georgia" pitchFamily="34" charset="0"/>
+                <a:ea typeface="Georgia" pitchFamily="34" charset="-122"/>
+                <a:cs typeface="Georgia" pitchFamily="34" charset="-120"/>
+              </a:rPr>
+              <a:t>Three agents that decide, budget and explain.</a:t>
+            </a:r>
+            <a:endParaRPr lang="en-US" sz="1400" dirty="0"/>
+          </a:p>
+        </p:txBody>
+      </p:sp>
+      <p:sp>
+        <p:nvSpPr>
+          <p:cNvPr id="22" name="Shape 20"/>
           <p:cNvSpPr/>
           <p:nvPr/>
         </p:nvSpPr>
         <p:spPr>
           <a:xfrm>
-            <a:off x="4434840" y="3017520"/>
-            <a:ext cx="329184" cy="329184"/>
+            <a:off x="3703320" y="3255264"/>
+            <a:ext cx="310896" cy="310896"/>
           </a:xfrm>
           <a:prstGeom prst="ellipse">
             <a:avLst/>
@@ -1566,14 +1661,14 @@
       </p:sp>
       <p:sp>
         <p:nvSpPr>
-          <p:cNvPr id="20" name="Text 18"/>
-          <p:cNvSpPr txBox="1"/>
-          <p:nvPr/>
-        </p:nvSpPr>
-        <p:spPr>
-          <a:xfrm>
-            <a:off x="4434840" y="3044952"/>
-            <a:ext cx="329184" cy="274320"/>
+          <p:cNvPr id="23" name="Text 21"/>
+          <p:cNvSpPr txBox="1"/>
+          <p:nvPr/>
+        </p:nvSpPr>
+        <p:spPr>
+          <a:xfrm>
+            <a:off x="3703320" y="3273552"/>
+            <a:ext cx="310896" cy="274320"/>
           </a:xfrm>
           <a:prstGeom prst="rect">
             <a:avLst/>
@@ -1589,7 +1684,7 @@
               <a:buNone/>
             </a:pPr>
             <a:r>
-              <a:rPr lang="en-US" sz="1300" dirty="0">
+              <a:rPr lang="en-US" sz="1200" dirty="0">
                 <a:solidFill>
                   <a:srgbClr val="C9A766"/>
                 </a:solidFill>
@@ -1599,36 +1694,36 @@
               </a:rPr>
               <a:t>1</a:t>
             </a:r>
-            <a:endParaRPr lang="en-US" sz="1300" dirty="0"/>
-          </a:p>
-        </p:txBody>
-      </p:sp>
-      <p:sp>
-        <p:nvSpPr>
-          <p:cNvPr id="21" name="Text 19"/>
-          <p:cNvSpPr txBox="1"/>
-          <p:nvPr/>
-        </p:nvSpPr>
-        <p:spPr>
-          <a:xfrm>
-            <a:off x="4937760" y="2999232"/>
-            <a:ext cx="3108960" cy="219456"/>
-          </a:xfrm>
-          <a:prstGeom prst="rect">
-            <a:avLst/>
-          </a:prstGeom>
-          <a:noFill/>
-          <a:ln/>
-        </p:spPr>
-        <p:txBody>
-          <a:bodyPr wrap="square" lIns="0" tIns="0" rIns="0" bIns="0" rtlCol="0" anchor="t"/>
-          <a:lstStyle/>
-          <a:p>
-            <a:pPr indent="0" marL="0">
-              <a:buNone/>
-            </a:pPr>
-            <a:r>
-              <a:rPr lang="en-US" sz="1250" b="1" dirty="0">
+            <a:endParaRPr lang="en-US" sz="1200" dirty="0"/>
+          </a:p>
+        </p:txBody>
+      </p:sp>
+      <p:sp>
+        <p:nvSpPr>
+          <p:cNvPr id="24" name="Text 22"/>
+          <p:cNvSpPr txBox="1"/>
+          <p:nvPr/>
+        </p:nvSpPr>
+        <p:spPr>
+          <a:xfrm>
+            <a:off x="4160520" y="3246120"/>
+            <a:ext cx="2331720" cy="219456"/>
+          </a:xfrm>
+          <a:prstGeom prst="rect">
+            <a:avLst/>
+          </a:prstGeom>
+          <a:noFill/>
+          <a:ln/>
+        </p:spPr>
+        <p:txBody>
+          <a:bodyPr wrap="square" lIns="0" tIns="0" rIns="0" bIns="0" rtlCol="0" anchor="t"/>
+          <a:lstStyle/>
+          <a:p>
+            <a:pPr indent="0" marL="0">
+              <a:buNone/>
+            </a:pPr>
+            <a:r>
+              <a:rPr lang="en-US" sz="1200" b="1" dirty="0">
                 <a:solidFill>
                   <a:srgbClr val="EEE9DE"/>
                 </a:solidFill>
@@ -1638,20 +1733,20 @@
               </a:rPr>
               <a:t>Vision Reader</a:t>
             </a:r>
-            <a:endParaRPr lang="en-US" sz="1250" dirty="0"/>
-          </a:p>
-        </p:txBody>
-      </p:sp>
-      <p:sp>
-        <p:nvSpPr>
-          <p:cNvPr id="22" name="Text 20"/>
-          <p:cNvSpPr txBox="1"/>
-          <p:nvPr/>
-        </p:nvSpPr>
-        <p:spPr>
-          <a:xfrm>
-            <a:off x="4937760" y="3227832"/>
-            <a:ext cx="3108960" cy="411480"/>
+            <a:endParaRPr lang="en-US" sz="1200" dirty="0"/>
+          </a:p>
+        </p:txBody>
+      </p:sp>
+      <p:sp>
+        <p:nvSpPr>
+          <p:cNvPr id="25" name="Text 23"/>
+          <p:cNvSpPr txBox="1"/>
+          <p:nvPr/>
+        </p:nvSpPr>
+        <p:spPr>
+          <a:xfrm>
+            <a:off x="4160520" y="3474720"/>
+            <a:ext cx="2331720" cy="548640"/>
           </a:xfrm>
           <a:prstGeom prst="rect">
             <a:avLst/>
@@ -1675,7 +1770,7 @@
                 <a:ea typeface="Arial" pitchFamily="34" charset="-122"/>
                 <a:cs typeface="Arial" pitchFamily="34" charset="-120"/>
               </a:rPr>
-              <a:t>Reads every frame, picks only from the club's sponsor list. Not sure? It says unknown.</a:t>
+              <a:t>Reads each frame, picks only from the sponsor list. Unsure? Says unknown.</a:t>
             </a:r>
             <a:endParaRPr lang="en-US" sz="1050" dirty="0"/>
           </a:p>
@@ -1683,14 +1778,14 @@
       </p:sp>
       <p:sp>
         <p:nvSpPr>
-          <p:cNvPr id="23" name="Shape 21"/>
+          <p:cNvPr id="26" name="Shape 24"/>
           <p:cNvSpPr/>
           <p:nvPr/>
         </p:nvSpPr>
         <p:spPr>
           <a:xfrm>
-            <a:off x="4434840" y="3694176"/>
-            <a:ext cx="329184" cy="329184"/>
+            <a:off x="3703320" y="4123944"/>
+            <a:ext cx="310896" cy="310896"/>
           </a:xfrm>
           <a:prstGeom prst="ellipse">
             <a:avLst/>
@@ -1708,14 +1803,14 @@
       </p:sp>
       <p:sp>
         <p:nvSpPr>
-          <p:cNvPr id="24" name="Text 22"/>
-          <p:cNvSpPr txBox="1"/>
-          <p:nvPr/>
-        </p:nvSpPr>
-        <p:spPr>
-          <a:xfrm>
-            <a:off x="4434840" y="3721608"/>
-            <a:ext cx="329184" cy="274320"/>
+          <p:cNvPr id="27" name="Text 25"/>
+          <p:cNvSpPr txBox="1"/>
+          <p:nvPr/>
+        </p:nvSpPr>
+        <p:spPr>
+          <a:xfrm>
+            <a:off x="3703320" y="4142232"/>
+            <a:ext cx="310896" cy="274320"/>
           </a:xfrm>
           <a:prstGeom prst="rect">
             <a:avLst/>
@@ -1731,7 +1826,7 @@
               <a:buNone/>
             </a:pPr>
             <a:r>
-              <a:rPr lang="en-US" sz="1300" dirty="0">
+              <a:rPr lang="en-US" sz="1200" dirty="0">
                 <a:solidFill>
                   <a:srgbClr val="C9A766"/>
                 </a:solidFill>
@@ -1741,36 +1836,36 @@
               </a:rPr>
               <a:t>2</a:t>
             </a:r>
-            <a:endParaRPr lang="en-US" sz="1300" dirty="0"/>
-          </a:p>
-        </p:txBody>
-      </p:sp>
-      <p:sp>
-        <p:nvSpPr>
-          <p:cNvPr id="25" name="Text 23"/>
-          <p:cNvSpPr txBox="1"/>
-          <p:nvPr/>
-        </p:nvSpPr>
-        <p:spPr>
-          <a:xfrm>
-            <a:off x="4937760" y="3675888"/>
-            <a:ext cx="3108960" cy="219456"/>
-          </a:xfrm>
-          <a:prstGeom prst="rect">
-            <a:avLst/>
-          </a:prstGeom>
-          <a:noFill/>
-          <a:ln/>
-        </p:spPr>
-        <p:txBody>
-          <a:bodyPr wrap="square" lIns="0" tIns="0" rIns="0" bIns="0" rtlCol="0" anchor="t"/>
-          <a:lstStyle/>
-          <a:p>
-            <a:pPr indent="0" marL="0">
-              <a:buNone/>
-            </a:pPr>
-            <a:r>
-              <a:rPr lang="en-US" sz="1250" b="1" dirty="0">
+            <a:endParaRPr lang="en-US" sz="1200" dirty="0"/>
+          </a:p>
+        </p:txBody>
+      </p:sp>
+      <p:sp>
+        <p:nvSpPr>
+          <p:cNvPr id="28" name="Text 26"/>
+          <p:cNvSpPr txBox="1"/>
+          <p:nvPr/>
+        </p:nvSpPr>
+        <p:spPr>
+          <a:xfrm>
+            <a:off x="4160520" y="4114800"/>
+            <a:ext cx="2331720" cy="219456"/>
+          </a:xfrm>
+          <a:prstGeom prst="rect">
+            <a:avLst/>
+          </a:prstGeom>
+          <a:noFill/>
+          <a:ln/>
+        </p:spPr>
+        <p:txBody>
+          <a:bodyPr wrap="square" lIns="0" tIns="0" rIns="0" bIns="0" rtlCol="0" anchor="t"/>
+          <a:lstStyle/>
+          <a:p>
+            <a:pPr indent="0" marL="0">
+              <a:buNone/>
+            </a:pPr>
+            <a:r>
+              <a:rPr lang="en-US" sz="1200" b="1" dirty="0">
                 <a:solidFill>
                   <a:srgbClr val="EEE9DE"/>
                 </a:solidFill>
@@ -1780,20 +1875,20 @@
               </a:rPr>
               <a:t>Budget Guard</a:t>
             </a:r>
-            <a:endParaRPr lang="en-US" sz="1250" dirty="0"/>
-          </a:p>
-        </p:txBody>
-      </p:sp>
-      <p:sp>
-        <p:nvSpPr>
-          <p:cNvPr id="26" name="Text 24"/>
-          <p:cNvSpPr txBox="1"/>
-          <p:nvPr/>
-        </p:nvSpPr>
-        <p:spPr>
-          <a:xfrm>
-            <a:off x="4937760" y="3904488"/>
-            <a:ext cx="3108960" cy="411480"/>
+            <a:endParaRPr lang="en-US" sz="1200" dirty="0"/>
+          </a:p>
+        </p:txBody>
+      </p:sp>
+      <p:sp>
+        <p:nvSpPr>
+          <p:cNvPr id="29" name="Text 27"/>
+          <p:cNvSpPr txBox="1"/>
+          <p:nvPr/>
+        </p:nvSpPr>
+        <p:spPr>
+          <a:xfrm>
+            <a:off x="4160520" y="4343400"/>
+            <a:ext cx="2331720" cy="548640"/>
           </a:xfrm>
           <a:prstGeom prst="rect">
             <a:avLst/>
@@ -1817,7 +1912,7 @@
                 <a:ea typeface="Arial" pitchFamily="34" charset="-122"/>
                 <a:cs typeface="Arial" pitchFamily="34" charset="-120"/>
               </a:rPr>
-              <a:t>Prices each model call before making it, under a hard per-match budget.</a:t>
+              <a:t>Prices every model call first; stops at a hard per-match budget.</a:t>
             </a:r>
             <a:endParaRPr lang="en-US" sz="1050" dirty="0"/>
           </a:p>
@@ -1825,14 +1920,14 @@
       </p:sp>
       <p:sp>
         <p:nvSpPr>
-          <p:cNvPr id="27" name="Shape 25"/>
+          <p:cNvPr id="30" name="Shape 28"/>
           <p:cNvSpPr/>
           <p:nvPr/>
         </p:nvSpPr>
         <p:spPr>
           <a:xfrm>
-            <a:off x="4434840" y="4370832"/>
-            <a:ext cx="329184" cy="329184"/>
+            <a:off x="3703320" y="4992624"/>
+            <a:ext cx="310896" cy="310896"/>
           </a:xfrm>
           <a:prstGeom prst="ellipse">
             <a:avLst/>
@@ -1850,14 +1945,14 @@
       </p:sp>
       <p:sp>
         <p:nvSpPr>
-          <p:cNvPr id="28" name="Text 26"/>
-          <p:cNvSpPr txBox="1"/>
-          <p:nvPr/>
-        </p:nvSpPr>
-        <p:spPr>
-          <a:xfrm>
-            <a:off x="4434840" y="4398264"/>
-            <a:ext cx="329184" cy="274320"/>
+          <p:cNvPr id="31" name="Text 29"/>
+          <p:cNvSpPr txBox="1"/>
+          <p:nvPr/>
+        </p:nvSpPr>
+        <p:spPr>
+          <a:xfrm>
+            <a:off x="3703320" y="5010912"/>
+            <a:ext cx="310896" cy="274320"/>
           </a:xfrm>
           <a:prstGeom prst="rect">
             <a:avLst/>
@@ -1873,7 +1968,7 @@
               <a:buNone/>
             </a:pPr>
             <a:r>
-              <a:rPr lang="en-US" sz="1300" dirty="0">
+              <a:rPr lang="en-US" sz="1200" dirty="0">
                 <a:solidFill>
                   <a:srgbClr val="C9A766"/>
                 </a:solidFill>
@@ -1883,36 +1978,36 @@
               </a:rPr>
               <a:t>3</a:t>
             </a:r>
-            <a:endParaRPr lang="en-US" sz="1300" dirty="0"/>
-          </a:p>
-        </p:txBody>
-      </p:sp>
-      <p:sp>
-        <p:nvSpPr>
-          <p:cNvPr id="29" name="Text 27"/>
-          <p:cNvSpPr txBox="1"/>
-          <p:nvPr/>
-        </p:nvSpPr>
-        <p:spPr>
-          <a:xfrm>
-            <a:off x="4937760" y="4352544"/>
-            <a:ext cx="3108960" cy="219456"/>
-          </a:xfrm>
-          <a:prstGeom prst="rect">
-            <a:avLst/>
-          </a:prstGeom>
-          <a:noFill/>
-          <a:ln/>
-        </p:spPr>
-        <p:txBody>
-          <a:bodyPr wrap="square" lIns="0" tIns="0" rIns="0" bIns="0" rtlCol="0" anchor="t"/>
-          <a:lstStyle/>
-          <a:p>
-            <a:pPr indent="0" marL="0">
-              <a:buNone/>
-            </a:pPr>
-            <a:r>
-              <a:rPr lang="en-US" sz="1250" b="1" dirty="0">
+            <a:endParaRPr lang="en-US" sz="1200" dirty="0"/>
+          </a:p>
+        </p:txBody>
+      </p:sp>
+      <p:sp>
+        <p:nvSpPr>
+          <p:cNvPr id="32" name="Text 30"/>
+          <p:cNvSpPr txBox="1"/>
+          <p:nvPr/>
+        </p:nvSpPr>
+        <p:spPr>
+          <a:xfrm>
+            <a:off x="4160520" y="4983480"/>
+            <a:ext cx="2331720" cy="219456"/>
+          </a:xfrm>
+          <a:prstGeom prst="rect">
+            <a:avLst/>
+          </a:prstGeom>
+          <a:noFill/>
+          <a:ln/>
+        </p:spPr>
+        <p:txBody>
+          <a:bodyPr wrap="square" lIns="0" tIns="0" rIns="0" bIns="0" rtlCol="0" anchor="t"/>
+          <a:lstStyle/>
+          <a:p>
+            <a:pPr indent="0" marL="0">
+              <a:buNone/>
+            </a:pPr>
+            <a:r>
+              <a:rPr lang="en-US" sz="1200" b="1" dirty="0">
                 <a:solidFill>
                   <a:srgbClr val="EEE9DE"/>
                 </a:solidFill>
@@ -1922,20 +2017,20 @@
               </a:rPr>
               <a:t>Sponsor Analyst</a:t>
             </a:r>
-            <a:endParaRPr lang="en-US" sz="1250" dirty="0"/>
-          </a:p>
-        </p:txBody>
-      </p:sp>
-      <p:sp>
-        <p:nvSpPr>
-          <p:cNvPr id="30" name="Text 28"/>
-          <p:cNvSpPr txBox="1"/>
-          <p:nvPr/>
-        </p:nvSpPr>
-        <p:spPr>
-          <a:xfrm>
-            <a:off x="4937760" y="4581144"/>
-            <a:ext cx="3108960" cy="411480"/>
+            <a:endParaRPr lang="en-US" sz="1200" dirty="0"/>
+          </a:p>
+        </p:txBody>
+      </p:sp>
+      <p:sp>
+        <p:nvSpPr>
+          <p:cNvPr id="33" name="Text 31"/>
+          <p:cNvSpPr txBox="1"/>
+          <p:nvPr/>
+        </p:nvSpPr>
+        <p:spPr>
+          <a:xfrm>
+            <a:off x="4160520" y="5212080"/>
+            <a:ext cx="2331720" cy="548640"/>
           </a:xfrm>
           <a:prstGeom prst="rect">
             <a:avLst/>
@@ -1959,7 +2054,7 @@
                 <a:ea typeface="Arial" pitchFamily="34" charset="-122"/>
                 <a:cs typeface="Arial" pitchFamily="34" charset="-120"/>
               </a:rPr>
-              <a:t>Answers open questions by calling the data API as tools, citing seconds and frames.</a:t>
+              <a:t>Plans its own tool calls on the data API; cites seconds and frames.</a:t>
             </a:r>
             <a:endParaRPr lang="en-US" sz="1050" dirty="0"/>
           </a:p>
@@ -1967,38 +2062,38 @@
       </p:sp>
       <p:sp>
         <p:nvSpPr>
-          <p:cNvPr id="31" name="Text 29"/>
-          <p:cNvSpPr txBox="1"/>
-          <p:nvPr/>
-        </p:nvSpPr>
-        <p:spPr>
-          <a:xfrm>
-            <a:off x="4434840" y="5120640"/>
-            <a:ext cx="3611880" cy="182880"/>
-          </a:xfrm>
-          <a:prstGeom prst="rect">
-            <a:avLst/>
-          </a:prstGeom>
-          <a:noFill/>
-          <a:ln/>
-        </p:spPr>
-        <p:txBody>
-          <a:bodyPr wrap="square" lIns="0" tIns="0" rIns="0" bIns="0" rtlCol="0" anchor="t"/>
-          <a:lstStyle/>
-          <a:p>
-            <a:pPr indent="0" marL="0">
-              <a:buNone/>
-            </a:pPr>
-            <a:r>
-              <a:rPr lang="en-US" sz="900" b="1" spc="100" kern="0" dirty="0">
-                <a:solidFill>
-                  <a:srgbClr val="6F6C64"/>
-                </a:solidFill>
-                <a:latin typeface="Arial" pitchFamily="34" charset="0"/>
-                <a:ea typeface="Arial" pitchFamily="34" charset="-122"/>
-                <a:cs typeface="Arial" pitchFamily="34" charset="-120"/>
-              </a:rPr>
-              <a:t>LIVE DATA LAYER ON AIVEN</a:t>
+          <p:cNvPr id="34" name="Text 32"/>
+          <p:cNvSpPr txBox="1"/>
+          <p:nvPr/>
+        </p:nvSpPr>
+        <p:spPr>
+          <a:xfrm>
+            <a:off x="6858000" y="2340864"/>
+            <a:ext cx="2148840" cy="201168"/>
+          </a:xfrm>
+          <a:prstGeom prst="rect">
+            <a:avLst/>
+          </a:prstGeom>
+          <a:noFill/>
+          <a:ln/>
+        </p:spPr>
+        <p:txBody>
+          <a:bodyPr wrap="square" lIns="0" tIns="0" rIns="0" bIns="0" rtlCol="0" anchor="t"/>
+          <a:lstStyle/>
+          <a:p>
+            <a:pPr indent="0" marL="0">
+              <a:buNone/>
+            </a:pPr>
+            <a:r>
+              <a:rPr lang="en-US" sz="900" b="1" spc="120" kern="0" dirty="0">
+                <a:solidFill>
+                  <a:srgbClr val="C9A766"/>
+                </a:solidFill>
+                <a:latin typeface="Arial" pitchFamily="34" charset="0"/>
+                <a:ea typeface="Arial" pitchFamily="34" charset="-122"/>
+                <a:cs typeface="Arial" pitchFamily="34" charset="-120"/>
+              </a:rPr>
+              <a:t>03  DATA AT THE CORE</a:t>
             </a:r>
             <a:endParaRPr lang="en-US" sz="900" dirty="0"/>
           </a:p>
@@ -2006,18 +2101,60 @@
       </p:sp>
       <p:sp>
         <p:nvSpPr>
-          <p:cNvPr id="32" name="Shape 30"/>
+          <p:cNvPr id="35" name="Text 33"/>
+          <p:cNvSpPr txBox="1"/>
+          <p:nvPr/>
+        </p:nvSpPr>
+        <p:spPr>
+          <a:xfrm>
+            <a:off x="6858000" y="2615184"/>
+            <a:ext cx="2148840" cy="530352"/>
+          </a:xfrm>
+          <a:prstGeom prst="rect">
+            <a:avLst/>
+          </a:prstGeom>
+          <a:noFill/>
+          <a:ln/>
+        </p:spPr>
+        <p:txBody>
+          <a:bodyPr wrap="square" lIns="0" tIns="0" rIns="0" bIns="0" rtlCol="0" anchor="t"/>
+          <a:lstStyle/>
+          <a:p>
+            <a:pPr indent="0" marL="0">
+              <a:lnSpc>
+                <a:spcPct val="95000"/>
+              </a:lnSpc>
+              <a:buNone/>
+            </a:pPr>
+            <a:r>
+              <a:rPr lang="en-US" sz="1400" dirty="0">
+                <a:solidFill>
+                  <a:srgbClr val="EEE9DE"/>
+                </a:solidFill>
+                <a:latin typeface="Georgia" pitchFamily="34" charset="0"/>
+                <a:ea typeface="Georgia" pitchFamily="34" charset="-122"/>
+                <a:cs typeface="Georgia" pitchFamily="34" charset="-120"/>
+              </a:rPr>
+              <a:t>No live data, no product.</a:t>
+            </a:r>
+            <a:endParaRPr lang="en-US" sz="1400" dirty="0"/>
+          </a:p>
+        </p:txBody>
+      </p:sp>
+      <p:sp>
+        <p:nvSpPr>
+          <p:cNvPr id="36" name="Shape 34"/>
           <p:cNvSpPr/>
           <p:nvPr/>
         </p:nvSpPr>
         <p:spPr>
           <a:xfrm>
-            <a:off x="4434840" y="5367528"/>
-            <a:ext cx="658368" cy="292608"/>
+            <a:off x="6858000" y="3236976"/>
+            <a:ext cx="2148840" cy="512064"/>
           </a:xfrm>
           <a:prstGeom prst="roundRect">
             <a:avLst>
-              <a:gd name="adj" fmla="val 50000"/>
+              <a:gd name="adj" fmla="val 14286"/>
             </a:avLst>
           </a:prstGeom>
           <a:solidFill>
@@ -2033,30 +2170,30 @@
       </p:sp>
       <p:sp>
         <p:nvSpPr>
-          <p:cNvPr id="33" name="Text 31"/>
-          <p:cNvSpPr txBox="1"/>
-          <p:nvPr/>
-        </p:nvSpPr>
-        <p:spPr>
-          <a:xfrm>
-            <a:off x="4434840" y="5367528"/>
-            <a:ext cx="658368" cy="292608"/>
-          </a:xfrm>
-          <a:prstGeom prst="rect">
-            <a:avLst/>
-          </a:prstGeom>
-          <a:noFill/>
-          <a:ln/>
-        </p:spPr>
-        <p:txBody>
-          <a:bodyPr wrap="square" lIns="0" tIns="0" rIns="0" bIns="0" rtlCol="0" anchor="ctr"/>
-          <a:lstStyle/>
-          <a:p>
-            <a:pPr algn="ctr" indent="0" marL="0">
-              <a:buNone/>
-            </a:pPr>
-            <a:r>
-              <a:rPr lang="en-US" sz="950" dirty="0">
+          <p:cNvPr id="37" name="Text 35"/>
+          <p:cNvSpPr txBox="1"/>
+          <p:nvPr/>
+        </p:nvSpPr>
+        <p:spPr>
+          <a:xfrm>
+            <a:off x="6986016" y="3300984"/>
+            <a:ext cx="1892808" cy="182880"/>
+          </a:xfrm>
+          <a:prstGeom prst="rect">
+            <a:avLst/>
+          </a:prstGeom>
+          <a:noFill/>
+          <a:ln/>
+        </p:spPr>
+        <p:txBody>
+          <a:bodyPr wrap="square" lIns="0" tIns="0" rIns="0" bIns="0" rtlCol="0" anchor="t"/>
+          <a:lstStyle/>
+          <a:p>
+            <a:pPr indent="0" marL="0">
+              <a:buNone/>
+            </a:pPr>
+            <a:r>
+              <a:rPr lang="en-US" sz="1050" b="1" dirty="0">
                 <a:solidFill>
                   <a:srgbClr val="EEE9DE"/>
                 </a:solidFill>
@@ -2066,63 +2203,63 @@
               </a:rPr>
               <a:t>Kafka</a:t>
             </a:r>
-            <a:endParaRPr lang="en-US" sz="950" dirty="0"/>
-          </a:p>
-        </p:txBody>
-      </p:sp>
-      <p:sp>
-        <p:nvSpPr>
-          <p:cNvPr id="34" name="Text 32"/>
-          <p:cNvSpPr txBox="1"/>
-          <p:nvPr/>
-        </p:nvSpPr>
-        <p:spPr>
-          <a:xfrm>
-            <a:off x="5093208" y="5358384"/>
-            <a:ext cx="182880" cy="292608"/>
-          </a:xfrm>
-          <a:prstGeom prst="rect">
-            <a:avLst/>
-          </a:prstGeom>
-          <a:noFill/>
-          <a:ln/>
-        </p:spPr>
-        <p:txBody>
-          <a:bodyPr wrap="square" lIns="0" tIns="0" rIns="0" bIns="0" rtlCol="0" anchor="ctr"/>
-          <a:lstStyle/>
-          <a:p>
-            <a:pPr algn="ctr" indent="0" marL="0">
-              <a:buNone/>
-            </a:pPr>
-            <a:r>
-              <a:rPr lang="en-US" sz="1200" dirty="0">
-                <a:solidFill>
-                  <a:srgbClr val="C9A766"/>
-                </a:solidFill>
-                <a:latin typeface="Arial" pitchFamily="34" charset="0"/>
-                <a:ea typeface="Arial" pitchFamily="34" charset="-122"/>
-                <a:cs typeface="Arial" pitchFamily="34" charset="-120"/>
-              </a:rPr>
-              <a:t>›</a:t>
-            </a:r>
-            <a:endParaRPr lang="en-US" sz="1200" dirty="0"/>
-          </a:p>
-        </p:txBody>
-      </p:sp>
-      <p:sp>
-        <p:nvSpPr>
-          <p:cNvPr id="35" name="Shape 33"/>
+            <a:endParaRPr lang="en-US" sz="1050" dirty="0"/>
+          </a:p>
+        </p:txBody>
+      </p:sp>
+      <p:sp>
+        <p:nvSpPr>
+          <p:cNvPr id="38" name="Text 36"/>
+          <p:cNvSpPr txBox="1"/>
+          <p:nvPr/>
+        </p:nvSpPr>
+        <p:spPr>
+          <a:xfrm>
+            <a:off x="6986016" y="3502152"/>
+            <a:ext cx="1892808" cy="182880"/>
+          </a:xfrm>
+          <a:prstGeom prst="rect">
+            <a:avLst/>
+          </a:prstGeom>
+          <a:noFill/>
+          <a:ln/>
+        </p:spPr>
+        <p:txBody>
+          <a:bodyPr wrap="square" lIns="0" tIns="0" rIns="0" bIns="0" rtlCol="0" anchor="t"/>
+          <a:lstStyle/>
+          <a:p>
+            <a:pPr indent="0" marL="0">
+              <a:buNone/>
+            </a:pPr>
+            <a:r>
+              <a:rPr lang="en-US" sz="900" dirty="0">
+                <a:solidFill>
+                  <a:srgbClr val="A39F94"/>
+                </a:solidFill>
+                <a:latin typeface="Arial" pitchFamily="34" charset="0"/>
+                <a:ea typeface="Arial" pitchFamily="34" charset="-122"/>
+                <a:cs typeface="Arial" pitchFamily="34" charset="-120"/>
+              </a:rPr>
+              <a:t>frames + decisions, streamed</a:t>
+            </a:r>
+            <a:endParaRPr lang="en-US" sz="900" dirty="0"/>
+          </a:p>
+        </p:txBody>
+      </p:sp>
+      <p:sp>
+        <p:nvSpPr>
+          <p:cNvPr id="39" name="Shape 37"/>
           <p:cNvSpPr/>
           <p:nvPr/>
         </p:nvSpPr>
         <p:spPr>
           <a:xfrm>
-            <a:off x="5276088" y="5367528"/>
-            <a:ext cx="896112" cy="292608"/>
+            <a:off x="6858000" y="3877056"/>
+            <a:ext cx="2148840" cy="512064"/>
           </a:xfrm>
           <a:prstGeom prst="roundRect">
             <a:avLst>
-              <a:gd name="adj" fmla="val 50000"/>
+              <a:gd name="adj" fmla="val 14286"/>
             </a:avLst>
           </a:prstGeom>
           <a:solidFill>
@@ -2138,30 +2275,30 @@
       </p:sp>
       <p:sp>
         <p:nvSpPr>
-          <p:cNvPr id="36" name="Text 34"/>
-          <p:cNvSpPr txBox="1"/>
-          <p:nvPr/>
-        </p:nvSpPr>
-        <p:spPr>
-          <a:xfrm>
-            <a:off x="5276088" y="5367528"/>
-            <a:ext cx="896112" cy="292608"/>
-          </a:xfrm>
-          <a:prstGeom prst="rect">
-            <a:avLst/>
-          </a:prstGeom>
-          <a:noFill/>
-          <a:ln/>
-        </p:spPr>
-        <p:txBody>
-          <a:bodyPr wrap="square" lIns="0" tIns="0" rIns="0" bIns="0" rtlCol="0" anchor="ctr"/>
-          <a:lstStyle/>
-          <a:p>
-            <a:pPr algn="ctr" indent="0" marL="0">
-              <a:buNone/>
-            </a:pPr>
-            <a:r>
-              <a:rPr lang="en-US" sz="950" dirty="0">
+          <p:cNvPr id="40" name="Text 38"/>
+          <p:cNvSpPr txBox="1"/>
+          <p:nvPr/>
+        </p:nvSpPr>
+        <p:spPr>
+          <a:xfrm>
+            <a:off x="6986016" y="3941064"/>
+            <a:ext cx="1892808" cy="182880"/>
+          </a:xfrm>
+          <a:prstGeom prst="rect">
+            <a:avLst/>
+          </a:prstGeom>
+          <a:noFill/>
+          <a:ln/>
+        </p:spPr>
+        <p:txBody>
+          <a:bodyPr wrap="square" lIns="0" tIns="0" rIns="0" bIns="0" rtlCol="0" anchor="t"/>
+          <a:lstStyle/>
+          <a:p>
+            <a:pPr indent="0" marL="0">
+              <a:buNone/>
+            </a:pPr>
+            <a:r>
+              <a:rPr lang="en-US" sz="1050" b="1" dirty="0">
                 <a:solidFill>
                   <a:srgbClr val="EEE9DE"/>
                 </a:solidFill>
@@ -2171,63 +2308,63 @@
               </a:rPr>
               <a:t>ClickHouse</a:t>
             </a:r>
-            <a:endParaRPr lang="en-US" sz="950" dirty="0"/>
-          </a:p>
-        </p:txBody>
-      </p:sp>
-      <p:sp>
-        <p:nvSpPr>
-          <p:cNvPr id="37" name="Text 35"/>
-          <p:cNvSpPr txBox="1"/>
-          <p:nvPr/>
-        </p:nvSpPr>
-        <p:spPr>
-          <a:xfrm>
-            <a:off x="6172200" y="5358384"/>
-            <a:ext cx="182880" cy="292608"/>
-          </a:xfrm>
-          <a:prstGeom prst="rect">
-            <a:avLst/>
-          </a:prstGeom>
-          <a:noFill/>
-          <a:ln/>
-        </p:spPr>
-        <p:txBody>
-          <a:bodyPr wrap="square" lIns="0" tIns="0" rIns="0" bIns="0" rtlCol="0" anchor="ctr"/>
-          <a:lstStyle/>
-          <a:p>
-            <a:pPr algn="ctr" indent="0" marL="0">
-              <a:buNone/>
-            </a:pPr>
-            <a:r>
-              <a:rPr lang="en-US" sz="1200" dirty="0">
-                <a:solidFill>
-                  <a:srgbClr val="C9A766"/>
-                </a:solidFill>
-                <a:latin typeface="Arial" pitchFamily="34" charset="0"/>
-                <a:ea typeface="Arial" pitchFamily="34" charset="-122"/>
-                <a:cs typeface="Arial" pitchFamily="34" charset="-120"/>
-              </a:rPr>
-              <a:t>›</a:t>
-            </a:r>
-            <a:endParaRPr lang="en-US" sz="1200" dirty="0"/>
-          </a:p>
-        </p:txBody>
-      </p:sp>
-      <p:sp>
-        <p:nvSpPr>
-          <p:cNvPr id="38" name="Shape 36"/>
+            <a:endParaRPr lang="en-US" sz="1050" dirty="0"/>
+          </a:p>
+        </p:txBody>
+      </p:sp>
+      <p:sp>
+        <p:nvSpPr>
+          <p:cNvPr id="41" name="Text 39"/>
+          <p:cNvSpPr txBox="1"/>
+          <p:nvPr/>
+        </p:nvSpPr>
+        <p:spPr>
+          <a:xfrm>
+            <a:off x="6986016" y="4142232"/>
+            <a:ext cx="1892808" cy="182880"/>
+          </a:xfrm>
+          <a:prstGeom prst="rect">
+            <a:avLst/>
+          </a:prstGeom>
+          <a:noFill/>
+          <a:ln/>
+        </p:spPr>
+        <p:txBody>
+          <a:bodyPr wrap="square" lIns="0" tIns="0" rIns="0" bIns="0" rtlCol="0" anchor="t"/>
+          <a:lstStyle/>
+          <a:p>
+            <a:pPr indent="0" marL="0">
+              <a:buNone/>
+            </a:pPr>
+            <a:r>
+              <a:rPr lang="en-US" sz="900" dirty="0">
+                <a:solidFill>
+                  <a:srgbClr val="A39F94"/>
+                </a:solidFill>
+                <a:latin typeface="Arial" pitchFamily="34" charset="0"/>
+                <a:ea typeface="Arial" pitchFamily="34" charset="-122"/>
+                <a:cs typeface="Arial" pitchFamily="34" charset="-120"/>
+              </a:rPr>
+              <a:t>per-second intervals, coverage</a:t>
+            </a:r>
+            <a:endParaRPr lang="en-US" sz="900" dirty="0"/>
+          </a:p>
+        </p:txBody>
+      </p:sp>
+      <p:sp>
+        <p:nvSpPr>
+          <p:cNvPr id="42" name="Shape 40"/>
           <p:cNvSpPr/>
           <p:nvPr/>
         </p:nvSpPr>
         <p:spPr>
           <a:xfrm>
-            <a:off x="6355080" y="5367528"/>
-            <a:ext cx="658368" cy="292608"/>
+            <a:off x="6858000" y="4517136"/>
+            <a:ext cx="2148840" cy="512064"/>
           </a:xfrm>
           <a:prstGeom prst="roundRect">
             <a:avLst>
-              <a:gd name="adj" fmla="val 50000"/>
+              <a:gd name="adj" fmla="val 14286"/>
             </a:avLst>
           </a:prstGeom>
           <a:solidFill>
@@ -2243,30 +2380,30 @@
       </p:sp>
       <p:sp>
         <p:nvSpPr>
-          <p:cNvPr id="39" name="Text 37"/>
-          <p:cNvSpPr txBox="1"/>
-          <p:nvPr/>
-        </p:nvSpPr>
-        <p:spPr>
-          <a:xfrm>
-            <a:off x="6355080" y="5367528"/>
-            <a:ext cx="658368" cy="292608"/>
-          </a:xfrm>
-          <a:prstGeom prst="rect">
-            <a:avLst/>
-          </a:prstGeom>
-          <a:noFill/>
-          <a:ln/>
-        </p:spPr>
-        <p:txBody>
-          <a:bodyPr wrap="square" lIns="0" tIns="0" rIns="0" bIns="0" rtlCol="0" anchor="ctr"/>
-          <a:lstStyle/>
-          <a:p>
-            <a:pPr algn="ctr" indent="0" marL="0">
-              <a:buNone/>
-            </a:pPr>
-            <a:r>
-              <a:rPr lang="en-US" sz="950" dirty="0">
+          <p:cNvPr id="43" name="Text 41"/>
+          <p:cNvSpPr txBox="1"/>
+          <p:nvPr/>
+        </p:nvSpPr>
+        <p:spPr>
+          <a:xfrm>
+            <a:off x="6986016" y="4581144"/>
+            <a:ext cx="1892808" cy="182880"/>
+          </a:xfrm>
+          <a:prstGeom prst="rect">
+            <a:avLst/>
+          </a:prstGeom>
+          <a:noFill/>
+          <a:ln/>
+        </p:spPr>
+        <p:txBody>
+          <a:bodyPr wrap="square" lIns="0" tIns="0" rIns="0" bIns="0" rtlCol="0" anchor="t"/>
+          <a:lstStyle/>
+          <a:p>
+            <a:pPr indent="0" marL="0">
+              <a:buNone/>
+            </a:pPr>
+            <a:r>
+              <a:rPr lang="en-US" sz="1050" b="1" dirty="0">
                 <a:solidFill>
                   <a:srgbClr val="EEE9DE"/>
                 </a:solidFill>
@@ -2276,63 +2413,63 @@
               </a:rPr>
               <a:t>Valkey</a:t>
             </a:r>
-            <a:endParaRPr lang="en-US" sz="950" dirty="0"/>
-          </a:p>
-        </p:txBody>
-      </p:sp>
-      <p:sp>
-        <p:nvSpPr>
-          <p:cNvPr id="40" name="Text 38"/>
-          <p:cNvSpPr txBox="1"/>
-          <p:nvPr/>
-        </p:nvSpPr>
-        <p:spPr>
-          <a:xfrm>
-            <a:off x="7013448" y="5358384"/>
-            <a:ext cx="182880" cy="292608"/>
-          </a:xfrm>
-          <a:prstGeom prst="rect">
-            <a:avLst/>
-          </a:prstGeom>
-          <a:noFill/>
-          <a:ln/>
-        </p:spPr>
-        <p:txBody>
-          <a:bodyPr wrap="square" lIns="0" tIns="0" rIns="0" bIns="0" rtlCol="0" anchor="ctr"/>
-          <a:lstStyle/>
-          <a:p>
-            <a:pPr algn="ctr" indent="0" marL="0">
-              <a:buNone/>
-            </a:pPr>
-            <a:r>
-              <a:rPr lang="en-US" sz="1200" dirty="0">
-                <a:solidFill>
-                  <a:srgbClr val="C9A766"/>
-                </a:solidFill>
-                <a:latin typeface="Arial" pitchFamily="34" charset="0"/>
-                <a:ea typeface="Arial" pitchFamily="34" charset="-122"/>
-                <a:cs typeface="Arial" pitchFamily="34" charset="-120"/>
-              </a:rPr>
-              <a:t>›</a:t>
-            </a:r>
-            <a:endParaRPr lang="en-US" sz="1200" dirty="0"/>
-          </a:p>
-        </p:txBody>
-      </p:sp>
-      <p:sp>
-        <p:nvSpPr>
-          <p:cNvPr id="41" name="Shape 39"/>
+            <a:endParaRPr lang="en-US" sz="1050" dirty="0"/>
+          </a:p>
+        </p:txBody>
+      </p:sp>
+      <p:sp>
+        <p:nvSpPr>
+          <p:cNvPr id="44" name="Text 42"/>
+          <p:cNvSpPr txBox="1"/>
+          <p:nvPr/>
+        </p:nvSpPr>
+        <p:spPr>
+          <a:xfrm>
+            <a:off x="6986016" y="4782312"/>
+            <a:ext cx="1892808" cy="182880"/>
+          </a:xfrm>
+          <a:prstGeom prst="rect">
+            <a:avLst/>
+          </a:prstGeom>
+          <a:noFill/>
+          <a:ln/>
+        </p:spPr>
+        <p:txBody>
+          <a:bodyPr wrap="square" lIns="0" tIns="0" rIns="0" bIns="0" rtlCol="0" anchor="t"/>
+          <a:lstStyle/>
+          <a:p>
+            <a:pPr indent="0" marL="0">
+              <a:buNone/>
+            </a:pPr>
+            <a:r>
+              <a:rPr lang="en-US" sz="900" dirty="0">
+                <a:solidFill>
+                  <a:srgbClr val="A39F94"/>
+                </a:solidFill>
+                <a:latin typeface="Arial" pitchFamily="34" charset="0"/>
+                <a:ea typeface="Arial" pitchFamily="34" charset="-122"/>
+                <a:cs typeface="Arial" pitchFamily="34" charset="-120"/>
+              </a:rPr>
+              <a:t>live counters, atomic budget</a:t>
+            </a:r>
+            <a:endParaRPr lang="en-US" sz="900" dirty="0"/>
+          </a:p>
+        </p:txBody>
+      </p:sp>
+      <p:sp>
+        <p:nvSpPr>
+          <p:cNvPr id="45" name="Shape 43"/>
           <p:cNvSpPr/>
           <p:nvPr/>
         </p:nvSpPr>
         <p:spPr>
           <a:xfrm>
-            <a:off x="7196328" y="5367528"/>
-            <a:ext cx="795528" cy="292608"/>
+            <a:off x="6858000" y="5157216"/>
+            <a:ext cx="2148840" cy="512064"/>
           </a:xfrm>
           <a:prstGeom prst="roundRect">
             <a:avLst>
-              <a:gd name="adj" fmla="val 50000"/>
+              <a:gd name="adj" fmla="val 14286"/>
             </a:avLst>
           </a:prstGeom>
           <a:solidFill>
@@ -2348,30 +2485,30 @@
       </p:sp>
       <p:sp>
         <p:nvSpPr>
-          <p:cNvPr id="42" name="Text 40"/>
-          <p:cNvSpPr txBox="1"/>
-          <p:nvPr/>
-        </p:nvSpPr>
-        <p:spPr>
-          <a:xfrm>
-            <a:off x="7196328" y="5367528"/>
-            <a:ext cx="795528" cy="292608"/>
-          </a:xfrm>
-          <a:prstGeom prst="rect">
-            <a:avLst/>
-          </a:prstGeom>
-          <a:noFill/>
-          <a:ln/>
-        </p:spPr>
-        <p:txBody>
-          <a:bodyPr wrap="square" lIns="0" tIns="0" rIns="0" bIns="0" rtlCol="0" anchor="ctr"/>
-          <a:lstStyle/>
-          <a:p>
-            <a:pPr algn="ctr" indent="0" marL="0">
-              <a:buNone/>
-            </a:pPr>
-            <a:r>
-              <a:rPr lang="en-US" sz="950" dirty="0">
+          <p:cNvPr id="46" name="Text 44"/>
+          <p:cNvSpPr txBox="1"/>
+          <p:nvPr/>
+        </p:nvSpPr>
+        <p:spPr>
+          <a:xfrm>
+            <a:off x="6986016" y="5221224"/>
+            <a:ext cx="1892808" cy="182880"/>
+          </a:xfrm>
+          <a:prstGeom prst="rect">
+            <a:avLst/>
+          </a:prstGeom>
+          <a:noFill/>
+          <a:ln/>
+        </p:spPr>
+        <p:txBody>
+          <a:bodyPr wrap="square" lIns="0" tIns="0" rIns="0" bIns="0" rtlCol="0" anchor="t"/>
+          <a:lstStyle/>
+          <a:p>
+            <a:pPr indent="0" marL="0">
+              <a:buNone/>
+            </a:pPr>
+            <a:r>
+              <a:rPr lang="en-US" sz="1050" b="1" dirty="0">
                 <a:solidFill>
                   <a:srgbClr val="EEE9DE"/>
                 </a:solidFill>
@@ -2379,38 +2516,38 @@
                 <a:ea typeface="Arial" pitchFamily="34" charset="-122"/>
                 <a:cs typeface="Arial" pitchFamily="34" charset="-120"/>
               </a:rPr>
-              <a:t>Postgres</a:t>
-            </a:r>
-            <a:endParaRPr lang="en-US" sz="950" dirty="0"/>
-          </a:p>
-        </p:txBody>
-      </p:sp>
-      <p:sp>
-        <p:nvSpPr>
-          <p:cNvPr id="43" name="Text 41"/>
-          <p:cNvSpPr txBox="1"/>
-          <p:nvPr/>
-        </p:nvSpPr>
-        <p:spPr>
-          <a:xfrm>
-            <a:off x="4434840" y="5760720"/>
-            <a:ext cx="3611880" cy="228600"/>
-          </a:xfrm>
-          <a:prstGeom prst="rect">
-            <a:avLst/>
-          </a:prstGeom>
-          <a:noFill/>
-          <a:ln/>
-        </p:spPr>
-        <p:txBody>
-          <a:bodyPr wrap="square" lIns="0" tIns="0" rIns="0" bIns="0" rtlCol="0" anchor="t"/>
-          <a:lstStyle/>
-          <a:p>
-            <a:pPr indent="0" marL="0">
-              <a:buNone/>
-            </a:pPr>
-            <a:r>
-              <a:rPr lang="en-US" sz="950" i="1" dirty="0">
+              <a:t>Postgres + pgvector</a:t>
+            </a:r>
+            <a:endParaRPr lang="en-US" sz="1050" dirty="0"/>
+          </a:p>
+        </p:txBody>
+      </p:sp>
+      <p:sp>
+        <p:nvSpPr>
+          <p:cNvPr id="47" name="Text 45"/>
+          <p:cNvSpPr txBox="1"/>
+          <p:nvPr/>
+        </p:nvSpPr>
+        <p:spPr>
+          <a:xfrm>
+            <a:off x="6986016" y="5422392"/>
+            <a:ext cx="1892808" cy="182880"/>
+          </a:xfrm>
+          <a:prstGeom prst="rect">
+            <a:avLst/>
+          </a:prstGeom>
+          <a:noFill/>
+          <a:ln/>
+        </p:spPr>
+        <p:txBody>
+          <a:bodyPr wrap="square" lIns="0" tIns="0" rIns="0" bIns="0" rtlCol="0" anchor="t"/>
+          <a:lstStyle/>
+          <a:p>
+            <a:pPr indent="0" marL="0">
+              <a:buNone/>
+            </a:pPr>
+            <a:r>
+              <a:rPr lang="en-US" sz="900" dirty="0">
                 <a:solidFill>
                   <a:srgbClr val="A39F94"/>
                 </a:solidFill>
@@ -2418,38 +2555,38 @@
                 <a:ea typeface="Arial" pitchFamily="34" charset="-122"/>
                 <a:cs typeface="Arial" pitchFamily="34" charset="-120"/>
               </a:rPr>
-              <a:t>Unmeasured seconds are logged, never counted.</a:t>
-            </a:r>
-            <a:endParaRPr lang="en-US" sz="950" dirty="0"/>
-          </a:p>
-        </p:txBody>
-      </p:sp>
-      <p:sp>
-        <p:nvSpPr>
-          <p:cNvPr id="44" name="Text 42"/>
-          <p:cNvSpPr txBox="1"/>
-          <p:nvPr/>
-        </p:nvSpPr>
-        <p:spPr>
-          <a:xfrm>
-            <a:off x="8412480" y="2633472"/>
-            <a:ext cx="3227832" cy="228600"/>
-          </a:xfrm>
-          <a:prstGeom prst="rect">
-            <a:avLst/>
-          </a:prstGeom>
-          <a:noFill/>
-          <a:ln/>
-        </p:spPr>
-        <p:txBody>
-          <a:bodyPr wrap="square" lIns="0" tIns="0" rIns="0" bIns="0" rtlCol="0" anchor="t"/>
-          <a:lstStyle/>
-          <a:p>
-            <a:pPr indent="0" marL="0">
-              <a:buNone/>
-            </a:pPr>
-            <a:r>
-              <a:rPr lang="en-US" sz="1000" b="1" spc="150" kern="0" dirty="0">
+              <a:t>evidence frames, logo memory</a:t>
+            </a:r>
+            <a:endParaRPr lang="en-US" sz="900" dirty="0"/>
+          </a:p>
+        </p:txBody>
+      </p:sp>
+      <p:sp>
+        <p:nvSpPr>
+          <p:cNvPr id="48" name="Text 46"/>
+          <p:cNvSpPr txBox="1"/>
+          <p:nvPr/>
+        </p:nvSpPr>
+        <p:spPr>
+          <a:xfrm>
+            <a:off x="9372600" y="2340864"/>
+            <a:ext cx="2267712" cy="201168"/>
+          </a:xfrm>
+          <a:prstGeom prst="rect">
+            <a:avLst/>
+          </a:prstGeom>
+          <a:noFill/>
+          <a:ln/>
+        </p:spPr>
+        <p:txBody>
+          <a:bodyPr wrap="square" lIns="0" tIns="0" rIns="0" bIns="0" rtlCol="0" anchor="t"/>
+          <a:lstStyle/>
+          <a:p>
+            <a:pPr indent="0" marL="0">
+              <a:buNone/>
+            </a:pPr>
+            <a:r>
+              <a:rPr lang="en-US" sz="900" b="1" spc="120" kern="0" dirty="0">
                 <a:solidFill>
                   <a:srgbClr val="C9A766"/>
                 </a:solidFill>
@@ -2457,116 +2594,80 @@
                 <a:ea typeface="Arial" pitchFamily="34" charset="-122"/>
                 <a:cs typeface="Arial" pitchFamily="34" charset="-120"/>
               </a:rPr>
-              <a:t>03   EVIDENCE IT WORKS</a:t>
-            </a:r>
-            <a:endParaRPr lang="en-US" sz="1000" dirty="0"/>
-          </a:p>
-        </p:txBody>
-      </p:sp>
-      <p:sp>
-        <p:nvSpPr>
-          <p:cNvPr id="45" name="Text 43"/>
-          <p:cNvSpPr txBox="1"/>
-          <p:nvPr/>
-        </p:nvSpPr>
-        <p:spPr>
-          <a:xfrm>
-            <a:off x="8412480" y="2980944"/>
-            <a:ext cx="1554480" cy="438912"/>
-          </a:xfrm>
-          <a:prstGeom prst="rect">
-            <a:avLst/>
-          </a:prstGeom>
-          <a:noFill/>
-          <a:ln/>
-        </p:spPr>
-        <p:txBody>
-          <a:bodyPr wrap="square" lIns="0" tIns="0" rIns="0" bIns="0" rtlCol="0" anchor="t"/>
-          <a:lstStyle/>
-          <a:p>
-            <a:pPr indent="0" marL="0">
-              <a:buNone/>
-            </a:pPr>
-            <a:r>
-              <a:rPr lang="en-US" sz="2800" dirty="0">
-                <a:solidFill>
-                  <a:srgbClr val="C9A766"/>
+              <a:t>04  EVIDENCE IT WORKS</a:t>
+            </a:r>
+            <a:endParaRPr lang="en-US" sz="900" dirty="0"/>
+          </a:p>
+        </p:txBody>
+      </p:sp>
+      <p:sp>
+        <p:nvSpPr>
+          <p:cNvPr id="49" name="Text 47"/>
+          <p:cNvSpPr txBox="1"/>
+          <p:nvPr/>
+        </p:nvSpPr>
+        <p:spPr>
+          <a:xfrm>
+            <a:off x="9372600" y="2615184"/>
+            <a:ext cx="2267712" cy="530352"/>
+          </a:xfrm>
+          <a:prstGeom prst="rect">
+            <a:avLst/>
+          </a:prstGeom>
+          <a:noFill/>
+          <a:ln/>
+        </p:spPr>
+        <p:txBody>
+          <a:bodyPr wrap="square" lIns="0" tIns="0" rIns="0" bIns="0" rtlCol="0" anchor="t"/>
+          <a:lstStyle/>
+          <a:p>
+            <a:pPr indent="0" marL="0">
+              <a:lnSpc>
+                <a:spcPct val="95000"/>
+              </a:lnSpc>
+              <a:buNone/>
+            </a:pPr>
+            <a:r>
+              <a:rPr lang="en-US" sz="1400" dirty="0">
+                <a:solidFill>
+                  <a:srgbClr val="EEE9DE"/>
                 </a:solidFill>
                 <a:latin typeface="Georgia" pitchFamily="34" charset="0"/>
                 <a:ea typeface="Georgia" pitchFamily="34" charset="-122"/>
                 <a:cs typeface="Georgia" pitchFamily="34" charset="-120"/>
               </a:rPr>
-              <a:t>116</a:t>
-            </a:r>
-            <a:endParaRPr lang="en-US" sz="2800" dirty="0"/>
-          </a:p>
-        </p:txBody>
-      </p:sp>
-      <p:sp>
-        <p:nvSpPr>
-          <p:cNvPr id="46" name="Text 44"/>
-          <p:cNvSpPr txBox="1"/>
-          <p:nvPr/>
-        </p:nvSpPr>
-        <p:spPr>
-          <a:xfrm>
-            <a:off x="8412480" y="3419856"/>
-            <a:ext cx="1536192" cy="310896"/>
-          </a:xfrm>
-          <a:prstGeom prst="rect">
-            <a:avLst/>
-          </a:prstGeom>
-          <a:noFill/>
-          <a:ln/>
-        </p:spPr>
-        <p:txBody>
-          <a:bodyPr wrap="square" lIns="0" tIns="0" rIns="0" bIns="0" rtlCol="0" anchor="t"/>
-          <a:lstStyle/>
-          <a:p>
-            <a:pPr indent="0" marL="0">
-              <a:buNone/>
-            </a:pPr>
-            <a:r>
-              <a:rPr lang="en-US" sz="900" dirty="0">
-                <a:solidFill>
-                  <a:srgbClr val="A39F94"/>
-                </a:solidFill>
-                <a:latin typeface="Arial" pitchFamily="34" charset="0"/>
-                <a:ea typeface="Arial" pitchFamily="34" charset="-122"/>
-                <a:cs typeface="Arial" pitchFamily="34" charset="-120"/>
-              </a:rPr>
-              <a:t>frames read, 81 logo sightings</a:t>
-            </a:r>
-            <a:endParaRPr lang="en-US" sz="900" dirty="0"/>
-          </a:p>
-        </p:txBody>
-      </p:sp>
-      <p:sp>
-        <p:nvSpPr>
-          <p:cNvPr id="47" name="Text 45"/>
-          <p:cNvSpPr txBox="1"/>
-          <p:nvPr/>
-        </p:nvSpPr>
-        <p:spPr>
-          <a:xfrm>
-            <a:off x="10076688" y="2980944"/>
-            <a:ext cx="1554480" cy="438912"/>
-          </a:xfrm>
-          <a:prstGeom prst="rect">
-            <a:avLst/>
-          </a:prstGeom>
-          <a:noFill/>
-          <a:ln/>
-        </p:spPr>
-        <p:txBody>
-          <a:bodyPr wrap="square" lIns="0" tIns="0" rIns="0" bIns="0" rtlCol="0" anchor="t"/>
-          <a:lstStyle/>
-          <a:p>
-            <a:pPr indent="0" marL="0">
-              <a:buNone/>
-            </a:pPr>
-            <a:r>
-              <a:rPr lang="en-US" sz="2800" dirty="0">
+              <a:t>Measured on a real broadcast.</a:t>
+            </a:r>
+            <a:endParaRPr lang="en-US" sz="1400" dirty="0"/>
+          </a:p>
+        </p:txBody>
+      </p:sp>
+      <p:sp>
+        <p:nvSpPr>
+          <p:cNvPr id="50" name="Text 48"/>
+          <p:cNvSpPr txBox="1"/>
+          <p:nvPr/>
+        </p:nvSpPr>
+        <p:spPr>
+          <a:xfrm>
+            <a:off x="9372600" y="3163824"/>
+            <a:ext cx="1143000" cy="402336"/>
+          </a:xfrm>
+          <a:prstGeom prst="rect">
+            <a:avLst/>
+          </a:prstGeom>
+          <a:noFill/>
+          <a:ln/>
+        </p:spPr>
+        <p:txBody>
+          <a:bodyPr wrap="square" lIns="0" tIns="0" rIns="0" bIns="0" rtlCol="0" anchor="t"/>
+          <a:lstStyle/>
+          <a:p>
+            <a:pPr indent="0" marL="0">
+              <a:buNone/>
+            </a:pPr>
+            <a:r>
+              <a:rPr lang="en-US" sz="2400" dirty="0">
                 <a:solidFill>
                   <a:srgbClr val="C9A766"/>
                 </a:solidFill>
@@ -2574,38 +2675,38 @@
                 <a:ea typeface="Georgia" pitchFamily="34" charset="-122"/>
                 <a:cs typeface="Georgia" pitchFamily="34" charset="-120"/>
               </a:rPr>
-              <a:t>0</a:t>
-            </a:r>
-            <a:endParaRPr lang="en-US" sz="2800" dirty="0"/>
-          </a:p>
-        </p:txBody>
-      </p:sp>
-      <p:sp>
-        <p:nvSpPr>
-          <p:cNvPr id="48" name="Text 46"/>
-          <p:cNvSpPr txBox="1"/>
-          <p:nvPr/>
-        </p:nvSpPr>
-        <p:spPr>
-          <a:xfrm>
-            <a:off x="10076688" y="3419856"/>
-            <a:ext cx="1536192" cy="310896"/>
-          </a:xfrm>
-          <a:prstGeom prst="rect">
-            <a:avLst/>
-          </a:prstGeom>
-          <a:noFill/>
-          <a:ln/>
-        </p:spPr>
-        <p:txBody>
-          <a:bodyPr wrap="square" lIns="0" tIns="0" rIns="0" bIns="0" rtlCol="0" anchor="t"/>
-          <a:lstStyle/>
-          <a:p>
-            <a:pPr indent="0" marL="0">
-              <a:buNone/>
-            </a:pPr>
-            <a:r>
-              <a:rPr lang="en-US" sz="900" dirty="0">
+              <a:t>116</a:t>
+            </a:r>
+            <a:endParaRPr lang="en-US" sz="2400" dirty="0"/>
+          </a:p>
+        </p:txBody>
+      </p:sp>
+      <p:sp>
+        <p:nvSpPr>
+          <p:cNvPr id="51" name="Text 49"/>
+          <p:cNvSpPr txBox="1"/>
+          <p:nvPr/>
+        </p:nvSpPr>
+        <p:spPr>
+          <a:xfrm>
+            <a:off x="9372600" y="3566160"/>
+            <a:ext cx="1097280" cy="274320"/>
+          </a:xfrm>
+          <a:prstGeom prst="rect">
+            <a:avLst/>
+          </a:prstGeom>
+          <a:noFill/>
+          <a:ln/>
+        </p:spPr>
+        <p:txBody>
+          <a:bodyPr wrap="square" lIns="0" tIns="0" rIns="0" bIns="0" rtlCol="0" anchor="t"/>
+          <a:lstStyle/>
+          <a:p>
+            <a:pPr indent="0" marL="0">
+              <a:buNone/>
+            </a:pPr>
+            <a:r>
+              <a:rPr lang="en-US" sz="850" dirty="0">
                 <a:solidFill>
                   <a:srgbClr val="A39F94"/>
                 </a:solidFill>
@@ -2613,38 +2714,38 @@
                 <a:ea typeface="Arial" pitchFamily="34" charset="-122"/>
                 <a:cs typeface="Arial" pitchFamily="34" charset="-120"/>
               </a:rPr>
-              <a:t>failed calls, 0 off-list brands</a:t>
-            </a:r>
-            <a:endParaRPr lang="en-US" sz="900" dirty="0"/>
-          </a:p>
-        </p:txBody>
-      </p:sp>
-      <p:sp>
-        <p:nvSpPr>
-          <p:cNvPr id="49" name="Text 47"/>
-          <p:cNvSpPr txBox="1"/>
-          <p:nvPr/>
-        </p:nvSpPr>
-        <p:spPr>
-          <a:xfrm>
-            <a:off x="8412480" y="3767328"/>
-            <a:ext cx="1554480" cy="438912"/>
-          </a:xfrm>
-          <a:prstGeom prst="rect">
-            <a:avLst/>
-          </a:prstGeom>
-          <a:noFill/>
-          <a:ln/>
-        </p:spPr>
-        <p:txBody>
-          <a:bodyPr wrap="square" lIns="0" tIns="0" rIns="0" bIns="0" rtlCol="0" anchor="t"/>
-          <a:lstStyle/>
-          <a:p>
-            <a:pPr indent="0" marL="0">
-              <a:buNone/>
-            </a:pPr>
-            <a:r>
-              <a:rPr lang="en-US" sz="2800" dirty="0">
+              <a:t>frames read</a:t>
+            </a:r>
+            <a:endParaRPr lang="en-US" sz="850" dirty="0"/>
+          </a:p>
+        </p:txBody>
+      </p:sp>
+      <p:sp>
+        <p:nvSpPr>
+          <p:cNvPr id="52" name="Text 50"/>
+          <p:cNvSpPr txBox="1"/>
+          <p:nvPr/>
+        </p:nvSpPr>
+        <p:spPr>
+          <a:xfrm>
+            <a:off x="10561320" y="3163824"/>
+            <a:ext cx="1143000" cy="402336"/>
+          </a:xfrm>
+          <a:prstGeom prst="rect">
+            <a:avLst/>
+          </a:prstGeom>
+          <a:noFill/>
+          <a:ln/>
+        </p:spPr>
+        <p:txBody>
+          <a:bodyPr wrap="square" lIns="0" tIns="0" rIns="0" bIns="0" rtlCol="0" anchor="t"/>
+          <a:lstStyle/>
+          <a:p>
+            <a:pPr indent="0" marL="0">
+              <a:buNone/>
+            </a:pPr>
+            <a:r>
+              <a:rPr lang="en-US" sz="2400" dirty="0">
                 <a:solidFill>
                   <a:srgbClr val="C9A766"/>
                 </a:solidFill>
@@ -2652,38 +2753,38 @@
                 <a:ea typeface="Georgia" pitchFamily="34" charset="-122"/>
                 <a:cs typeface="Georgia" pitchFamily="34" charset="-120"/>
               </a:rPr>
-              <a:t>$0.12</a:t>
-            </a:r>
-            <a:endParaRPr lang="en-US" sz="2800" dirty="0"/>
-          </a:p>
-        </p:txBody>
-      </p:sp>
-      <p:sp>
-        <p:nvSpPr>
-          <p:cNvPr id="50" name="Text 48"/>
-          <p:cNvSpPr txBox="1"/>
-          <p:nvPr/>
-        </p:nvSpPr>
-        <p:spPr>
-          <a:xfrm>
-            <a:off x="8412480" y="4206240"/>
-            <a:ext cx="1536192" cy="310896"/>
-          </a:xfrm>
-          <a:prstGeom prst="rect">
-            <a:avLst/>
-          </a:prstGeom>
-          <a:noFill/>
-          <a:ln/>
-        </p:spPr>
-        <p:txBody>
-          <a:bodyPr wrap="square" lIns="0" tIns="0" rIns="0" bIns="0" rtlCol="0" anchor="t"/>
-          <a:lstStyle/>
-          <a:p>
-            <a:pPr indent="0" marL="0">
-              <a:buNone/>
-            </a:pPr>
-            <a:r>
-              <a:rPr lang="en-US" sz="900" dirty="0">
+              <a:t>0</a:t>
+            </a:r>
+            <a:endParaRPr lang="en-US" sz="2400" dirty="0"/>
+          </a:p>
+        </p:txBody>
+      </p:sp>
+      <p:sp>
+        <p:nvSpPr>
+          <p:cNvPr id="53" name="Text 51"/>
+          <p:cNvSpPr txBox="1"/>
+          <p:nvPr/>
+        </p:nvSpPr>
+        <p:spPr>
+          <a:xfrm>
+            <a:off x="10561320" y="3566160"/>
+            <a:ext cx="1097280" cy="274320"/>
+          </a:xfrm>
+          <a:prstGeom prst="rect">
+            <a:avLst/>
+          </a:prstGeom>
+          <a:noFill/>
+          <a:ln/>
+        </p:spPr>
+        <p:txBody>
+          <a:bodyPr wrap="square" lIns="0" tIns="0" rIns="0" bIns="0" rtlCol="0" anchor="t"/>
+          <a:lstStyle/>
+          <a:p>
+            <a:pPr indent="0" marL="0">
+              <a:buNone/>
+            </a:pPr>
+            <a:r>
+              <a:rPr lang="en-US" sz="850" dirty="0">
                 <a:solidFill>
                   <a:srgbClr val="A39F94"/>
                 </a:solidFill>
@@ -2691,38 +2792,38 @@
                 <a:ea typeface="Arial" pitchFamily="34" charset="-122"/>
                 <a:cs typeface="Arial" pitchFamily="34" charset="-120"/>
               </a:rPr>
-              <a:t>per match-minute</a:t>
-            </a:r>
-            <a:endParaRPr lang="en-US" sz="900" dirty="0"/>
-          </a:p>
-        </p:txBody>
-      </p:sp>
-      <p:sp>
-        <p:nvSpPr>
-          <p:cNvPr id="51" name="Text 49"/>
-          <p:cNvSpPr txBox="1"/>
-          <p:nvPr/>
-        </p:nvSpPr>
-        <p:spPr>
-          <a:xfrm>
-            <a:off x="10076688" y="3767328"/>
-            <a:ext cx="1554480" cy="438912"/>
-          </a:xfrm>
-          <a:prstGeom prst="rect">
-            <a:avLst/>
-          </a:prstGeom>
-          <a:noFill/>
-          <a:ln/>
-        </p:spPr>
-        <p:txBody>
-          <a:bodyPr wrap="square" lIns="0" tIns="0" rIns="0" bIns="0" rtlCol="0" anchor="t"/>
-          <a:lstStyle/>
-          <a:p>
-            <a:pPr indent="0" marL="0">
-              <a:buNone/>
-            </a:pPr>
-            <a:r>
-              <a:rPr lang="en-US" sz="2800" dirty="0">
+              <a:t>errors, off-list brands</a:t>
+            </a:r>
+            <a:endParaRPr lang="en-US" sz="850" dirty="0"/>
+          </a:p>
+        </p:txBody>
+      </p:sp>
+      <p:sp>
+        <p:nvSpPr>
+          <p:cNvPr id="54" name="Text 52"/>
+          <p:cNvSpPr txBox="1"/>
+          <p:nvPr/>
+        </p:nvSpPr>
+        <p:spPr>
+          <a:xfrm>
+            <a:off x="9372600" y="3895344"/>
+            <a:ext cx="1143000" cy="402336"/>
+          </a:xfrm>
+          <a:prstGeom prst="rect">
+            <a:avLst/>
+          </a:prstGeom>
+          <a:noFill/>
+          <a:ln/>
+        </p:spPr>
+        <p:txBody>
+          <a:bodyPr wrap="square" lIns="0" tIns="0" rIns="0" bIns="0" rtlCol="0" anchor="t"/>
+          <a:lstStyle/>
+          <a:p>
+            <a:pPr indent="0" marL="0">
+              <a:buNone/>
+            </a:pPr>
+            <a:r>
+              <a:rPr lang="en-US" sz="2400" dirty="0">
                 <a:solidFill>
                   <a:srgbClr val="C9A766"/>
                 </a:solidFill>
@@ -2730,38 +2831,116 @@
                 <a:ea typeface="Georgia" pitchFamily="34" charset="-122"/>
                 <a:cs typeface="Georgia" pitchFamily="34" charset="-120"/>
               </a:rPr>
+              <a:t>$0.12</a:t>
+            </a:r>
+            <a:endParaRPr lang="en-US" sz="2400" dirty="0"/>
+          </a:p>
+        </p:txBody>
+      </p:sp>
+      <p:sp>
+        <p:nvSpPr>
+          <p:cNvPr id="55" name="Text 53"/>
+          <p:cNvSpPr txBox="1"/>
+          <p:nvPr/>
+        </p:nvSpPr>
+        <p:spPr>
+          <a:xfrm>
+            <a:off x="9372600" y="4297680"/>
+            <a:ext cx="1097280" cy="274320"/>
+          </a:xfrm>
+          <a:prstGeom prst="rect">
+            <a:avLst/>
+          </a:prstGeom>
+          <a:noFill/>
+          <a:ln/>
+        </p:spPr>
+        <p:txBody>
+          <a:bodyPr wrap="square" lIns="0" tIns="0" rIns="0" bIns="0" rtlCol="0" anchor="t"/>
+          <a:lstStyle/>
+          <a:p>
+            <a:pPr indent="0" marL="0">
+              <a:buNone/>
+            </a:pPr>
+            <a:r>
+              <a:rPr lang="en-US" sz="850" dirty="0">
+                <a:solidFill>
+                  <a:srgbClr val="A39F94"/>
+                </a:solidFill>
+                <a:latin typeface="Arial" pitchFamily="34" charset="0"/>
+                <a:ea typeface="Arial" pitchFamily="34" charset="-122"/>
+                <a:cs typeface="Arial" pitchFamily="34" charset="-120"/>
+              </a:rPr>
+              <a:t>per match-minute</a:t>
+            </a:r>
+            <a:endParaRPr lang="en-US" sz="850" dirty="0"/>
+          </a:p>
+        </p:txBody>
+      </p:sp>
+      <p:sp>
+        <p:nvSpPr>
+          <p:cNvPr id="56" name="Text 54"/>
+          <p:cNvSpPr txBox="1"/>
+          <p:nvPr/>
+        </p:nvSpPr>
+        <p:spPr>
+          <a:xfrm>
+            <a:off x="10561320" y="3895344"/>
+            <a:ext cx="1143000" cy="402336"/>
+          </a:xfrm>
+          <a:prstGeom prst="rect">
+            <a:avLst/>
+          </a:prstGeom>
+          <a:noFill/>
+          <a:ln/>
+        </p:spPr>
+        <p:txBody>
+          <a:bodyPr wrap="square" lIns="0" tIns="0" rIns="0" bIns="0" rtlCol="0" anchor="t"/>
+          <a:lstStyle/>
+          <a:p>
+            <a:pPr indent="0" marL="0">
+              <a:buNone/>
+            </a:pPr>
+            <a:r>
+              <a:rPr lang="en-US" sz="2400" dirty="0">
+                <a:solidFill>
+                  <a:srgbClr val="C9A766"/>
+                </a:solidFill>
+                <a:latin typeface="Georgia" pitchFamily="34" charset="0"/>
+                <a:ea typeface="Georgia" pitchFamily="34" charset="-122"/>
+                <a:cs typeface="Georgia" pitchFamily="34" charset="-120"/>
+              </a:rPr>
               <a:t>96%</a:t>
             </a:r>
-            <a:endParaRPr lang="en-US" sz="2800" dirty="0"/>
-          </a:p>
-        </p:txBody>
-      </p:sp>
-      <p:sp>
-        <p:nvSpPr>
-          <p:cNvPr id="52" name="Text 50"/>
-          <p:cNvSpPr txBox="1"/>
-          <p:nvPr/>
-        </p:nvSpPr>
-        <p:spPr>
-          <a:xfrm>
-            <a:off x="10076688" y="4206240"/>
-            <a:ext cx="1536192" cy="310896"/>
-          </a:xfrm>
-          <a:prstGeom prst="rect">
-            <a:avLst/>
-          </a:prstGeom>
-          <a:noFill/>
-          <a:ln/>
-        </p:spPr>
-        <p:txBody>
-          <a:bodyPr wrap="square" lIns="0" tIns="0" rIns="0" bIns="0" rtlCol="0" anchor="t"/>
-          <a:lstStyle/>
-          <a:p>
-            <a:pPr indent="0" marL="0">
-              <a:buNone/>
-            </a:pPr>
-            <a:r>
-              <a:rPr lang="en-US" sz="900" dirty="0">
+            <a:endParaRPr lang="en-US" sz="2400" dirty="0"/>
+          </a:p>
+        </p:txBody>
+      </p:sp>
+      <p:sp>
+        <p:nvSpPr>
+          <p:cNvPr id="57" name="Text 55"/>
+          <p:cNvSpPr txBox="1"/>
+          <p:nvPr/>
+        </p:nvSpPr>
+        <p:spPr>
+          <a:xfrm>
+            <a:off x="10561320" y="4297680"/>
+            <a:ext cx="1097280" cy="274320"/>
+          </a:xfrm>
+          <a:prstGeom prst="rect">
+            <a:avLst/>
+          </a:prstGeom>
+          <a:noFill/>
+          <a:ln/>
+        </p:spPr>
+        <p:txBody>
+          <a:bodyPr wrap="square" lIns="0" tIns="0" rIns="0" bIns="0" rtlCol="0" anchor="t"/>
+          <a:lstStyle/>
+          <a:p>
+            <a:pPr indent="0" marL="0">
+              <a:buNone/>
+            </a:pPr>
+            <a:r>
+              <a:rPr lang="en-US" sz="850" dirty="0">
                 <a:solidFill>
                   <a:srgbClr val="A39F94"/>
                 </a:solidFill>
@@ -2771,36 +2950,36 @@
               </a:rPr>
               <a:t>pilot vs 18–56% OCR*</a:t>
             </a:r>
-            <a:endParaRPr lang="en-US" sz="900" dirty="0"/>
-          </a:p>
-        </p:txBody>
-      </p:sp>
-      <p:sp>
-        <p:nvSpPr>
-          <p:cNvPr id="53" name="Text 51"/>
-          <p:cNvSpPr txBox="1"/>
-          <p:nvPr/>
-        </p:nvSpPr>
-        <p:spPr>
-          <a:xfrm>
-            <a:off x="8412480" y="4645152"/>
-            <a:ext cx="3227832" cy="182880"/>
-          </a:xfrm>
-          <a:prstGeom prst="rect">
-            <a:avLst/>
-          </a:prstGeom>
-          <a:noFill/>
-          <a:ln/>
-        </p:spPr>
-        <p:txBody>
-          <a:bodyPr wrap="square" lIns="0" tIns="0" rIns="0" bIns="0" rtlCol="0" anchor="t"/>
-          <a:lstStyle/>
-          <a:p>
-            <a:pPr indent="0" marL="0">
-              <a:buNone/>
-            </a:pPr>
-            <a:r>
-              <a:rPr lang="en-US" sz="900" b="1" spc="100" kern="0" dirty="0">
+            <a:endParaRPr lang="en-US" sz="850" dirty="0"/>
+          </a:p>
+        </p:txBody>
+      </p:sp>
+      <p:sp>
+        <p:nvSpPr>
+          <p:cNvPr id="58" name="Text 56"/>
+          <p:cNvSpPr txBox="1"/>
+          <p:nvPr/>
+        </p:nvSpPr>
+        <p:spPr>
+          <a:xfrm>
+            <a:off x="9372600" y="4700016"/>
+            <a:ext cx="2267712" cy="182880"/>
+          </a:xfrm>
+          <a:prstGeom prst="rect">
+            <a:avLst/>
+          </a:prstGeom>
+          <a:noFill/>
+          <a:ln/>
+        </p:spPr>
+        <p:txBody>
+          <a:bodyPr wrap="square" lIns="0" tIns="0" rIns="0" bIns="0" rtlCol="0" anchor="t"/>
+          <a:lstStyle/>
+          <a:p>
+            <a:pPr indent="0" marL="0">
+              <a:buNone/>
+            </a:pPr>
+            <a:r>
+              <a:rPr lang="en-US" sz="850" b="1" spc="100" kern="0" dirty="0">
                 <a:solidFill>
                   <a:srgbClr val="6F6C64"/>
                 </a:solidFill>
@@ -2810,20 +2989,20 @@
               </a:rPr>
               <a:t>SCREEN TIME, 58 s UCL SEGMENT</a:t>
             </a:r>
-            <a:endParaRPr lang="en-US" sz="900" dirty="0"/>
-          </a:p>
-        </p:txBody>
-      </p:sp>
-      <p:sp>
-        <p:nvSpPr>
-          <p:cNvPr id="54" name="Text 52"/>
-          <p:cNvSpPr txBox="1"/>
-          <p:nvPr/>
-        </p:nvSpPr>
-        <p:spPr>
-          <a:xfrm>
-            <a:off x="8412480" y="4919472"/>
-            <a:ext cx="868680" cy="164592"/>
+            <a:endParaRPr lang="en-US" sz="850" dirty="0"/>
+          </a:p>
+        </p:txBody>
+      </p:sp>
+      <p:sp>
+        <p:nvSpPr>
+          <p:cNvPr id="59" name="Text 57"/>
+          <p:cNvSpPr txBox="1"/>
+          <p:nvPr/>
+        </p:nvSpPr>
+        <p:spPr>
+          <a:xfrm>
+            <a:off x="9372600" y="4956048"/>
+            <a:ext cx="749808" cy="164592"/>
           </a:xfrm>
           <a:prstGeom prst="rect">
             <a:avLst/>
@@ -2839,7 +3018,7 @@
               <a:buNone/>
             </a:pPr>
             <a:r>
-              <a:rPr lang="en-US" sz="900" dirty="0">
+              <a:rPr lang="en-US" sz="850" dirty="0">
                 <a:solidFill>
                   <a:srgbClr val="EEE9DE"/>
                 </a:solidFill>
@@ -2849,20 +3028,20 @@
               </a:rPr>
               <a:t>FedEx</a:t>
             </a:r>
-            <a:endParaRPr lang="en-US" sz="900" dirty="0"/>
-          </a:p>
-        </p:txBody>
-      </p:sp>
-      <p:sp>
-        <p:nvSpPr>
-          <p:cNvPr id="55" name="Shape 53"/>
+            <a:endParaRPr lang="en-US" sz="850" dirty="0"/>
+          </a:p>
+        </p:txBody>
+      </p:sp>
+      <p:sp>
+        <p:nvSpPr>
+          <p:cNvPr id="60" name="Shape 58"/>
           <p:cNvSpPr/>
           <p:nvPr/>
         </p:nvSpPr>
         <p:spPr>
           <a:xfrm>
-            <a:off x="9326880" y="4965192"/>
-            <a:ext cx="1828800" cy="73152"/>
+            <a:off x="10149840" y="5001768"/>
+            <a:ext cx="1051560" cy="73152"/>
           </a:xfrm>
           <a:prstGeom prst="rect">
             <a:avLst/>
@@ -2875,14 +3054,14 @@
       </p:sp>
       <p:sp>
         <p:nvSpPr>
-          <p:cNvPr id="56" name="Shape 54"/>
+          <p:cNvPr id="61" name="Shape 59"/>
           <p:cNvSpPr/>
           <p:nvPr/>
         </p:nvSpPr>
         <p:spPr>
           <a:xfrm>
-            <a:off x="9326880" y="4965192"/>
-            <a:ext cx="1828800" cy="73152"/>
+            <a:off x="10149840" y="5001768"/>
+            <a:ext cx="1051560" cy="73152"/>
           </a:xfrm>
           <a:prstGeom prst="rect">
             <a:avLst/>
@@ -2895,14 +3074,14 @@
       </p:sp>
       <p:sp>
         <p:nvSpPr>
-          <p:cNvPr id="57" name="Text 55"/>
-          <p:cNvSpPr txBox="1"/>
-          <p:nvPr/>
-        </p:nvSpPr>
-        <p:spPr>
-          <a:xfrm>
-            <a:off x="11228832" y="4919472"/>
-            <a:ext cx="411480" cy="164592"/>
+          <p:cNvPr id="62" name="Text 60"/>
+          <p:cNvSpPr txBox="1"/>
+          <p:nvPr/>
+        </p:nvSpPr>
+        <p:spPr>
+          <a:xfrm>
+            <a:off x="11247120" y="4956048"/>
+            <a:ext cx="393192" cy="164592"/>
           </a:xfrm>
           <a:prstGeom prst="rect">
             <a:avLst/>
@@ -2918,7 +3097,7 @@
               <a:buNone/>
             </a:pPr>
             <a:r>
-              <a:rPr lang="en-US" sz="900" dirty="0">
+              <a:rPr lang="en-US" sz="850" dirty="0">
                 <a:solidFill>
                   <a:srgbClr val="A39F94"/>
                 </a:solidFill>
@@ -2928,20 +3107,20 @@
               </a:rPr>
               <a:t>20.0 s</a:t>
             </a:r>
-            <a:endParaRPr lang="en-US" sz="900" dirty="0"/>
-          </a:p>
-        </p:txBody>
-      </p:sp>
-      <p:sp>
-        <p:nvSpPr>
-          <p:cNvPr id="58" name="Text 56"/>
-          <p:cNvSpPr txBox="1"/>
-          <p:nvPr/>
-        </p:nvSpPr>
-        <p:spPr>
-          <a:xfrm>
-            <a:off x="8412480" y="5148072"/>
-            <a:ext cx="868680" cy="164592"/>
+            <a:endParaRPr lang="en-US" sz="850" dirty="0"/>
+          </a:p>
+        </p:txBody>
+      </p:sp>
+      <p:sp>
+        <p:nvSpPr>
+          <p:cNvPr id="63" name="Text 61"/>
+          <p:cNvSpPr txBox="1"/>
+          <p:nvPr/>
+        </p:nvSpPr>
+        <p:spPr>
+          <a:xfrm>
+            <a:off x="9372600" y="5175504"/>
+            <a:ext cx="749808" cy="164592"/>
           </a:xfrm>
           <a:prstGeom prst="rect">
             <a:avLst/>
@@ -2957,7 +3136,7 @@
               <a:buNone/>
             </a:pPr>
             <a:r>
-              <a:rPr lang="en-US" sz="900" dirty="0">
+              <a:rPr lang="en-US" sz="850" dirty="0">
                 <a:solidFill>
                   <a:srgbClr val="EEE9DE"/>
                 </a:solidFill>
@@ -2967,20 +3146,20 @@
               </a:rPr>
               <a:t>PlayStation</a:t>
             </a:r>
-            <a:endParaRPr lang="en-US" sz="900" dirty="0"/>
-          </a:p>
-        </p:txBody>
-      </p:sp>
-      <p:sp>
-        <p:nvSpPr>
-          <p:cNvPr id="59" name="Shape 57"/>
+            <a:endParaRPr lang="en-US" sz="850" dirty="0"/>
+          </a:p>
+        </p:txBody>
+      </p:sp>
+      <p:sp>
+        <p:nvSpPr>
+          <p:cNvPr id="64" name="Shape 62"/>
           <p:cNvSpPr/>
           <p:nvPr/>
         </p:nvSpPr>
         <p:spPr>
           <a:xfrm>
-            <a:off x="9326880" y="5193792"/>
-            <a:ext cx="1828800" cy="73152"/>
+            <a:off x="10149840" y="5221224"/>
+            <a:ext cx="1051560" cy="73152"/>
           </a:xfrm>
           <a:prstGeom prst="rect">
             <a:avLst/>
@@ -2993,14 +3172,14 @@
       </p:sp>
       <p:sp>
         <p:nvSpPr>
-          <p:cNvPr id="60" name="Shape 58"/>
+          <p:cNvPr id="65" name="Shape 63"/>
           <p:cNvSpPr/>
           <p:nvPr/>
         </p:nvSpPr>
         <p:spPr>
           <a:xfrm>
-            <a:off x="9326880" y="5193792"/>
-            <a:ext cx="1097280" cy="73152"/>
+            <a:off x="10149840" y="5221224"/>
+            <a:ext cx="630936" cy="73152"/>
           </a:xfrm>
           <a:prstGeom prst="rect">
             <a:avLst/>
@@ -3013,14 +3192,14 @@
       </p:sp>
       <p:sp>
         <p:nvSpPr>
-          <p:cNvPr id="61" name="Text 59"/>
-          <p:cNvSpPr txBox="1"/>
-          <p:nvPr/>
-        </p:nvSpPr>
-        <p:spPr>
-          <a:xfrm>
-            <a:off x="11228832" y="5148072"/>
-            <a:ext cx="411480" cy="164592"/>
+          <p:cNvPr id="66" name="Text 64"/>
+          <p:cNvSpPr txBox="1"/>
+          <p:nvPr/>
+        </p:nvSpPr>
+        <p:spPr>
+          <a:xfrm>
+            <a:off x="11247120" y="5175504"/>
+            <a:ext cx="393192" cy="164592"/>
           </a:xfrm>
           <a:prstGeom prst="rect">
             <a:avLst/>
@@ -3036,7 +3215,7 @@
               <a:buNone/>
             </a:pPr>
             <a:r>
-              <a:rPr lang="en-US" sz="900" dirty="0">
+              <a:rPr lang="en-US" sz="850" dirty="0">
                 <a:solidFill>
                   <a:srgbClr val="A39F94"/>
                 </a:solidFill>
@@ -3046,20 +3225,20 @@
               </a:rPr>
               <a:t>12.0 s</a:t>
             </a:r>
-            <a:endParaRPr lang="en-US" sz="900" dirty="0"/>
-          </a:p>
-        </p:txBody>
-      </p:sp>
-      <p:sp>
-        <p:nvSpPr>
-          <p:cNvPr id="62" name="Text 60"/>
-          <p:cNvSpPr txBox="1"/>
-          <p:nvPr/>
-        </p:nvSpPr>
-        <p:spPr>
-          <a:xfrm>
-            <a:off x="8412480" y="5376672"/>
-            <a:ext cx="868680" cy="164592"/>
+            <a:endParaRPr lang="en-US" sz="850" dirty="0"/>
+          </a:p>
+        </p:txBody>
+      </p:sp>
+      <p:sp>
+        <p:nvSpPr>
+          <p:cNvPr id="67" name="Text 65"/>
+          <p:cNvSpPr txBox="1"/>
+          <p:nvPr/>
+        </p:nvSpPr>
+        <p:spPr>
+          <a:xfrm>
+            <a:off x="9372600" y="5394960"/>
+            <a:ext cx="749808" cy="164592"/>
           </a:xfrm>
           <a:prstGeom prst="rect">
             <a:avLst/>
@@ -3075,7 +3254,7 @@
               <a:buNone/>
             </a:pPr>
             <a:r>
-              <a:rPr lang="en-US" sz="900" dirty="0">
+              <a:rPr lang="en-US" sz="850" dirty="0">
                 <a:solidFill>
                   <a:srgbClr val="EEE9DE"/>
                 </a:solidFill>
@@ -3085,20 +3264,20 @@
               </a:rPr>
               <a:t>Heineken</a:t>
             </a:r>
-            <a:endParaRPr lang="en-US" sz="900" dirty="0"/>
-          </a:p>
-        </p:txBody>
-      </p:sp>
-      <p:sp>
-        <p:nvSpPr>
-          <p:cNvPr id="63" name="Shape 61"/>
+            <a:endParaRPr lang="en-US" sz="850" dirty="0"/>
+          </a:p>
+        </p:txBody>
+      </p:sp>
+      <p:sp>
+        <p:nvSpPr>
+          <p:cNvPr id="68" name="Shape 66"/>
           <p:cNvSpPr/>
           <p:nvPr/>
         </p:nvSpPr>
         <p:spPr>
           <a:xfrm>
-            <a:off x="9326880" y="5422392"/>
-            <a:ext cx="1828800" cy="73152"/>
+            <a:off x="10149840" y="5440680"/>
+            <a:ext cx="1051560" cy="73152"/>
           </a:xfrm>
           <a:prstGeom prst="rect">
             <a:avLst/>
@@ -3111,14 +3290,14 @@
       </p:sp>
       <p:sp>
         <p:nvSpPr>
-          <p:cNvPr id="64" name="Shape 62"/>
+          <p:cNvPr id="69" name="Shape 67"/>
           <p:cNvSpPr/>
           <p:nvPr/>
         </p:nvSpPr>
         <p:spPr>
           <a:xfrm>
-            <a:off x="9326880" y="5422392"/>
-            <a:ext cx="594360" cy="73152"/>
+            <a:off x="10149840" y="5440680"/>
+            <a:ext cx="341757" cy="73152"/>
           </a:xfrm>
           <a:prstGeom prst="rect">
             <a:avLst/>
@@ -3131,14 +3310,14 @@
       </p:sp>
       <p:sp>
         <p:nvSpPr>
-          <p:cNvPr id="65" name="Text 63"/>
-          <p:cNvSpPr txBox="1"/>
-          <p:nvPr/>
-        </p:nvSpPr>
-        <p:spPr>
-          <a:xfrm>
-            <a:off x="11228832" y="5376672"/>
-            <a:ext cx="411480" cy="164592"/>
+          <p:cNvPr id="70" name="Text 68"/>
+          <p:cNvSpPr txBox="1"/>
+          <p:nvPr/>
+        </p:nvSpPr>
+        <p:spPr>
+          <a:xfrm>
+            <a:off x="11247120" y="5394960"/>
+            <a:ext cx="393192" cy="164592"/>
           </a:xfrm>
           <a:prstGeom prst="rect">
             <a:avLst/>
@@ -3154,7 +3333,7 @@
               <a:buNone/>
             </a:pPr>
             <a:r>
-              <a:rPr lang="en-US" sz="900" dirty="0">
+              <a:rPr lang="en-US" sz="850" dirty="0">
                 <a:solidFill>
                   <a:srgbClr val="A39F94"/>
                 </a:solidFill>
@@ -3164,20 +3343,20 @@
               </a:rPr>
               <a:t>6.5 s</a:t>
             </a:r>
-            <a:endParaRPr lang="en-US" sz="900" dirty="0"/>
-          </a:p>
-        </p:txBody>
-      </p:sp>
-      <p:sp>
-        <p:nvSpPr>
-          <p:cNvPr id="66" name="Text 64"/>
-          <p:cNvSpPr txBox="1"/>
-          <p:nvPr/>
-        </p:nvSpPr>
-        <p:spPr>
-          <a:xfrm>
-            <a:off x="8412480" y="5605272"/>
-            <a:ext cx="868680" cy="164592"/>
+            <a:endParaRPr lang="en-US" sz="850" dirty="0"/>
+          </a:p>
+        </p:txBody>
+      </p:sp>
+      <p:sp>
+        <p:nvSpPr>
+          <p:cNvPr id="71" name="Text 69"/>
+          <p:cNvSpPr txBox="1"/>
+          <p:nvPr/>
+        </p:nvSpPr>
+        <p:spPr>
+          <a:xfrm>
+            <a:off x="9372600" y="5614416"/>
+            <a:ext cx="749808" cy="164592"/>
           </a:xfrm>
           <a:prstGeom prst="rect">
             <a:avLst/>
@@ -3193,7 +3372,7 @@
               <a:buNone/>
             </a:pPr>
             <a:r>
-              <a:rPr lang="en-US" sz="900" dirty="0">
+              <a:rPr lang="en-US" sz="850" dirty="0">
                 <a:solidFill>
                   <a:srgbClr val="EEE9DE"/>
                 </a:solidFill>
@@ -3203,20 +3382,20 @@
               </a:rPr>
               <a:t>Mastercard</a:t>
             </a:r>
-            <a:endParaRPr lang="en-US" sz="900" dirty="0"/>
-          </a:p>
-        </p:txBody>
-      </p:sp>
-      <p:sp>
-        <p:nvSpPr>
-          <p:cNvPr id="67" name="Shape 65"/>
+            <a:endParaRPr lang="en-US" sz="850" dirty="0"/>
+          </a:p>
+        </p:txBody>
+      </p:sp>
+      <p:sp>
+        <p:nvSpPr>
+          <p:cNvPr id="72" name="Shape 70"/>
           <p:cNvSpPr/>
           <p:nvPr/>
         </p:nvSpPr>
         <p:spPr>
           <a:xfrm>
-            <a:off x="9326880" y="5650992"/>
-            <a:ext cx="1828800" cy="73152"/>
+            <a:off x="10149840" y="5660136"/>
+            <a:ext cx="1051560" cy="73152"/>
           </a:xfrm>
           <a:prstGeom prst="rect">
             <a:avLst/>
@@ -3229,14 +3408,14 @@
       </p:sp>
       <p:sp>
         <p:nvSpPr>
-          <p:cNvPr id="68" name="Shape 66"/>
+          <p:cNvPr id="73" name="Shape 71"/>
           <p:cNvSpPr/>
           <p:nvPr/>
         </p:nvSpPr>
         <p:spPr>
           <a:xfrm>
-            <a:off x="9326880" y="5650992"/>
-            <a:ext cx="91440" cy="73152"/>
+            <a:off x="10149840" y="5660136"/>
+            <a:ext cx="52578" cy="73152"/>
           </a:xfrm>
           <a:prstGeom prst="rect">
             <a:avLst/>
@@ -3249,14 +3428,14 @@
       </p:sp>
       <p:sp>
         <p:nvSpPr>
-          <p:cNvPr id="69" name="Text 67"/>
-          <p:cNvSpPr txBox="1"/>
-          <p:nvPr/>
-        </p:nvSpPr>
-        <p:spPr>
-          <a:xfrm>
-            <a:off x="11228832" y="5605272"/>
-            <a:ext cx="411480" cy="164592"/>
+          <p:cNvPr id="74" name="Text 72"/>
+          <p:cNvSpPr txBox="1"/>
+          <p:nvPr/>
+        </p:nvSpPr>
+        <p:spPr>
+          <a:xfrm>
+            <a:off x="11247120" y="5614416"/>
+            <a:ext cx="393192" cy="164592"/>
           </a:xfrm>
           <a:prstGeom prst="rect">
             <a:avLst/>
@@ -3272,7 +3451,7 @@
               <a:buNone/>
             </a:pPr>
             <a:r>
-              <a:rPr lang="en-US" sz="900" dirty="0">
+              <a:rPr lang="en-US" sz="850" dirty="0">
                 <a:solidFill>
                   <a:srgbClr val="A39F94"/>
                 </a:solidFill>
@@ -3282,13 +3461,13 @@
               </a:rPr>
               <a:t>1.0 s</a:t>
             </a:r>
-            <a:endParaRPr lang="en-US" sz="900" dirty="0"/>
-          </a:p>
-        </p:txBody>
-      </p:sp>
-      <p:sp>
-        <p:nvSpPr>
-          <p:cNvPr id="70" name="Shape 68"/>
+            <a:endParaRPr lang="en-US" sz="850" dirty="0"/>
+          </a:p>
+        </p:txBody>
+      </p:sp>
+      <p:sp>
+        <p:nvSpPr>
+          <p:cNvPr id="75" name="Shape 73"/>
           <p:cNvSpPr/>
           <p:nvPr/>
         </p:nvSpPr>
@@ -3311,14 +3490,14 @@
       </p:sp>
       <p:sp>
         <p:nvSpPr>
-          <p:cNvPr id="71" name="Text 69"/>
+          <p:cNvPr id="76" name="Text 74"/>
           <p:cNvSpPr txBox="1"/>
           <p:nvPr/>
         </p:nvSpPr>
         <p:spPr>
           <a:xfrm>
             <a:off x="548640" y="6144768"/>
-            <a:ext cx="8595360" cy="274320"/>
+            <a:ext cx="9326880" cy="274320"/>
           </a:xfrm>
           <a:prstGeom prst="rect">
             <a:avLst/>
@@ -3334,7 +3513,7 @@
               <a:buNone/>
             </a:pPr>
             <a:r>
-              <a:rPr lang="en-US" sz="1000" b="1" spc="100" kern="0" dirty="0">
+              <a:rPr lang="en-US" sz="900" b="1" spc="120" kern="0" dirty="0">
                 <a:solidFill>
                   <a:srgbClr val="C9A766"/>
                 </a:solidFill>
@@ -3342,13 +3521,13 @@
                 <a:ea typeface="Arial" pitchFamily="34" charset="-122"/>
                 <a:cs typeface="Arial" pitchFamily="34" charset="-120"/>
               </a:rPr>
-              <a:t>WHY US  </a:t>
-            </a:r>
-            <a:pPr indent="0" marL="0">
-              <a:buNone/>
-            </a:pPr>
-            <a:r>
-              <a:rPr lang="en-US" sz="1300" i="1" dirty="0">
+              <a:t>05  EXECUTION &amp; PITCH   </a:t>
+            </a:r>
+            <a:pPr indent="0" marL="0">
+              <a:buNone/>
+            </a:pPr>
+            <a:r>
+              <a:rPr lang="en-US" sz="1250" i="1" dirty="0">
                 <a:solidFill>
                   <a:srgbClr val="EEE9DE"/>
                 </a:solidFill>
@@ -3356,15 +3535,15 @@
                 <a:ea typeface="Georgia" pitchFamily="34" charset="-122"/>
                 <a:cs typeface="Georgia" pitchFamily="34" charset="-120"/>
               </a:rPr>
-              <a:t>Not a count after the match: a live ledger where every second has a frame, a confidence and a cost.</a:t>
-            </a:r>
-            <a:endParaRPr lang="en-US" sz="1000" dirty="0"/>
-          </a:p>
-        </p:txBody>
-      </p:sp>
-      <p:sp>
-        <p:nvSpPr>
-          <p:cNvPr id="72" name="Text 70"/>
+              <a:t>Live on Aiven Runtime. Not a count after the match: proof for every second.</a:t>
+            </a:r>
+            <a:endParaRPr lang="en-US" sz="900" dirty="0"/>
+          </a:p>
+        </p:txBody>
+      </p:sp>
+      <p:sp>
+        <p:nvSpPr>
+          <p:cNvPr id="77" name="Text 75"/>
           <p:cNvSpPr txBox="1"/>
           <p:nvPr/>
         </p:nvSpPr>
@@ -3395,7 +3574,7 @@
                 <a:ea typeface="Arial" pitchFamily="34" charset="-122"/>
                 <a:cs typeface="Arial" pitchFamily="34" charset="-120"/>
               </a:rPr>
-              <a:t>*Pilot on our earlier prototype, partly circular; independent labelling next. Evidence: recorded broadcast replayed through the live pipeline on Aiven Runtime. Repo: github.com/kaktamsdengami/accel_hack-</a:t>
+              <a:t>*Pilot on our earlier prototype, partly circular; independent labelling next. Evidence: recorded broadcast replayed through the live pipeline. Repo: github.com/kaktamsdengami/accel_hack-</a:t>
             </a:r>
             <a:endParaRPr lang="en-US" sz="800" dirty="0"/>
           </a:p>
@@ -3403,7 +3582,7 @@
       </p:sp>
       <p:sp>
         <p:nvSpPr>
-          <p:cNvPr id="73" name="Text 71">
+          <p:cNvPr id="78" name="Text 76">
             <a:hlinkClick r:id="rId1" tooltip=""/>
           </p:cNvPr>
           <p:cNvSpPr txBox="1"/>
@@ -3411,8 +3590,8 @@
         </p:nvSpPr>
         <p:spPr>
           <a:xfrm>
-            <a:off x="9509760" y="6144768"/>
-            <a:ext cx="2130552" cy="274320"/>
+            <a:off x="9966960" y="6144768"/>
+            <a:ext cx="1673352" cy="274320"/>
           </a:xfrm>
           <a:prstGeom prst="rect">
             <a:avLst/>

</xml_diff>